<commit_message>
Replace demo slide with full-resolution UI screenshot
</commit_message>
<xml_diff>
--- a/submission/SRM_Team_Ctrl_Alt_Elite_1_Submission.pptx
+++ b/submission/SRM_Team_Ctrl_Alt_Elite_1_Submission.pptx
@@ -2,24 +2,24 @@
 <file path=ppt/presentation.xml><?xml version="1.0" encoding="utf-8"?>
 <p:presentation xmlns:p="http://schemas.openxmlformats.org/presentationml/2006/main">
   <p:sldMasterIdLst>
-    <p:sldMasterId xmlns:r="http://schemas.openxmlformats.org/officeDocument/2006/relationships" id="2147483648" r:id="R74af69056e374227"/>
+    <p:sldMasterId xmlns:r="http://schemas.openxmlformats.org/officeDocument/2006/relationships" id="2147483648" r:id="R6bfee2f295704558"/>
   </p:sldMasterIdLst>
   <p:notesMasterIdLst>
-    <p:notesMasterId xmlns:r="http://schemas.openxmlformats.org/officeDocument/2006/relationships" r:id="Rc7aa85ff024a4c49"/>
+    <p:notesMasterId xmlns:r="http://schemas.openxmlformats.org/officeDocument/2006/relationships" r:id="R0031f81d85294ccc"/>
   </p:notesMasterIdLst>
   <p:sldIdLst>
-    <p:sldId xmlns:r="http://schemas.openxmlformats.org/officeDocument/2006/relationships" id="256" r:id="Rfd3197d34a79489b"/>
-    <p:sldId xmlns:r="http://schemas.openxmlformats.org/officeDocument/2006/relationships" id="257" r:id="R2c468d5e9db54984"/>
-    <p:sldId xmlns:r="http://schemas.openxmlformats.org/officeDocument/2006/relationships" id="258" r:id="R9ae14a4d0af043c3"/>
-    <p:sldId xmlns:r="http://schemas.openxmlformats.org/officeDocument/2006/relationships" id="259" r:id="R32f0db812a18468a"/>
-    <p:sldId xmlns:r="http://schemas.openxmlformats.org/officeDocument/2006/relationships" id="260" r:id="R33d71c9891544154"/>
-    <p:sldId xmlns:r="http://schemas.openxmlformats.org/officeDocument/2006/relationships" id="261" r:id="R1322275cae3142b7"/>
-    <p:sldId xmlns:r="http://schemas.openxmlformats.org/officeDocument/2006/relationships" id="262" r:id="Rf66714ae924f4138"/>
-    <p:sldId xmlns:r="http://schemas.openxmlformats.org/officeDocument/2006/relationships" id="263" r:id="Rb33a5325480a4b84"/>
-    <p:sldId xmlns:r="http://schemas.openxmlformats.org/officeDocument/2006/relationships" id="264" r:id="Re5ba04c12f514c22"/>
-    <p:sldId xmlns:r="http://schemas.openxmlformats.org/officeDocument/2006/relationships" id="265" r:id="Rda3d1e595d2c4b82"/>
-    <p:sldId xmlns:r="http://schemas.openxmlformats.org/officeDocument/2006/relationships" id="266" r:id="R5f88f31eb66f425e"/>
-    <p:sldId xmlns:r="http://schemas.openxmlformats.org/officeDocument/2006/relationships" id="267" r:id="R5d9c8c1a447e40f2"/>
+    <p:sldId xmlns:r="http://schemas.openxmlformats.org/officeDocument/2006/relationships" id="256" r:id="R15c9bd34f12d463c"/>
+    <p:sldId xmlns:r="http://schemas.openxmlformats.org/officeDocument/2006/relationships" id="257" r:id="R436a12759fd6437a"/>
+    <p:sldId xmlns:r="http://schemas.openxmlformats.org/officeDocument/2006/relationships" id="258" r:id="R6b829dc952dd4630"/>
+    <p:sldId xmlns:r="http://schemas.openxmlformats.org/officeDocument/2006/relationships" id="259" r:id="Rebeff2e04e5d482d"/>
+    <p:sldId xmlns:r="http://schemas.openxmlformats.org/officeDocument/2006/relationships" id="260" r:id="R66ef8402df6a4411"/>
+    <p:sldId xmlns:r="http://schemas.openxmlformats.org/officeDocument/2006/relationships" id="261" r:id="Rbb02419e3b824b81"/>
+    <p:sldId xmlns:r="http://schemas.openxmlformats.org/officeDocument/2006/relationships" id="262" r:id="R544e5ca0155640db"/>
+    <p:sldId xmlns:r="http://schemas.openxmlformats.org/officeDocument/2006/relationships" id="263" r:id="R0cbb73b2201e4cd2"/>
+    <p:sldId xmlns:r="http://schemas.openxmlformats.org/officeDocument/2006/relationships" id="264" r:id="R108bd0c18a834e1c"/>
+    <p:sldId xmlns:r="http://schemas.openxmlformats.org/officeDocument/2006/relationships" id="265" r:id="R2111477f6d504957"/>
+    <p:sldId xmlns:r="http://schemas.openxmlformats.org/officeDocument/2006/relationships" id="266" r:id="R58e7f268e5564d72"/>
+    <p:sldId xmlns:r="http://schemas.openxmlformats.org/officeDocument/2006/relationships" id="267" r:id="R2d6fbab0d7ef482b"/>
   </p:sldIdLst>
   <p:sldSz cx="12192000" cy="6858000"/>
   <p:notesSz cx="6858000" cy="9144000"/>
@@ -978,7 +978,7 @@
           <a:lstStyle xmlns:a="http://schemas.openxmlformats.org/drawingml/2006/main"/>
           <a:p xmlns:a="http://schemas.openxmlformats.org/drawingml/2006/main">
             <a:r>
-              <a:t>Video URL: https://drive.google.com/file/d/1Y7nbuiszgRgTFUJU7GKSjsI3tVVWGHv8/view?usp=sharing . Duration 3:30 reported by team lead. Drive landing page loads anonymously; full playback not independently reviewed. UI image extracted from supplied v4 PDF. Manual query in proposed script: which files import collections? Version history is a controlled fixture.</a:t>
+              <a:t>Video URL: https://drive.google.com/file/d/1Y7nbuiszgRgTFUJU7GKSjsI3tVVWGHv8/view?usp=sharing . Duration 3:30 reported by team lead. Drive landing page loads anonymously; full playback not independently reviewed. UI screenshot supplied directly by the team lead at full resolution. Manual query in proposed script: which files import collections? Version history is a controlled fixture.</a:t>
             </a:r>
           </a:p>
           <a:p xmlns:a="http://schemas.openxmlformats.org/drawingml/2006/main">
@@ -1351,7 +1351,7 @@
   </p:cSld>
   <p:clrMap bg1="lt1" tx1="dk1" bg2="lt2" tx2="dk2" accent1="accent1" accent2="accent2" accent3="accent3" accent4="accent4" accent5="accent5" accent6="accent6" hlink="hlink" folHlink="folHlink"/>
   <p:sldLayoutIdLst>
-    <p:sldLayoutId xmlns:r="http://schemas.openxmlformats.org/officeDocument/2006/relationships" id="2147483649" r:id="R170b5cfe8a0347c7"/>
+    <p:sldLayoutId xmlns:r="http://schemas.openxmlformats.org/officeDocument/2006/relationships" id="2147483649" r:id="R44ba65dfb7b34c5c"/>
   </p:sldLayoutIdLst>
   <p:txStyles>
     <p:titleStyle>
@@ -1902,7 +1902,7 @@
           <p:cNvPr id="11" name="">
             <a:extLst xmlns:a="http://schemas.openxmlformats.org/drawingml/2006/main">
               <a:ext uri="{FF2B5EF4-FFF2-40B4-BE49-F238E27FC236}">
-                <a16:creationId xmlns:a16="http://schemas.microsoft.com/office/drawing/2014/main" id="{181FCDF6-1B1F-4864-BADD-AF96326AE2B5}"/>
+                <a16:creationId xmlns:a16="http://schemas.microsoft.com/office/drawing/2014/main" id="{FE43FD59-8DE2-41C3-B3D7-1E047C16BFAD}"/>
               </a:ext>
             </a:extLst>
           </p:cNvPr>
@@ -1959,7 +1959,7 @@
           <p:cNvPr id="2" name="">
             <a:extLst xmlns:a="http://schemas.openxmlformats.org/drawingml/2006/main">
               <a:ext uri="{FF2B5EF4-FFF2-40B4-BE49-F238E27FC236}">
-                <a16:creationId xmlns:a16="http://schemas.microsoft.com/office/drawing/2014/main" id="{431E6632-D02A-46D5-A0E8-76C95BF508CF}"/>
+                <a16:creationId xmlns:a16="http://schemas.microsoft.com/office/drawing/2014/main" id="{3A27B746-2352-4DF6-A407-380840DA4E84}"/>
               </a:ext>
             </a:extLst>
           </p:cNvPr>
@@ -2016,7 +2016,7 @@
           <p:cNvPr id="3" name="">
             <a:extLst xmlns:a="http://schemas.openxmlformats.org/drawingml/2006/main">
               <a:ext uri="{FF2B5EF4-FFF2-40B4-BE49-F238E27FC236}">
-                <a16:creationId xmlns:a16="http://schemas.microsoft.com/office/drawing/2014/main" id="{961CB6E9-D299-48B4-B182-47D1C3DCD3EF}"/>
+                <a16:creationId xmlns:a16="http://schemas.microsoft.com/office/drawing/2014/main" id="{BB4F140E-7632-4E9A-A7CD-7855B8574380}"/>
               </a:ext>
             </a:extLst>
           </p:cNvPr>
@@ -2073,7 +2073,7 @@
           <p:cNvPr id="4" name="">
             <a:extLst xmlns:a="http://schemas.openxmlformats.org/drawingml/2006/main">
               <a:ext uri="{FF2B5EF4-FFF2-40B4-BE49-F238E27FC236}">
-                <a16:creationId xmlns:a16="http://schemas.microsoft.com/office/drawing/2014/main" id="{9AE4580D-2E8C-4992-8D85-50B252F0067E}"/>
+                <a16:creationId xmlns:a16="http://schemas.microsoft.com/office/drawing/2014/main" id="{4E222D60-5DF8-48B3-9867-20D794ED4C9D}"/>
               </a:ext>
             </a:extLst>
           </p:cNvPr>
@@ -2130,7 +2130,7 @@
           <p:cNvPr id="5" name="">
             <a:extLst xmlns:a="http://schemas.openxmlformats.org/drawingml/2006/main">
               <a:ext uri="{FF2B5EF4-FFF2-40B4-BE49-F238E27FC236}">
-                <a16:creationId xmlns:a16="http://schemas.microsoft.com/office/drawing/2014/main" id="{0E9A38BA-8C13-4A5D-8511-3E141A9F709A}"/>
+                <a16:creationId xmlns:a16="http://schemas.microsoft.com/office/drawing/2014/main" id="{FEDE58D2-CD5F-4553-B480-FF76A350FDFD}"/>
               </a:ext>
             </a:extLst>
           </p:cNvPr>
@@ -2187,7 +2187,7 @@
           <p:cNvPr id="6" name="">
             <a:extLst xmlns:a="http://schemas.openxmlformats.org/drawingml/2006/main">
               <a:ext uri="{FF2B5EF4-FFF2-40B4-BE49-F238E27FC236}">
-                <a16:creationId xmlns:a16="http://schemas.microsoft.com/office/drawing/2014/main" id="{89BEC9FA-3A10-4ECB-A224-4F2405F271BF}"/>
+                <a16:creationId xmlns:a16="http://schemas.microsoft.com/office/drawing/2014/main" id="{2A8B5EDA-7F1D-4CF5-B56E-5D3770C5B649}"/>
               </a:ext>
             </a:extLst>
           </p:cNvPr>
@@ -2244,7 +2244,7 @@
           <p:cNvPr id="7" name="">
             <a:extLst xmlns:a="http://schemas.openxmlformats.org/drawingml/2006/main">
               <a:ext uri="{FF2B5EF4-FFF2-40B4-BE49-F238E27FC236}">
-                <a16:creationId xmlns:a16="http://schemas.microsoft.com/office/drawing/2014/main" id="{9EFFE3B4-92F2-4288-9209-398B61261A9D}"/>
+                <a16:creationId xmlns:a16="http://schemas.microsoft.com/office/drawing/2014/main" id="{792755A9-3FD3-44A0-B5AF-3BB475D35F5C}"/>
               </a:ext>
             </a:extLst>
           </p:cNvPr>
@@ -2301,7 +2301,7 @@
           <p:cNvPr id="8" name="">
             <a:extLst xmlns:a="http://schemas.openxmlformats.org/drawingml/2006/main">
               <a:ext uri="{FF2B5EF4-FFF2-40B4-BE49-F238E27FC236}">
-                <a16:creationId xmlns:a16="http://schemas.microsoft.com/office/drawing/2014/main" id="{73C260A6-FEEC-4076-AEAD-7065577B1266}"/>
+                <a16:creationId xmlns:a16="http://schemas.microsoft.com/office/drawing/2014/main" id="{3783EB64-6557-4F39-B477-9FCB07BE799B}"/>
               </a:ext>
             </a:extLst>
           </p:cNvPr>
@@ -2431,7 +2431,7 @@
           <p:nvPr/>
         </p:nvPicPr>
         <p:blipFill>
-          <a:blip xmlns:r="http://schemas.openxmlformats.org/officeDocument/2006/relationships" xmlns:a="http://schemas.openxmlformats.org/drawingml/2006/main" r:embed="R5deb84a1e4094311"/>
+          <a:blip xmlns:r="http://schemas.openxmlformats.org/officeDocument/2006/relationships" xmlns:a="http://schemas.openxmlformats.org/drawingml/2006/main" r:embed="Rf2d1595acdd9483b"/>
           <a:stretch xmlns:a="http://schemas.openxmlformats.org/drawingml/2006/main"/>
         </p:blipFill>
         <p:spPr>
@@ -2449,7 +2449,7 @@
           <p:cNvPr id="10" name="">
             <a:extLst xmlns:a="http://schemas.openxmlformats.org/drawingml/2006/main">
               <a:ext uri="{FF2B5EF4-FFF2-40B4-BE49-F238E27FC236}">
-                <a16:creationId xmlns:a16="http://schemas.microsoft.com/office/drawing/2014/main" id="{F514790D-9AAF-461E-AA9D-587034AB7DAC}"/>
+                <a16:creationId xmlns:a16="http://schemas.microsoft.com/office/drawing/2014/main" id="{B6A8E06B-5755-4C80-A0CF-46F26406A94A}"/>
               </a:ext>
             </a:extLst>
           </p:cNvPr>
@@ -2495,7 +2495,7 @@
                 <a:latin typeface="Arial"/>
                 <a:ea typeface="Arial"/>
                 <a:cs typeface="Arial"/>
-                <a:hlinkClick xmlns:r="http://schemas.openxmlformats.org/officeDocument/2006/relationships" r:id="Rd955d9e1a60247c6"/>
+                <a:hlinkClick xmlns:r="http://schemas.openxmlformats.org/officeDocument/2006/relationships" r:id="R19582bebfc804d67"/>
               </a:rPr>
               <a:t>Public GitHub repository</a:t>
             </a:r>
@@ -2505,7 +2505,7 @@
     </p:spTree>
     <p:extLst>
       <p:ext uri="{BB962C8B-B14F-4D97-AF65-F5344CB8AC3E}">
-        <p14:creationId xmlns:p14="http://schemas.microsoft.com/office/powerpoint/2010/main" val="1531421568"/>
+        <p14:creationId xmlns:p14="http://schemas.microsoft.com/office/powerpoint/2010/main" val="1234725392"/>
       </p:ext>
     </p:extLst>
   </p:cSld>
@@ -2536,7 +2536,7 @@
           <p:cNvPr id="14" name="">
             <a:extLst xmlns:a="http://schemas.openxmlformats.org/drawingml/2006/main">
               <a:ext uri="{FF2B5EF4-FFF2-40B4-BE49-F238E27FC236}">
-                <a16:creationId xmlns:a16="http://schemas.microsoft.com/office/drawing/2014/main" id="{86666603-C824-451E-AFE4-4EF716D3DD64}"/>
+                <a16:creationId xmlns:a16="http://schemas.microsoft.com/office/drawing/2014/main" id="{D485B091-040D-4254-95D9-7E5637944F62}"/>
               </a:ext>
             </a:extLst>
           </p:cNvPr>
@@ -2593,7 +2593,7 @@
           <p:cNvPr id="2" name="">
             <a:extLst xmlns:a="http://schemas.openxmlformats.org/drawingml/2006/main">
               <a:ext uri="{FF2B5EF4-FFF2-40B4-BE49-F238E27FC236}">
-                <a16:creationId xmlns:a16="http://schemas.microsoft.com/office/drawing/2014/main" id="{809FD191-13A4-435E-AE20-523EC9A7B154}"/>
+                <a16:creationId xmlns:a16="http://schemas.microsoft.com/office/drawing/2014/main" id="{ADE90514-4CE3-493A-A108-758D7C2CFC45}"/>
               </a:ext>
             </a:extLst>
           </p:cNvPr>
@@ -2650,7 +2650,7 @@
           <p:cNvPr id="3" name="">
             <a:extLst xmlns:a="http://schemas.openxmlformats.org/drawingml/2006/main">
               <a:ext uri="{FF2B5EF4-FFF2-40B4-BE49-F238E27FC236}">
-                <a16:creationId xmlns:a16="http://schemas.microsoft.com/office/drawing/2014/main" id="{67B143FC-32E8-4EB5-AAE0-E7DE49F5D7E3}"/>
+                <a16:creationId xmlns:a16="http://schemas.microsoft.com/office/drawing/2014/main" id="{2E5127D4-4F7D-4263-A132-EBA73D219418}"/>
               </a:ext>
             </a:extLst>
           </p:cNvPr>
@@ -2707,7 +2707,7 @@
           <p:cNvPr id="4" name="">
             <a:extLst xmlns:a="http://schemas.openxmlformats.org/drawingml/2006/main">
               <a:ext uri="{FF2B5EF4-FFF2-40B4-BE49-F238E27FC236}">
-                <a16:creationId xmlns:a16="http://schemas.microsoft.com/office/drawing/2014/main" id="{3AEE3438-B040-46B7-B272-7354E966A745}"/>
+                <a16:creationId xmlns:a16="http://schemas.microsoft.com/office/drawing/2014/main" id="{2B25AEDD-1970-4143-9C13-E89222B6BDC2}"/>
               </a:ext>
             </a:extLst>
           </p:cNvPr>
@@ -2737,7 +2737,7 @@
           <p:cNvPr id="5" name="">
             <a:extLst xmlns:a="http://schemas.openxmlformats.org/drawingml/2006/main">
               <a:ext uri="{FF2B5EF4-FFF2-40B4-BE49-F238E27FC236}">
-                <a16:creationId xmlns:a16="http://schemas.microsoft.com/office/drawing/2014/main" id="{6DDDE0AF-E941-4AC9-8767-A3398F4F684A}"/>
+                <a16:creationId xmlns:a16="http://schemas.microsoft.com/office/drawing/2014/main" id="{15908D04-A1E5-4F32-B425-ABBE10C8F52F}"/>
               </a:ext>
             </a:extLst>
           </p:cNvPr>
@@ -2794,7 +2794,7 @@
           <p:cNvPr id="6" name="">
             <a:extLst xmlns:a="http://schemas.openxmlformats.org/drawingml/2006/main">
               <a:ext uri="{FF2B5EF4-FFF2-40B4-BE49-F238E27FC236}">
-                <a16:creationId xmlns:a16="http://schemas.microsoft.com/office/drawing/2014/main" id="{27E4B0F3-92AE-4383-876F-732FADC2546C}"/>
+                <a16:creationId xmlns:a16="http://schemas.microsoft.com/office/drawing/2014/main" id="{D9A80862-F1E4-40B6-913F-0CC03F3D9DCF}"/>
               </a:ext>
             </a:extLst>
           </p:cNvPr>
@@ -2851,7 +2851,7 @@
           <p:cNvPr id="7" name="">
             <a:extLst xmlns:a="http://schemas.openxmlformats.org/drawingml/2006/main">
               <a:ext uri="{FF2B5EF4-FFF2-40B4-BE49-F238E27FC236}">
-                <a16:creationId xmlns:a16="http://schemas.microsoft.com/office/drawing/2014/main" id="{99111D49-6F60-4E6D-AD9F-D0A2869B66D4}"/>
+                <a16:creationId xmlns:a16="http://schemas.microsoft.com/office/drawing/2014/main" id="{AF3C888E-680A-4B14-AC94-DE37F096C5CC}"/>
               </a:ext>
             </a:extLst>
           </p:cNvPr>
@@ -2881,7 +2881,7 @@
           <p:cNvPr id="8" name="">
             <a:extLst xmlns:a="http://schemas.openxmlformats.org/drawingml/2006/main">
               <a:ext uri="{FF2B5EF4-FFF2-40B4-BE49-F238E27FC236}">
-                <a16:creationId xmlns:a16="http://schemas.microsoft.com/office/drawing/2014/main" id="{EF08ED55-5923-4848-AED4-50EF51E69055}"/>
+                <a16:creationId xmlns:a16="http://schemas.microsoft.com/office/drawing/2014/main" id="{B02DD5C8-46C8-4936-9CC1-B6F340B1EE41}"/>
               </a:ext>
             </a:extLst>
           </p:cNvPr>
@@ -2938,7 +2938,7 @@
           <p:cNvPr id="9" name="">
             <a:extLst xmlns:a="http://schemas.openxmlformats.org/drawingml/2006/main">
               <a:ext uri="{FF2B5EF4-FFF2-40B4-BE49-F238E27FC236}">
-                <a16:creationId xmlns:a16="http://schemas.microsoft.com/office/drawing/2014/main" id="{3B8309FB-7171-4ECA-B795-D63BE76B0CE2}"/>
+                <a16:creationId xmlns:a16="http://schemas.microsoft.com/office/drawing/2014/main" id="{84405273-B045-4FF4-97A2-4B206CED7279}"/>
               </a:ext>
             </a:extLst>
           </p:cNvPr>
@@ -2995,7 +2995,7 @@
           <p:cNvPr id="10" name="">
             <a:extLst xmlns:a="http://schemas.openxmlformats.org/drawingml/2006/main">
               <a:ext uri="{FF2B5EF4-FFF2-40B4-BE49-F238E27FC236}">
-                <a16:creationId xmlns:a16="http://schemas.microsoft.com/office/drawing/2014/main" id="{865AF41C-EC56-41F1-B0E4-EAC28CEEA9D4}"/>
+                <a16:creationId xmlns:a16="http://schemas.microsoft.com/office/drawing/2014/main" id="{B78F5536-146B-448C-9DA5-4A74344F8E6D}"/>
               </a:ext>
             </a:extLst>
           </p:cNvPr>
@@ -3025,7 +3025,7 @@
           <p:cNvPr id="11" name="">
             <a:extLst xmlns:a="http://schemas.openxmlformats.org/drawingml/2006/main">
               <a:ext uri="{FF2B5EF4-FFF2-40B4-BE49-F238E27FC236}">
-                <a16:creationId xmlns:a16="http://schemas.microsoft.com/office/drawing/2014/main" id="{CB4E7992-51EB-4E62-8806-957AAB0FC70F}"/>
+                <a16:creationId xmlns:a16="http://schemas.microsoft.com/office/drawing/2014/main" id="{CEA7A931-785A-4D9C-8B2C-E344B704D1DB}"/>
               </a:ext>
             </a:extLst>
           </p:cNvPr>
@@ -3082,7 +3082,7 @@
           <p:cNvPr id="12" name="">
             <a:extLst xmlns:a="http://schemas.openxmlformats.org/drawingml/2006/main">
               <a:ext uri="{FF2B5EF4-FFF2-40B4-BE49-F238E27FC236}">
-                <a16:creationId xmlns:a16="http://schemas.microsoft.com/office/drawing/2014/main" id="{545777DE-757A-4DB8-AC45-91AFB0D3A024}"/>
+                <a16:creationId xmlns:a16="http://schemas.microsoft.com/office/drawing/2014/main" id="{1CA34741-5CCA-4375-88EC-A8D1110B985A}"/>
               </a:ext>
             </a:extLst>
           </p:cNvPr>
@@ -3139,7 +3139,7 @@
           <p:cNvPr id="13" name="">
             <a:extLst xmlns:a="http://schemas.openxmlformats.org/drawingml/2006/main">
               <a:ext uri="{FF2B5EF4-FFF2-40B4-BE49-F238E27FC236}">
-                <a16:creationId xmlns:a16="http://schemas.microsoft.com/office/drawing/2014/main" id="{BA24EF0F-345B-4F45-9284-C8CF4B65ABA0}"/>
+                <a16:creationId xmlns:a16="http://schemas.microsoft.com/office/drawing/2014/main" id="{D2CC3660-A27D-4C14-BB00-ECA22F043DA5}"/>
               </a:ext>
             </a:extLst>
           </p:cNvPr>
@@ -3167,7 +3167,7 @@
     </p:spTree>
     <p:extLst>
       <p:ext uri="{BB962C8B-B14F-4D97-AF65-F5344CB8AC3E}">
-        <p14:creationId xmlns:p14="http://schemas.microsoft.com/office/powerpoint/2010/main" val="1345407943"/>
+        <p14:creationId xmlns:p14="http://schemas.microsoft.com/office/powerpoint/2010/main" val="337726152"/>
       </p:ext>
     </p:extLst>
   </p:cSld>
@@ -3198,7 +3198,7 @@
           <p:cNvPr id="5" name="">
             <a:extLst xmlns:a="http://schemas.openxmlformats.org/drawingml/2006/main">
               <a:ext uri="{FF2B5EF4-FFF2-40B4-BE49-F238E27FC236}">
-                <a16:creationId xmlns:a16="http://schemas.microsoft.com/office/drawing/2014/main" id="{4C7023B3-9E2F-4E15-B256-8CA06D4D3843}"/>
+                <a16:creationId xmlns:a16="http://schemas.microsoft.com/office/drawing/2014/main" id="{91FBD584-4280-486E-9E05-DADC633014F1}"/>
               </a:ext>
             </a:extLst>
           </p:cNvPr>
@@ -3677,7 +3677,7 @@
           <p:cNvPr id="3" name="">
             <a:extLst xmlns:a="http://schemas.openxmlformats.org/drawingml/2006/main">
               <a:ext uri="{FF2B5EF4-FFF2-40B4-BE49-F238E27FC236}">
-                <a16:creationId xmlns:a16="http://schemas.microsoft.com/office/drawing/2014/main" id="{1FEAC847-2477-44B0-AA02-FA11D566D04C}"/>
+                <a16:creationId xmlns:a16="http://schemas.microsoft.com/office/drawing/2014/main" id="{512A2F70-2C17-4144-B730-32CEBA3A5D98}"/>
               </a:ext>
             </a:extLst>
           </p:cNvPr>
@@ -3734,7 +3734,7 @@
           <p:cNvPr id="4" name="">
             <a:extLst xmlns:a="http://schemas.openxmlformats.org/drawingml/2006/main">
               <a:ext uri="{FF2B5EF4-FFF2-40B4-BE49-F238E27FC236}">
-                <a16:creationId xmlns:a16="http://schemas.microsoft.com/office/drawing/2014/main" id="{BCAFB48F-E4FC-4F24-803D-6E001923DACF}"/>
+                <a16:creationId xmlns:a16="http://schemas.microsoft.com/office/drawing/2014/main" id="{27F76FB8-F238-4B31-A0C5-BE167073BCC3}"/>
               </a:ext>
             </a:extLst>
           </p:cNvPr>
@@ -3789,7 +3789,7 @@
     </p:spTree>
     <p:extLst>
       <p:ext uri="{BB962C8B-B14F-4D97-AF65-F5344CB8AC3E}">
-        <p14:creationId xmlns:p14="http://schemas.microsoft.com/office/powerpoint/2010/main" val="819466506"/>
+        <p14:creationId xmlns:p14="http://schemas.microsoft.com/office/powerpoint/2010/main" val="490486900"/>
       </p:ext>
     </p:extLst>
   </p:cSld>
@@ -3820,7 +3820,7 @@
           <p:cNvPr id="9" name="">
             <a:extLst xmlns:a="http://schemas.openxmlformats.org/drawingml/2006/main">
               <a:ext uri="{FF2B5EF4-FFF2-40B4-BE49-F238E27FC236}">
-                <a16:creationId xmlns:a16="http://schemas.microsoft.com/office/drawing/2014/main" id="{24760A3C-A25C-4455-B154-DDD3D989361E}"/>
+                <a16:creationId xmlns:a16="http://schemas.microsoft.com/office/drawing/2014/main" id="{5D52E3AD-F9CE-4F63-8515-0250E847AEED}"/>
               </a:ext>
             </a:extLst>
           </p:cNvPr>
@@ -3877,7 +3877,7 @@
           <p:cNvPr id="2" name="">
             <a:extLst xmlns:a="http://schemas.openxmlformats.org/drawingml/2006/main">
               <a:ext uri="{FF2B5EF4-FFF2-40B4-BE49-F238E27FC236}">
-                <a16:creationId xmlns:a16="http://schemas.microsoft.com/office/drawing/2014/main" id="{40C8720B-5EA8-4579-BC1C-E90CF9EF8833}"/>
+                <a16:creationId xmlns:a16="http://schemas.microsoft.com/office/drawing/2014/main" id="{A50938F7-AEB7-4183-B30D-9F1CE36A20F4}"/>
               </a:ext>
             </a:extLst>
           </p:cNvPr>
@@ -3934,7 +3934,7 @@
           <p:cNvPr id="3" name="">
             <a:extLst xmlns:a="http://schemas.openxmlformats.org/drawingml/2006/main">
               <a:ext uri="{FF2B5EF4-FFF2-40B4-BE49-F238E27FC236}">
-                <a16:creationId xmlns:a16="http://schemas.microsoft.com/office/drawing/2014/main" id="{A1DC2B3B-3BC4-443E-B650-B8BACD4462B2}"/>
+                <a16:creationId xmlns:a16="http://schemas.microsoft.com/office/drawing/2014/main" id="{3E7B0BC3-B2CC-4429-91BC-7D2B352EE893}"/>
               </a:ext>
             </a:extLst>
           </p:cNvPr>
@@ -3991,7 +3991,7 @@
           <p:cNvPr id="4" name="">
             <a:extLst xmlns:a="http://schemas.openxmlformats.org/drawingml/2006/main">
               <a:ext uri="{FF2B5EF4-FFF2-40B4-BE49-F238E27FC236}">
-                <a16:creationId xmlns:a16="http://schemas.microsoft.com/office/drawing/2014/main" id="{86926718-F0AB-4C63-8BD9-B32083723EDC}"/>
+                <a16:creationId xmlns:a16="http://schemas.microsoft.com/office/drawing/2014/main" id="{8FA1B834-D1F9-45D8-A412-6E975689E34D}"/>
               </a:ext>
             </a:extLst>
           </p:cNvPr>
@@ -4048,7 +4048,7 @@
           <p:cNvPr id="5" name="">
             <a:extLst xmlns:a="http://schemas.openxmlformats.org/drawingml/2006/main">
               <a:ext uri="{FF2B5EF4-FFF2-40B4-BE49-F238E27FC236}">
-                <a16:creationId xmlns:a16="http://schemas.microsoft.com/office/drawing/2014/main" id="{233A9F02-AC70-401A-BF62-AF27DBCF7D86}"/>
+                <a16:creationId xmlns:a16="http://schemas.microsoft.com/office/drawing/2014/main" id="{E1E50D17-1975-41C6-87CD-459353461A9D}"/>
               </a:ext>
             </a:extLst>
           </p:cNvPr>
@@ -4105,7 +4105,7 @@
           <p:cNvPr id="6" name="">
             <a:extLst xmlns:a="http://schemas.openxmlformats.org/drawingml/2006/main">
               <a:ext uri="{FF2B5EF4-FFF2-40B4-BE49-F238E27FC236}">
-                <a16:creationId xmlns:a16="http://schemas.microsoft.com/office/drawing/2014/main" id="{1A927D0D-0D98-436D-AB0F-D6B5C1791393}"/>
+                <a16:creationId xmlns:a16="http://schemas.microsoft.com/office/drawing/2014/main" id="{47FD719F-5851-49A3-A4BD-AD1152822FEB}"/>
               </a:ext>
             </a:extLst>
           </p:cNvPr>
@@ -4151,7 +4151,7 @@
                 <a:latin typeface="Arial"/>
                 <a:ea typeface="Arial"/>
                 <a:cs typeface="Arial"/>
-                <a:hlinkClick xmlns:r="http://schemas.openxmlformats.org/officeDocument/2006/relationships" r:id="Reb765a9e0f10431e"/>
+                <a:hlinkClick xmlns:r="http://schemas.openxmlformats.org/officeDocument/2006/relationships" r:id="R4a631a7d9fe54808"/>
               </a:rPr>
               <a:t>View the public GitHub repository</a:t>
             </a:r>
@@ -4163,7 +4163,7 @@
           <p:cNvPr id="7" name="">
             <a:extLst xmlns:a="http://schemas.openxmlformats.org/drawingml/2006/main">
               <a:ext uri="{FF2B5EF4-FFF2-40B4-BE49-F238E27FC236}">
-                <a16:creationId xmlns:a16="http://schemas.microsoft.com/office/drawing/2014/main" id="{D362B486-2AC9-4021-864B-60B5D17E270B}"/>
+                <a16:creationId xmlns:a16="http://schemas.microsoft.com/office/drawing/2014/main" id="{4B5949AD-CC03-41B0-AEFB-AE0CDD2A1F87}"/>
               </a:ext>
             </a:extLst>
           </p:cNvPr>
@@ -4209,7 +4209,7 @@
                 <a:latin typeface="Arial"/>
                 <a:ea typeface="Arial"/>
                 <a:cs typeface="Arial"/>
-                <a:hlinkClick xmlns:r="http://schemas.openxmlformats.org/officeDocument/2006/relationships" r:id="R2b0bd60864f740a3"/>
+                <a:hlinkClick xmlns:r="http://schemas.openxmlformats.org/officeDocument/2006/relationships" r:id="Rcb83ac9c518e4eda"/>
               </a:rPr>
               <a:t>Watch our 3:30 demo</a:t>
             </a:r>
@@ -4221,7 +4221,7 @@
           <p:cNvPr id="8" name="">
             <a:extLst xmlns:a="http://schemas.openxmlformats.org/drawingml/2006/main">
               <a:ext uri="{FF2B5EF4-FFF2-40B4-BE49-F238E27FC236}">
-                <a16:creationId xmlns:a16="http://schemas.microsoft.com/office/drawing/2014/main" id="{E97920E7-469E-4075-A3B8-9BC15160631C}"/>
+                <a16:creationId xmlns:a16="http://schemas.microsoft.com/office/drawing/2014/main" id="{7039B08D-3508-4E92-B4EE-E630C4D73367}"/>
               </a:ext>
             </a:extLst>
           </p:cNvPr>
@@ -4276,7 +4276,7 @@
     </p:spTree>
     <p:extLst>
       <p:ext uri="{BB962C8B-B14F-4D97-AF65-F5344CB8AC3E}">
-        <p14:creationId xmlns:p14="http://schemas.microsoft.com/office/powerpoint/2010/main" val="1273320021"/>
+        <p14:creationId xmlns:p14="http://schemas.microsoft.com/office/powerpoint/2010/main" val="195912709"/>
       </p:ext>
     </p:extLst>
   </p:cSld>
@@ -4307,7 +4307,7 @@
           <p:cNvPr id="14" name="">
             <a:extLst xmlns:a="http://schemas.openxmlformats.org/drawingml/2006/main">
               <a:ext uri="{FF2B5EF4-FFF2-40B4-BE49-F238E27FC236}">
-                <a16:creationId xmlns:a16="http://schemas.microsoft.com/office/drawing/2014/main" id="{8574184E-958E-47D2-998C-7B5EE8DCEB7B}"/>
+                <a16:creationId xmlns:a16="http://schemas.microsoft.com/office/drawing/2014/main" id="{43E22B65-ADAF-40EC-BF08-E1099C7C9E63}"/>
               </a:ext>
             </a:extLst>
           </p:cNvPr>
@@ -4364,7 +4364,7 @@
           <p:cNvPr id="2" name="">
             <a:extLst xmlns:a="http://schemas.openxmlformats.org/drawingml/2006/main">
               <a:ext uri="{FF2B5EF4-FFF2-40B4-BE49-F238E27FC236}">
-                <a16:creationId xmlns:a16="http://schemas.microsoft.com/office/drawing/2014/main" id="{DFB887EF-FC7D-4758-A557-9CA1CCEB2593}"/>
+                <a16:creationId xmlns:a16="http://schemas.microsoft.com/office/drawing/2014/main" id="{F6CBD482-8B64-4712-B442-C295D84BE42F}"/>
               </a:ext>
             </a:extLst>
           </p:cNvPr>
@@ -4421,7 +4421,7 @@
           <p:cNvPr id="3" name="">
             <a:extLst xmlns:a="http://schemas.openxmlformats.org/drawingml/2006/main">
               <a:ext uri="{FF2B5EF4-FFF2-40B4-BE49-F238E27FC236}">
-                <a16:creationId xmlns:a16="http://schemas.microsoft.com/office/drawing/2014/main" id="{A725A44B-5863-4D09-8A0D-E3DFFD262ED5}"/>
+                <a16:creationId xmlns:a16="http://schemas.microsoft.com/office/drawing/2014/main" id="{EC48B093-5212-4C2C-BFE8-6BFC3B26AC29}"/>
               </a:ext>
             </a:extLst>
           </p:cNvPr>
@@ -4478,7 +4478,7 @@
           <p:cNvPr id="4" name="">
             <a:extLst xmlns:a="http://schemas.openxmlformats.org/drawingml/2006/main">
               <a:ext uri="{FF2B5EF4-FFF2-40B4-BE49-F238E27FC236}">
-                <a16:creationId xmlns:a16="http://schemas.microsoft.com/office/drawing/2014/main" id="{CBE2C689-778B-4DC3-ACDA-FDAAB3ABDEF4}"/>
+                <a16:creationId xmlns:a16="http://schemas.microsoft.com/office/drawing/2014/main" id="{EE1B8DDD-B0D9-480A-AEE9-625960880658}"/>
               </a:ext>
             </a:extLst>
           </p:cNvPr>
@@ -4535,7 +4535,7 @@
           <p:cNvPr id="5" name="">
             <a:extLst xmlns:a="http://schemas.openxmlformats.org/drawingml/2006/main">
               <a:ext uri="{FF2B5EF4-FFF2-40B4-BE49-F238E27FC236}">
-                <a16:creationId xmlns:a16="http://schemas.microsoft.com/office/drawing/2014/main" id="{72184221-AC9D-431C-9606-51C2752688E8}"/>
+                <a16:creationId xmlns:a16="http://schemas.microsoft.com/office/drawing/2014/main" id="{A7E8BA1D-32D6-452F-AE26-C157012521F1}"/>
               </a:ext>
             </a:extLst>
           </p:cNvPr>
@@ -4592,7 +4592,7 @@
           <p:cNvPr id="6" name="">
             <a:extLst xmlns:a="http://schemas.openxmlformats.org/drawingml/2006/main">
               <a:ext uri="{FF2B5EF4-FFF2-40B4-BE49-F238E27FC236}">
-                <a16:creationId xmlns:a16="http://schemas.microsoft.com/office/drawing/2014/main" id="{0873079E-E4AC-4BAB-855B-0BB3C9EF13ED}"/>
+                <a16:creationId xmlns:a16="http://schemas.microsoft.com/office/drawing/2014/main" id="{7BAE254F-7893-41D6-B4B1-74E127DE523E}"/>
               </a:ext>
             </a:extLst>
           </p:cNvPr>
@@ -4622,7 +4622,7 @@
           <p:cNvPr id="7" name="">
             <a:extLst xmlns:a="http://schemas.openxmlformats.org/drawingml/2006/main">
               <a:ext uri="{FF2B5EF4-FFF2-40B4-BE49-F238E27FC236}">
-                <a16:creationId xmlns:a16="http://schemas.microsoft.com/office/drawing/2014/main" id="{E1FDC1F3-99C7-422B-913D-A6EE38FB2165}"/>
+                <a16:creationId xmlns:a16="http://schemas.microsoft.com/office/drawing/2014/main" id="{D8CAD147-FABB-4D33-8111-A70D2A811594}"/>
               </a:ext>
             </a:extLst>
           </p:cNvPr>
@@ -4679,7 +4679,7 @@
           <p:cNvPr id="8" name="">
             <a:extLst xmlns:a="http://schemas.openxmlformats.org/drawingml/2006/main">
               <a:ext uri="{FF2B5EF4-FFF2-40B4-BE49-F238E27FC236}">
-                <a16:creationId xmlns:a16="http://schemas.microsoft.com/office/drawing/2014/main" id="{755B60E3-9C0C-47F2-A427-4C1002034A42}"/>
+                <a16:creationId xmlns:a16="http://schemas.microsoft.com/office/drawing/2014/main" id="{99A5BEA2-4FF6-4748-B928-A9B8E8F5D3C1}"/>
               </a:ext>
             </a:extLst>
           </p:cNvPr>
@@ -4736,7 +4736,7 @@
           <p:cNvPr id="9" name="">
             <a:extLst xmlns:a="http://schemas.openxmlformats.org/drawingml/2006/main">
               <a:ext uri="{FF2B5EF4-FFF2-40B4-BE49-F238E27FC236}">
-                <a16:creationId xmlns:a16="http://schemas.microsoft.com/office/drawing/2014/main" id="{F709BCE7-4DE7-4D66-A496-284CC3E846AC}"/>
+                <a16:creationId xmlns:a16="http://schemas.microsoft.com/office/drawing/2014/main" id="{72356E35-0404-4003-945F-370CBBB7E1EF}"/>
               </a:ext>
             </a:extLst>
           </p:cNvPr>
@@ -4766,7 +4766,7 @@
           <p:cNvPr id="10" name="">
             <a:extLst xmlns:a="http://schemas.openxmlformats.org/drawingml/2006/main">
               <a:ext uri="{FF2B5EF4-FFF2-40B4-BE49-F238E27FC236}">
-                <a16:creationId xmlns:a16="http://schemas.microsoft.com/office/drawing/2014/main" id="{C2194D8E-9102-4C01-B8CF-800C77110E9F}"/>
+                <a16:creationId xmlns:a16="http://schemas.microsoft.com/office/drawing/2014/main" id="{438CA6FB-E64B-46E6-A1ED-92B6FC49AB63}"/>
               </a:ext>
             </a:extLst>
           </p:cNvPr>
@@ -4823,7 +4823,7 @@
           <p:cNvPr id="11" name="">
             <a:extLst xmlns:a="http://schemas.openxmlformats.org/drawingml/2006/main">
               <a:ext uri="{FF2B5EF4-FFF2-40B4-BE49-F238E27FC236}">
-                <a16:creationId xmlns:a16="http://schemas.microsoft.com/office/drawing/2014/main" id="{7B5DB6E1-DFFB-45A3-A039-84F7E23D66C6}"/>
+                <a16:creationId xmlns:a16="http://schemas.microsoft.com/office/drawing/2014/main" id="{5C1C51A1-A6DE-4D62-8B4A-8A2DEDF48078}"/>
               </a:ext>
             </a:extLst>
           </p:cNvPr>
@@ -4880,7 +4880,7 @@
           <p:cNvPr id="12" name="">
             <a:extLst xmlns:a="http://schemas.openxmlformats.org/drawingml/2006/main">
               <a:ext uri="{FF2B5EF4-FFF2-40B4-BE49-F238E27FC236}">
-                <a16:creationId xmlns:a16="http://schemas.microsoft.com/office/drawing/2014/main" id="{719EB22F-92AF-4FDA-8096-47E85FDF9D52}"/>
+                <a16:creationId xmlns:a16="http://schemas.microsoft.com/office/drawing/2014/main" id="{72605C95-5755-42C1-AA7E-68115B49FD53}"/>
               </a:ext>
             </a:extLst>
           </p:cNvPr>
@@ -4910,7 +4910,7 @@
           <p:cNvPr id="13" name="">
             <a:extLst xmlns:a="http://schemas.openxmlformats.org/drawingml/2006/main">
               <a:ext uri="{FF2B5EF4-FFF2-40B4-BE49-F238E27FC236}">
-                <a16:creationId xmlns:a16="http://schemas.microsoft.com/office/drawing/2014/main" id="{7C30A4E8-9CE8-45FC-88E5-3E70C0BC6277}"/>
+                <a16:creationId xmlns:a16="http://schemas.microsoft.com/office/drawing/2014/main" id="{175A3F2F-E16C-4585-9FE6-B776A2E4AFFF}"/>
               </a:ext>
             </a:extLst>
           </p:cNvPr>
@@ -4965,7 +4965,7 @@
     </p:spTree>
     <p:extLst>
       <p:ext uri="{BB962C8B-B14F-4D97-AF65-F5344CB8AC3E}">
-        <p14:creationId xmlns:p14="http://schemas.microsoft.com/office/powerpoint/2010/main" val="92445285"/>
+        <p14:creationId xmlns:p14="http://schemas.microsoft.com/office/powerpoint/2010/main" val="1805950204"/>
       </p:ext>
     </p:extLst>
   </p:cSld>
@@ -4996,7 +4996,7 @@
           <p:cNvPr id="5" name="">
             <a:extLst xmlns:a="http://schemas.openxmlformats.org/drawingml/2006/main">
               <a:ext uri="{FF2B5EF4-FFF2-40B4-BE49-F238E27FC236}">
-                <a16:creationId xmlns:a16="http://schemas.microsoft.com/office/drawing/2014/main" id="{A1D94BC4-2F98-4ED3-980C-453DC163DF4F}"/>
+                <a16:creationId xmlns:a16="http://schemas.microsoft.com/office/drawing/2014/main" id="{87983907-C198-4E49-B8EB-553F5FB0B90F}"/>
               </a:ext>
             </a:extLst>
           </p:cNvPr>
@@ -5372,7 +5372,7 @@
           <p:cNvPr id="3" name="">
             <a:extLst xmlns:a="http://schemas.openxmlformats.org/drawingml/2006/main">
               <a:ext uri="{FF2B5EF4-FFF2-40B4-BE49-F238E27FC236}">
-                <a16:creationId xmlns:a16="http://schemas.microsoft.com/office/drawing/2014/main" id="{7A3D4EF6-4AEE-42DF-9C8E-38197FFDDE85}"/>
+                <a16:creationId xmlns:a16="http://schemas.microsoft.com/office/drawing/2014/main" id="{E098B155-EBA3-4FE8-B97F-FB658A65995A}"/>
               </a:ext>
             </a:extLst>
           </p:cNvPr>
@@ -5429,7 +5429,7 @@
           <p:cNvPr id="4" name="">
             <a:extLst xmlns:a="http://schemas.openxmlformats.org/drawingml/2006/main">
               <a:ext uri="{FF2B5EF4-FFF2-40B4-BE49-F238E27FC236}">
-                <a16:creationId xmlns:a16="http://schemas.microsoft.com/office/drawing/2014/main" id="{4A869A1E-0444-4634-8015-947E6DA137CE}"/>
+                <a16:creationId xmlns:a16="http://schemas.microsoft.com/office/drawing/2014/main" id="{2E0258CF-EBEC-4133-BD01-7C22B0C1B87D}"/>
               </a:ext>
             </a:extLst>
           </p:cNvPr>
@@ -5484,7 +5484,7 @@
     </p:spTree>
     <p:extLst>
       <p:ext uri="{BB962C8B-B14F-4D97-AF65-F5344CB8AC3E}">
-        <p14:creationId xmlns:p14="http://schemas.microsoft.com/office/powerpoint/2010/main" val="249971872"/>
+        <p14:creationId xmlns:p14="http://schemas.microsoft.com/office/powerpoint/2010/main" val="334869347"/>
       </p:ext>
     </p:extLst>
   </p:cSld>
@@ -5515,7 +5515,7 @@
           <p:cNvPr id="33" name="">
             <a:extLst xmlns:a="http://schemas.openxmlformats.org/drawingml/2006/main">
               <a:ext uri="{FF2B5EF4-FFF2-40B4-BE49-F238E27FC236}">
-                <a16:creationId xmlns:a16="http://schemas.microsoft.com/office/drawing/2014/main" id="{71348801-0A2C-4FBB-81E7-2116B84D3649}"/>
+                <a16:creationId xmlns:a16="http://schemas.microsoft.com/office/drawing/2014/main" id="{7CF1FDED-2E90-4A3A-ACE0-6B3AEB90AD0A}"/>
               </a:ext>
             </a:extLst>
           </p:cNvPr>
@@ -5572,7 +5572,7 @@
           <p:cNvPr id="2" name="">
             <a:extLst xmlns:a="http://schemas.openxmlformats.org/drawingml/2006/main">
               <a:ext uri="{FF2B5EF4-FFF2-40B4-BE49-F238E27FC236}">
-                <a16:creationId xmlns:a16="http://schemas.microsoft.com/office/drawing/2014/main" id="{D6388271-DFCF-408F-933C-58BB22487505}"/>
+                <a16:creationId xmlns:a16="http://schemas.microsoft.com/office/drawing/2014/main" id="{630AAA29-7744-4465-AAD2-96EC49DFF6CD}"/>
               </a:ext>
             </a:extLst>
           </p:cNvPr>
@@ -5635,7 +5635,7 @@
           <p:cNvPr id="3" name="">
             <a:extLst xmlns:a="http://schemas.openxmlformats.org/drawingml/2006/main">
               <a:ext uri="{FF2B5EF4-FFF2-40B4-BE49-F238E27FC236}">
-                <a16:creationId xmlns:a16="http://schemas.microsoft.com/office/drawing/2014/main" id="{BEB617E9-5FFF-4691-916D-77D53FB571DB}"/>
+                <a16:creationId xmlns:a16="http://schemas.microsoft.com/office/drawing/2014/main" id="{871ADBFB-8970-479C-BC4A-7FC950D6092A}"/>
               </a:ext>
             </a:extLst>
           </p:cNvPr>
@@ -5723,7 +5723,7 @@
           <p:cNvPr id="5" name="">
             <a:extLst xmlns:a="http://schemas.openxmlformats.org/drawingml/2006/main">
               <a:ext uri="{FF2B5EF4-FFF2-40B4-BE49-F238E27FC236}">
-                <a16:creationId xmlns:a16="http://schemas.microsoft.com/office/drawing/2014/main" id="{92696D2D-B927-4AFF-8244-54C6C41D0C4F}"/>
+                <a16:creationId xmlns:a16="http://schemas.microsoft.com/office/drawing/2014/main" id="{A4D15168-60B3-4B73-9DEE-42A67D931170}"/>
               </a:ext>
             </a:extLst>
           </p:cNvPr>
@@ -5780,7 +5780,7 @@
           <p:cNvPr id="6" name="">
             <a:extLst xmlns:a="http://schemas.openxmlformats.org/drawingml/2006/main">
               <a:ext uri="{FF2B5EF4-FFF2-40B4-BE49-F238E27FC236}">
-                <a16:creationId xmlns:a16="http://schemas.microsoft.com/office/drawing/2014/main" id="{7C7ADD15-FB24-4AE9-ADB0-BF56074455B0}"/>
+                <a16:creationId xmlns:a16="http://schemas.microsoft.com/office/drawing/2014/main" id="{859B1EBD-AF06-49EF-8462-3C7F6C0825EF}"/>
               </a:ext>
             </a:extLst>
           </p:cNvPr>
@@ -5866,7 +5866,7 @@
           <p:cNvPr id="7" name="">
             <a:extLst xmlns:a="http://schemas.openxmlformats.org/drawingml/2006/main">
               <a:ext uri="{FF2B5EF4-FFF2-40B4-BE49-F238E27FC236}">
-                <a16:creationId xmlns:a16="http://schemas.microsoft.com/office/drawing/2014/main" id="{F52A0D62-1CC8-45C5-B372-5A6A608CCA8C}"/>
+                <a16:creationId xmlns:a16="http://schemas.microsoft.com/office/drawing/2014/main" id="{A9DE3BEB-802E-452A-BF0E-6BE239D9C735}"/>
               </a:ext>
             </a:extLst>
           </p:cNvPr>
@@ -5952,7 +5952,7 @@
           <p:cNvPr id="8" name="">
             <a:extLst xmlns:a="http://schemas.openxmlformats.org/drawingml/2006/main">
               <a:ext uri="{FF2B5EF4-FFF2-40B4-BE49-F238E27FC236}">
-                <a16:creationId xmlns:a16="http://schemas.microsoft.com/office/drawing/2014/main" id="{63F8D7A4-7137-49C8-8B9D-975BAE1984FD}"/>
+                <a16:creationId xmlns:a16="http://schemas.microsoft.com/office/drawing/2014/main" id="{D255C740-124F-4B60-8DC4-D7EB6B668F0C}"/>
               </a:ext>
             </a:extLst>
           </p:cNvPr>
@@ -6038,7 +6038,7 @@
           <p:cNvPr id="9" name="">
             <a:extLst xmlns:a="http://schemas.openxmlformats.org/drawingml/2006/main">
               <a:ext uri="{FF2B5EF4-FFF2-40B4-BE49-F238E27FC236}">
-                <a16:creationId xmlns:a16="http://schemas.microsoft.com/office/drawing/2014/main" id="{DE7E1304-DBED-41FD-9C78-DBA7757D5A5B}"/>
+                <a16:creationId xmlns:a16="http://schemas.microsoft.com/office/drawing/2014/main" id="{57706567-2C93-4EBD-9090-CBD3A407D69A}"/>
               </a:ext>
             </a:extLst>
           </p:cNvPr>
@@ -6236,7 +6236,7 @@
           <p:cNvPr id="14" name="">
             <a:extLst xmlns:a="http://schemas.openxmlformats.org/drawingml/2006/main">
               <a:ext uri="{FF2B5EF4-FFF2-40B4-BE49-F238E27FC236}">
-                <a16:creationId xmlns:a16="http://schemas.microsoft.com/office/drawing/2014/main" id="{DF4937E0-6CC4-4DAC-A06D-F97782F3FC05}"/>
+                <a16:creationId xmlns:a16="http://schemas.microsoft.com/office/drawing/2014/main" id="{0377970B-8E2F-4999-B7EC-23B4D608576D}"/>
               </a:ext>
             </a:extLst>
           </p:cNvPr>
@@ -6322,7 +6322,7 @@
           <p:cNvPr id="15" name="">
             <a:extLst xmlns:a="http://schemas.openxmlformats.org/drawingml/2006/main">
               <a:ext uri="{FF2B5EF4-FFF2-40B4-BE49-F238E27FC236}">
-                <a16:creationId xmlns:a16="http://schemas.microsoft.com/office/drawing/2014/main" id="{D4321960-5B43-4FC0-BC03-5EE206029F1C}"/>
+                <a16:creationId xmlns:a16="http://schemas.microsoft.com/office/drawing/2014/main" id="{65026A1D-0CD9-4878-8EF1-2D81B8C5BAC5}"/>
               </a:ext>
             </a:extLst>
           </p:cNvPr>
@@ -6464,7 +6464,7 @@
           <p:cNvPr id="18" name="">
             <a:extLst xmlns:a="http://schemas.openxmlformats.org/drawingml/2006/main">
               <a:ext uri="{FF2B5EF4-FFF2-40B4-BE49-F238E27FC236}">
-                <a16:creationId xmlns:a16="http://schemas.microsoft.com/office/drawing/2014/main" id="{75C71A87-C54B-4EB0-B5FD-69EC4E00E8B2}"/>
+                <a16:creationId xmlns:a16="http://schemas.microsoft.com/office/drawing/2014/main" id="{1F82F3A7-AF9E-4E7D-9B21-9631B7B286CC}"/>
               </a:ext>
             </a:extLst>
           </p:cNvPr>
@@ -6606,7 +6606,7 @@
           <p:cNvPr id="21" name="">
             <a:extLst xmlns:a="http://schemas.openxmlformats.org/drawingml/2006/main">
               <a:ext uri="{FF2B5EF4-FFF2-40B4-BE49-F238E27FC236}">
-                <a16:creationId xmlns:a16="http://schemas.microsoft.com/office/drawing/2014/main" id="{9A681514-2389-49A5-827A-F7E1A3F4C47E}"/>
+                <a16:creationId xmlns:a16="http://schemas.microsoft.com/office/drawing/2014/main" id="{08ABA8CE-8AA2-45F9-B3A0-DD653A616126}"/>
               </a:ext>
             </a:extLst>
           </p:cNvPr>
@@ -6692,7 +6692,7 @@
           <p:cNvPr id="22" name="">
             <a:extLst xmlns:a="http://schemas.openxmlformats.org/drawingml/2006/main">
               <a:ext uri="{FF2B5EF4-FFF2-40B4-BE49-F238E27FC236}">
-                <a16:creationId xmlns:a16="http://schemas.microsoft.com/office/drawing/2014/main" id="{AB016182-3DCA-427B-B8D7-C97C35BCE556}"/>
+                <a16:creationId xmlns:a16="http://schemas.microsoft.com/office/drawing/2014/main" id="{9CEBF358-5248-4008-9248-74FF3F4DF842}"/>
               </a:ext>
             </a:extLst>
           </p:cNvPr>
@@ -6778,7 +6778,7 @@
           <p:cNvPr id="23" name="">
             <a:extLst xmlns:a="http://schemas.openxmlformats.org/drawingml/2006/main">
               <a:ext uri="{FF2B5EF4-FFF2-40B4-BE49-F238E27FC236}">
-                <a16:creationId xmlns:a16="http://schemas.microsoft.com/office/drawing/2014/main" id="{02699E3D-55CF-4AEE-97B3-5F8EEEA5EEE7}"/>
+                <a16:creationId xmlns:a16="http://schemas.microsoft.com/office/drawing/2014/main" id="{69DE29DE-7D4E-4AAD-9E5C-F87C8AE54CF0}"/>
               </a:ext>
             </a:extLst>
           </p:cNvPr>
@@ -6939,7 +6939,7 @@
           <p:cNvPr id="27" name="">
             <a:extLst xmlns:a="http://schemas.openxmlformats.org/drawingml/2006/main">
               <a:ext uri="{FF2B5EF4-FFF2-40B4-BE49-F238E27FC236}">
-                <a16:creationId xmlns:a16="http://schemas.microsoft.com/office/drawing/2014/main" id="{08F36E55-D997-43E2-BE95-8EBB423AD831}"/>
+                <a16:creationId xmlns:a16="http://schemas.microsoft.com/office/drawing/2014/main" id="{E6BA9C06-16EF-459A-B520-E867989F1792}"/>
               </a:ext>
             </a:extLst>
           </p:cNvPr>
@@ -7110,7 +7110,7 @@
           <p:cNvPr id="32" name="">
             <a:extLst xmlns:a="http://schemas.openxmlformats.org/drawingml/2006/main">
               <a:ext uri="{FF2B5EF4-FFF2-40B4-BE49-F238E27FC236}">
-                <a16:creationId xmlns:a16="http://schemas.microsoft.com/office/drawing/2014/main" id="{7513DD9A-E2F7-4891-AAF9-8DE108B8777A}"/>
+                <a16:creationId xmlns:a16="http://schemas.microsoft.com/office/drawing/2014/main" id="{0F90A27D-8C13-4E3C-8966-F1FFD0013D1B}"/>
               </a:ext>
             </a:extLst>
           </p:cNvPr>
@@ -7165,7 +7165,7 @@
     </p:spTree>
     <p:extLst>
       <p:ext uri="{BB962C8B-B14F-4D97-AF65-F5344CB8AC3E}">
-        <p14:creationId xmlns:p14="http://schemas.microsoft.com/office/powerpoint/2010/main" val="520255272"/>
+        <p14:creationId xmlns:p14="http://schemas.microsoft.com/office/powerpoint/2010/main" val="383905501"/>
       </p:ext>
     </p:extLst>
   </p:cSld>
@@ -7196,7 +7196,7 @@
           <p:cNvPr id="14" name="">
             <a:extLst xmlns:a="http://schemas.openxmlformats.org/drawingml/2006/main">
               <a:ext uri="{FF2B5EF4-FFF2-40B4-BE49-F238E27FC236}">
-                <a16:creationId xmlns:a16="http://schemas.microsoft.com/office/drawing/2014/main" id="{2096987E-272C-41A0-B4EE-91CF2090D50D}"/>
+                <a16:creationId xmlns:a16="http://schemas.microsoft.com/office/drawing/2014/main" id="{16C2CD76-15EE-45EB-9A8C-D2BB64334240}"/>
               </a:ext>
             </a:extLst>
           </p:cNvPr>
@@ -7257,13 +7257,13 @@
           <p:nvPr/>
         </p:nvPicPr>
         <p:blipFill>
-          <a:blip xmlns:r="http://schemas.openxmlformats.org/officeDocument/2006/relationships" xmlns:a="http://schemas.openxmlformats.org/drawingml/2006/main" r:embed="R7a95344b276c4480"/>
+          <a:blip xmlns:r="http://schemas.openxmlformats.org/officeDocument/2006/relationships" xmlns:a="http://schemas.openxmlformats.org/drawingml/2006/main" r:embed="R3ebe87a0a2e043cb"/>
           <a:stretch xmlns:a="http://schemas.openxmlformats.org/drawingml/2006/main"/>
         </p:blipFill>
         <p:spPr>
           <a:xfrm xmlns:a="http://schemas.openxmlformats.org/drawingml/2006/main">
-            <a:off x="762000" y="1758555"/>
-            <a:ext cx="7048500" cy="3198016"/>
+            <a:off x="1122866" y="1466850"/>
+            <a:ext cx="6326768" cy="4095750"/>
           </a:xfrm>
           <a:prstGeom xmlns:a="http://schemas.openxmlformats.org/drawingml/2006/main" prst="rect">
             <a:avLst/>
@@ -7275,7 +7275,7 @@
           <p:cNvPr id="3" name="">
             <a:extLst xmlns:a="http://schemas.openxmlformats.org/drawingml/2006/main">
               <a:ext uri="{FF2B5EF4-FFF2-40B4-BE49-F238E27FC236}">
-                <a16:creationId xmlns:a16="http://schemas.microsoft.com/office/drawing/2014/main" id="{B1AA1E08-52AC-4566-AC7E-51FE0A77D36F}"/>
+                <a16:creationId xmlns:a16="http://schemas.microsoft.com/office/drawing/2014/main" id="{D97C8900-51DA-4640-A2B4-AF372F43BDCD}"/>
               </a:ext>
             </a:extLst>
           </p:cNvPr>
@@ -7332,7 +7332,7 @@
           <p:cNvPr id="4" name="">
             <a:extLst xmlns:a="http://schemas.openxmlformats.org/drawingml/2006/main">
               <a:ext uri="{FF2B5EF4-FFF2-40B4-BE49-F238E27FC236}">
-                <a16:creationId xmlns:a16="http://schemas.microsoft.com/office/drawing/2014/main" id="{468535AA-BEA2-45BD-B2EB-0E7E4361137A}"/>
+                <a16:creationId xmlns:a16="http://schemas.microsoft.com/office/drawing/2014/main" id="{3B802567-04BC-4924-88F0-A7B8D7765AC8}"/>
               </a:ext>
             </a:extLst>
           </p:cNvPr>
@@ -7389,7 +7389,7 @@
           <p:cNvPr id="5" name="">
             <a:extLst xmlns:a="http://schemas.openxmlformats.org/drawingml/2006/main">
               <a:ext uri="{FF2B5EF4-FFF2-40B4-BE49-F238E27FC236}">
-                <a16:creationId xmlns:a16="http://schemas.microsoft.com/office/drawing/2014/main" id="{2BB2A337-E05C-4D33-8A1B-6B6F79DE3D13}"/>
+                <a16:creationId xmlns:a16="http://schemas.microsoft.com/office/drawing/2014/main" id="{A07A266F-D9D1-4BC9-BECD-5743E2A7692C}"/>
               </a:ext>
             </a:extLst>
           </p:cNvPr>
@@ -7446,7 +7446,7 @@
           <p:cNvPr id="6" name="">
             <a:extLst xmlns:a="http://schemas.openxmlformats.org/drawingml/2006/main">
               <a:ext uri="{FF2B5EF4-FFF2-40B4-BE49-F238E27FC236}">
-                <a16:creationId xmlns:a16="http://schemas.microsoft.com/office/drawing/2014/main" id="{628246EC-2E23-4F92-BCA5-1ECD5473A4A4}"/>
+                <a16:creationId xmlns:a16="http://schemas.microsoft.com/office/drawing/2014/main" id="{474EB059-526B-496D-A90D-E62C7579236F}"/>
               </a:ext>
             </a:extLst>
           </p:cNvPr>
@@ -7503,7 +7503,7 @@
           <p:cNvPr id="7" name="">
             <a:extLst xmlns:a="http://schemas.openxmlformats.org/drawingml/2006/main">
               <a:ext uri="{FF2B5EF4-FFF2-40B4-BE49-F238E27FC236}">
-                <a16:creationId xmlns:a16="http://schemas.microsoft.com/office/drawing/2014/main" id="{0A08F0AD-6F72-4CD1-A89B-D10C064173B7}"/>
+                <a16:creationId xmlns:a16="http://schemas.microsoft.com/office/drawing/2014/main" id="{5723ECA4-7F24-470D-B568-477927711BCB}"/>
               </a:ext>
             </a:extLst>
           </p:cNvPr>
@@ -7560,7 +7560,7 @@
           <p:cNvPr id="8" name="">
             <a:extLst xmlns:a="http://schemas.openxmlformats.org/drawingml/2006/main">
               <a:ext uri="{FF2B5EF4-FFF2-40B4-BE49-F238E27FC236}">
-                <a16:creationId xmlns:a16="http://schemas.microsoft.com/office/drawing/2014/main" id="{8922B702-CA48-47AE-BC2C-583C820113EA}"/>
+                <a16:creationId xmlns:a16="http://schemas.microsoft.com/office/drawing/2014/main" id="{62B25D1D-6031-4832-960D-360855184784}"/>
               </a:ext>
             </a:extLst>
           </p:cNvPr>
@@ -7617,7 +7617,7 @@
           <p:cNvPr id="9" name="">
             <a:extLst xmlns:a="http://schemas.openxmlformats.org/drawingml/2006/main">
               <a:ext uri="{FF2B5EF4-FFF2-40B4-BE49-F238E27FC236}">
-                <a16:creationId xmlns:a16="http://schemas.microsoft.com/office/drawing/2014/main" id="{0F7EE5D9-DBE5-437D-A972-939A8FF26B6F}"/>
+                <a16:creationId xmlns:a16="http://schemas.microsoft.com/office/drawing/2014/main" id="{1E6CED69-38F8-48BF-BAFC-A408B18D6C28}"/>
               </a:ext>
             </a:extLst>
           </p:cNvPr>
@@ -7674,7 +7674,7 @@
           <p:cNvPr id="10" name="">
             <a:extLst xmlns:a="http://schemas.openxmlformats.org/drawingml/2006/main">
               <a:ext uri="{FF2B5EF4-FFF2-40B4-BE49-F238E27FC236}">
-                <a16:creationId xmlns:a16="http://schemas.microsoft.com/office/drawing/2014/main" id="{56607F24-93A2-4E37-8B90-B793C217A44B}"/>
+                <a16:creationId xmlns:a16="http://schemas.microsoft.com/office/drawing/2014/main" id="{0943F4E2-E9FD-42C4-ABC6-5D45ED3F4BE5}"/>
               </a:ext>
             </a:extLst>
           </p:cNvPr>
@@ -7731,7 +7731,7 @@
           <p:cNvPr id="11" name="">
             <a:extLst xmlns:a="http://schemas.openxmlformats.org/drawingml/2006/main">
               <a:ext uri="{FF2B5EF4-FFF2-40B4-BE49-F238E27FC236}">
-                <a16:creationId xmlns:a16="http://schemas.microsoft.com/office/drawing/2014/main" id="{75DA2D61-6286-49C7-84C9-58F148F09014}"/>
+                <a16:creationId xmlns:a16="http://schemas.microsoft.com/office/drawing/2014/main" id="{E1D41C1E-6372-4A86-BEBA-A23838C1C057}"/>
               </a:ext>
             </a:extLst>
           </p:cNvPr>
@@ -7788,18 +7788,18 @@
           <p:cNvPr id="12" name="">
             <a:extLst xmlns:a="http://schemas.openxmlformats.org/drawingml/2006/main">
               <a:ext uri="{FF2B5EF4-FFF2-40B4-BE49-F238E27FC236}">
-                <a16:creationId xmlns:a16="http://schemas.microsoft.com/office/drawing/2014/main" id="{50ACDF34-1CCE-4A42-939E-3FAE45D0BCCA}"/>
-              </a:ext>
-            </a:extLst>
-          </p:cNvPr>
-          <p:cNvSpPr>
-            <a:spLocks xmlns:a="http://schemas.openxmlformats.org/drawingml/2006/main" noGrp="1"/>
-          </p:cNvSpPr>
-          <p:nvPr/>
-        </p:nvSpPr>
-        <p:spPr>
-          <a:xfrm xmlns:a="http://schemas.openxmlformats.org/drawingml/2006/main">
-            <a:off x="800100" y="5334000"/>
+                <a16:creationId xmlns:a16="http://schemas.microsoft.com/office/drawing/2014/main" id="{4688301E-B6A1-4B70-AF01-BD98A0BBD2B2}"/>
+              </a:ext>
+            </a:extLst>
+          </p:cNvPr>
+          <p:cNvSpPr>
+            <a:spLocks xmlns:a="http://schemas.openxmlformats.org/drawingml/2006/main" noGrp="1"/>
+          </p:cNvSpPr>
+          <p:nvPr/>
+        </p:nvSpPr>
+        <p:spPr>
+          <a:xfrm xmlns:a="http://schemas.openxmlformats.org/drawingml/2006/main">
+            <a:off x="800100" y="5772150"/>
             <a:ext cx="6667500" cy="400050"/>
           </a:xfrm>
           <a:prstGeom xmlns:a="http://schemas.openxmlformats.org/drawingml/2006/main" prst="rect">
@@ -7817,24 +7817,24 @@
           <a:lstStyle xmlns:a="http://schemas.openxmlformats.org/drawingml/2006/main"/>
           <a:p xmlns:a="http://schemas.openxmlformats.org/drawingml/2006/main">
             <a:pPr>
-              <a:defRPr sz="2175" b="0">
-                <a:solidFill>
-                  <a:srgbClr val="714CB0"/>
-                </a:solidFill>
-                <a:latin typeface="Arial"/>
-                <a:ea typeface="Arial"/>
-                <a:cs typeface="Arial"/>
-              </a:defRPr>
-            </a:pPr>
-            <a:r>
-              <a:rPr sz="2175" b="0">
-                <a:solidFill>
-                  <a:srgbClr val="714CB0"/>
-                </a:solidFill>
-                <a:latin typeface="Arial"/>
-                <a:ea typeface="Arial"/>
-                <a:cs typeface="Arial"/>
-                <a:hlinkClick xmlns:r="http://schemas.openxmlformats.org/officeDocument/2006/relationships" r:id="R048217fe858c4143"/>
+              <a:defRPr sz="1875" b="0">
+                <a:solidFill>
+                  <a:srgbClr val="714CB0"/>
+                </a:solidFill>
+                <a:latin typeface="Arial"/>
+                <a:ea typeface="Arial"/>
+                <a:cs typeface="Arial"/>
+              </a:defRPr>
+            </a:pPr>
+            <a:r>
+              <a:rPr sz="1875" b="0">
+                <a:solidFill>
+                  <a:srgbClr val="714CB0"/>
+                </a:solidFill>
+                <a:latin typeface="Arial"/>
+                <a:ea typeface="Arial"/>
+                <a:cs typeface="Arial"/>
+                <a:hlinkClick xmlns:r="http://schemas.openxmlformats.org/officeDocument/2006/relationships" r:id="Rc7e0e929af6a4560"/>
               </a:rPr>
               <a:t>Watch the demo — 3:30</a:t>
             </a:r>
@@ -7846,19 +7846,19 @@
           <p:cNvPr id="13" name="">
             <a:extLst xmlns:a="http://schemas.openxmlformats.org/drawingml/2006/main">
               <a:ext uri="{FF2B5EF4-FFF2-40B4-BE49-F238E27FC236}">
-                <a16:creationId xmlns:a16="http://schemas.microsoft.com/office/drawing/2014/main" id="{B236452D-1D82-40F0-B487-F63418238970}"/>
-              </a:ext>
-            </a:extLst>
-          </p:cNvPr>
-          <p:cNvSpPr>
-            <a:spLocks xmlns:a="http://schemas.openxmlformats.org/drawingml/2006/main" noGrp="1"/>
-          </p:cNvSpPr>
-          <p:nvPr/>
-        </p:nvSpPr>
-        <p:spPr>
-          <a:xfrm xmlns:a="http://schemas.openxmlformats.org/drawingml/2006/main">
-            <a:off x="800100" y="5924550"/>
-            <a:ext cx="6858000" cy="600075"/>
+                <a16:creationId xmlns:a16="http://schemas.microsoft.com/office/drawing/2014/main" id="{2E612841-9274-49F8-AC67-8B1502BE4536}"/>
+              </a:ext>
+            </a:extLst>
+          </p:cNvPr>
+          <p:cNvSpPr>
+            <a:spLocks xmlns:a="http://schemas.openxmlformats.org/drawingml/2006/main" noGrp="1"/>
+          </p:cNvSpPr>
+          <p:nvPr/>
+        </p:nvSpPr>
+        <p:spPr>
+          <a:xfrm xmlns:a="http://schemas.openxmlformats.org/drawingml/2006/main">
+            <a:off x="800100" y="6191250"/>
+            <a:ext cx="10572750" cy="381000"/>
           </a:xfrm>
           <a:prstGeom xmlns:a="http://schemas.openxmlformats.org/drawingml/2006/main" prst="rect">
             <a:avLst/>
@@ -7875,7 +7875,7 @@
           <a:lstStyle xmlns:a="http://schemas.openxmlformats.org/drawingml/2006/main"/>
           <a:p xmlns:a="http://schemas.openxmlformats.org/drawingml/2006/main">
             <a:pPr>
-              <a:defRPr sz="1725" b="0">
+              <a:defRPr sz="1575" b="0">
                 <a:solidFill>
                   <a:srgbClr val="655E79"/>
                 </a:solidFill>
@@ -7885,7 +7885,7 @@
               </a:defRPr>
             </a:pPr>
             <a:r>
-              <a:rPr sz="1725" b="0">
+              <a:rPr sz="1575" b="0">
                 <a:solidFill>
                   <a:srgbClr val="655E79"/>
                 </a:solidFill>
@@ -7901,7 +7901,7 @@
     </p:spTree>
     <p:extLst>
       <p:ext uri="{BB962C8B-B14F-4D97-AF65-F5344CB8AC3E}">
-        <p14:creationId xmlns:p14="http://schemas.microsoft.com/office/powerpoint/2010/main" val="1241765047"/>
+        <p14:creationId xmlns:p14="http://schemas.microsoft.com/office/powerpoint/2010/main" val="777226070"/>
       </p:ext>
     </p:extLst>
   </p:cSld>
@@ -7932,7 +7932,7 @@
           <p:cNvPr id="14" name="">
             <a:extLst xmlns:a="http://schemas.openxmlformats.org/drawingml/2006/main">
               <a:ext uri="{FF2B5EF4-FFF2-40B4-BE49-F238E27FC236}">
-                <a16:creationId xmlns:a16="http://schemas.microsoft.com/office/drawing/2014/main" id="{48DAB7A2-6EFE-443F-8075-E0D5AD106BB1}"/>
+                <a16:creationId xmlns:a16="http://schemas.microsoft.com/office/drawing/2014/main" id="{613B2597-DF9A-4E80-965A-9C85F5716E62}"/>
               </a:ext>
             </a:extLst>
           </p:cNvPr>
@@ -7989,7 +7989,7 @@
           <p:cNvPr id="2" name="">
             <a:extLst xmlns:a="http://schemas.openxmlformats.org/drawingml/2006/main">
               <a:ext uri="{FF2B5EF4-FFF2-40B4-BE49-F238E27FC236}">
-                <a16:creationId xmlns:a16="http://schemas.microsoft.com/office/drawing/2014/main" id="{FE453E3F-02C1-4FDF-8189-4F3C031889EE}"/>
+                <a16:creationId xmlns:a16="http://schemas.microsoft.com/office/drawing/2014/main" id="{12D13443-891C-49D2-8B19-655B2557BACD}"/>
               </a:ext>
             </a:extLst>
           </p:cNvPr>
@@ -8046,7 +8046,7 @@
           <p:cNvPr id="3" name="">
             <a:extLst xmlns:a="http://schemas.openxmlformats.org/drawingml/2006/main">
               <a:ext uri="{FF2B5EF4-FFF2-40B4-BE49-F238E27FC236}">
-                <a16:creationId xmlns:a16="http://schemas.microsoft.com/office/drawing/2014/main" id="{6E3F96B8-A7AD-4FE9-B3E0-377E840411DB}"/>
+                <a16:creationId xmlns:a16="http://schemas.microsoft.com/office/drawing/2014/main" id="{DEE5A77C-DDA4-4AF1-AACF-09598D25F787}"/>
               </a:ext>
             </a:extLst>
           </p:cNvPr>
@@ -8126,7 +8126,7 @@
           <p:cNvPr id="4" name="">
             <a:extLst xmlns:a="http://schemas.openxmlformats.org/drawingml/2006/main">
               <a:ext uri="{FF2B5EF4-FFF2-40B4-BE49-F238E27FC236}">
-                <a16:creationId xmlns:a16="http://schemas.microsoft.com/office/drawing/2014/main" id="{18E80C2C-DF7F-43AC-96E4-A75D41A363A5}"/>
+                <a16:creationId xmlns:a16="http://schemas.microsoft.com/office/drawing/2014/main" id="{C46D37C8-AEE8-4D5D-B565-4C989EDC5D36}"/>
               </a:ext>
             </a:extLst>
           </p:cNvPr>
@@ -8156,7 +8156,7 @@
           <p:cNvPr id="5" name="">
             <a:extLst xmlns:a="http://schemas.openxmlformats.org/drawingml/2006/main">
               <a:ext uri="{FF2B5EF4-FFF2-40B4-BE49-F238E27FC236}">
-                <a16:creationId xmlns:a16="http://schemas.microsoft.com/office/drawing/2014/main" id="{DDBE6621-2D65-4BBB-871A-46B14F3088D9}"/>
+                <a16:creationId xmlns:a16="http://schemas.microsoft.com/office/drawing/2014/main" id="{3B87451C-C946-4932-98A3-ECE96CAB5479}"/>
               </a:ext>
             </a:extLst>
           </p:cNvPr>
@@ -8213,7 +8213,7 @@
           <p:cNvPr id="6" name="">
             <a:extLst xmlns:a="http://schemas.openxmlformats.org/drawingml/2006/main">
               <a:ext uri="{FF2B5EF4-FFF2-40B4-BE49-F238E27FC236}">
-                <a16:creationId xmlns:a16="http://schemas.microsoft.com/office/drawing/2014/main" id="{226FF069-3CA9-49CE-B057-40D7B6F4D811}"/>
+                <a16:creationId xmlns:a16="http://schemas.microsoft.com/office/drawing/2014/main" id="{5522A9E2-C651-4E92-8A8D-60D7AC47269C}"/>
               </a:ext>
             </a:extLst>
           </p:cNvPr>
@@ -8293,7 +8293,7 @@
           <p:cNvPr id="7" name="">
             <a:extLst xmlns:a="http://schemas.openxmlformats.org/drawingml/2006/main">
               <a:ext uri="{FF2B5EF4-FFF2-40B4-BE49-F238E27FC236}">
-                <a16:creationId xmlns:a16="http://schemas.microsoft.com/office/drawing/2014/main" id="{545CF767-8C51-4292-8728-02A32F3A328B}"/>
+                <a16:creationId xmlns:a16="http://schemas.microsoft.com/office/drawing/2014/main" id="{010BA5CD-068B-406B-AA0C-79DD213D86B0}"/>
               </a:ext>
             </a:extLst>
           </p:cNvPr>
@@ -8323,7 +8323,7 @@
           <p:cNvPr id="8" name="">
             <a:extLst xmlns:a="http://schemas.openxmlformats.org/drawingml/2006/main">
               <a:ext uri="{FF2B5EF4-FFF2-40B4-BE49-F238E27FC236}">
-                <a16:creationId xmlns:a16="http://schemas.microsoft.com/office/drawing/2014/main" id="{67008AE7-4FA7-408A-8563-6A3ED8DAA047}"/>
+                <a16:creationId xmlns:a16="http://schemas.microsoft.com/office/drawing/2014/main" id="{0E4C8E9E-82AB-4A57-A256-432D0BD44616}"/>
               </a:ext>
             </a:extLst>
           </p:cNvPr>
@@ -8380,7 +8380,7 @@
           <p:cNvPr id="9" name="">
             <a:extLst xmlns:a="http://schemas.openxmlformats.org/drawingml/2006/main">
               <a:ext uri="{FF2B5EF4-FFF2-40B4-BE49-F238E27FC236}">
-                <a16:creationId xmlns:a16="http://schemas.microsoft.com/office/drawing/2014/main" id="{54E07A7D-9631-49C6-8F0D-9A2F21BA8B5C}"/>
+                <a16:creationId xmlns:a16="http://schemas.microsoft.com/office/drawing/2014/main" id="{2FBA9FCE-E56D-4289-9771-CDA3DA67B588}"/>
               </a:ext>
             </a:extLst>
           </p:cNvPr>
@@ -8460,7 +8460,7 @@
           <p:cNvPr id="10" name="">
             <a:extLst xmlns:a="http://schemas.openxmlformats.org/drawingml/2006/main">
               <a:ext uri="{FF2B5EF4-FFF2-40B4-BE49-F238E27FC236}">
-                <a16:creationId xmlns:a16="http://schemas.microsoft.com/office/drawing/2014/main" id="{363ED081-864D-4E83-9B7B-A106BC6CFC8B}"/>
+                <a16:creationId xmlns:a16="http://schemas.microsoft.com/office/drawing/2014/main" id="{7B6379DE-DD46-44D6-84E2-7EAF217E83C7}"/>
               </a:ext>
             </a:extLst>
           </p:cNvPr>
@@ -8490,7 +8490,7 @@
           <p:cNvPr id="11" name="">
             <a:extLst xmlns:a="http://schemas.openxmlformats.org/drawingml/2006/main">
               <a:ext uri="{FF2B5EF4-FFF2-40B4-BE49-F238E27FC236}">
-                <a16:creationId xmlns:a16="http://schemas.microsoft.com/office/drawing/2014/main" id="{9E8B2773-8D48-4A31-8540-A5023F6BCC32}"/>
+                <a16:creationId xmlns:a16="http://schemas.microsoft.com/office/drawing/2014/main" id="{87FB47C0-A3D3-46E4-B19F-ADD8605B078D}"/>
               </a:ext>
             </a:extLst>
           </p:cNvPr>
@@ -8547,7 +8547,7 @@
           <p:cNvPr id="12" name="">
             <a:extLst xmlns:a="http://schemas.openxmlformats.org/drawingml/2006/main">
               <a:ext uri="{FF2B5EF4-FFF2-40B4-BE49-F238E27FC236}">
-                <a16:creationId xmlns:a16="http://schemas.microsoft.com/office/drawing/2014/main" id="{1244DA14-3D01-4E6B-8E39-E130322EE609}"/>
+                <a16:creationId xmlns:a16="http://schemas.microsoft.com/office/drawing/2014/main" id="{DC8B82F5-3A0D-47D6-8B8A-DD6705FBA161}"/>
               </a:ext>
             </a:extLst>
           </p:cNvPr>
@@ -8627,7 +8627,7 @@
           <p:cNvPr id="13" name="">
             <a:extLst xmlns:a="http://schemas.openxmlformats.org/drawingml/2006/main">
               <a:ext uri="{FF2B5EF4-FFF2-40B4-BE49-F238E27FC236}">
-                <a16:creationId xmlns:a16="http://schemas.microsoft.com/office/drawing/2014/main" id="{0E97165D-D335-47C7-A3F6-7D55A25EA685}"/>
+                <a16:creationId xmlns:a16="http://schemas.microsoft.com/office/drawing/2014/main" id="{5CA182BF-A07C-4139-AA9B-99917D3399AD}"/>
               </a:ext>
             </a:extLst>
           </p:cNvPr>
@@ -8655,7 +8655,7 @@
     </p:spTree>
     <p:extLst>
       <p:ext uri="{BB962C8B-B14F-4D97-AF65-F5344CB8AC3E}">
-        <p14:creationId xmlns:p14="http://schemas.microsoft.com/office/powerpoint/2010/main" val="2067829595"/>
+        <p14:creationId xmlns:p14="http://schemas.microsoft.com/office/powerpoint/2010/main" val="225826411"/>
       </p:ext>
     </p:extLst>
   </p:cSld>
@@ -8686,7 +8686,7 @@
           <p:cNvPr id="13" name="">
             <a:extLst xmlns:a="http://schemas.openxmlformats.org/drawingml/2006/main">
               <a:ext uri="{FF2B5EF4-FFF2-40B4-BE49-F238E27FC236}">
-                <a16:creationId xmlns:a16="http://schemas.microsoft.com/office/drawing/2014/main" id="{E3196B6F-81AA-447A-82FB-544C13137EEA}"/>
+                <a16:creationId xmlns:a16="http://schemas.microsoft.com/office/drawing/2014/main" id="{38A7BCB3-AB61-46AE-97AD-D18562BA5E1C}"/>
               </a:ext>
             </a:extLst>
           </p:cNvPr>
@@ -8743,7 +8743,7 @@
           <p:cNvPr id="2" name="">
             <a:extLst xmlns:a="http://schemas.openxmlformats.org/drawingml/2006/main">
               <a:ext uri="{FF2B5EF4-FFF2-40B4-BE49-F238E27FC236}">
-                <a16:creationId xmlns:a16="http://schemas.microsoft.com/office/drawing/2014/main" id="{B0B0A5ED-675D-47F1-9FC4-A80FD7E063BC}"/>
+                <a16:creationId xmlns:a16="http://schemas.microsoft.com/office/drawing/2014/main" id="{172143F3-82D6-43C6-A025-591052BA7A77}"/>
               </a:ext>
             </a:extLst>
           </p:cNvPr>
@@ -8800,7 +8800,7 @@
           <p:cNvPr id="3" name="">
             <a:extLst xmlns:a="http://schemas.openxmlformats.org/drawingml/2006/main">
               <a:ext uri="{FF2B5EF4-FFF2-40B4-BE49-F238E27FC236}">
-                <a16:creationId xmlns:a16="http://schemas.microsoft.com/office/drawing/2014/main" id="{3A8CB972-CBA0-4D5E-B405-8448A99F8497}"/>
+                <a16:creationId xmlns:a16="http://schemas.microsoft.com/office/drawing/2014/main" id="{6F24F976-8710-4F0A-B213-F56F8EDC43D6}"/>
               </a:ext>
             </a:extLst>
           </p:cNvPr>
@@ -8857,7 +8857,7 @@
           <p:cNvPr id="4" name="">
             <a:extLst xmlns:a="http://schemas.openxmlformats.org/drawingml/2006/main">
               <a:ext uri="{FF2B5EF4-FFF2-40B4-BE49-F238E27FC236}">
-                <a16:creationId xmlns:a16="http://schemas.microsoft.com/office/drawing/2014/main" id="{E8492E7A-C1BE-4127-857D-6343CE7EBE0D}"/>
+                <a16:creationId xmlns:a16="http://schemas.microsoft.com/office/drawing/2014/main" id="{52706358-94D2-42AD-B328-36B269734920}"/>
               </a:ext>
             </a:extLst>
           </p:cNvPr>
@@ -8887,7 +8887,7 @@
           <p:cNvPr id="5" name="">
             <a:extLst xmlns:a="http://schemas.openxmlformats.org/drawingml/2006/main">
               <a:ext uri="{FF2B5EF4-FFF2-40B4-BE49-F238E27FC236}">
-                <a16:creationId xmlns:a16="http://schemas.microsoft.com/office/drawing/2014/main" id="{1D3207C5-5774-4F12-8E96-84080C690B74}"/>
+                <a16:creationId xmlns:a16="http://schemas.microsoft.com/office/drawing/2014/main" id="{EA26B3AF-CB9E-447E-965C-51F0FD1F71BC}"/>
               </a:ext>
             </a:extLst>
           </p:cNvPr>
@@ -8944,7 +8944,7 @@
           <p:cNvPr id="6" name="">
             <a:extLst xmlns:a="http://schemas.openxmlformats.org/drawingml/2006/main">
               <a:ext uri="{FF2B5EF4-FFF2-40B4-BE49-F238E27FC236}">
-                <a16:creationId xmlns:a16="http://schemas.microsoft.com/office/drawing/2014/main" id="{73C161F2-AE31-4719-89ED-7EDA4A6A55E5}"/>
+                <a16:creationId xmlns:a16="http://schemas.microsoft.com/office/drawing/2014/main" id="{597EC2D7-2726-4358-87DD-B726663E99B4}"/>
               </a:ext>
             </a:extLst>
           </p:cNvPr>
@@ -9001,7 +9001,7 @@
           <p:cNvPr id="7" name="">
             <a:extLst xmlns:a="http://schemas.openxmlformats.org/drawingml/2006/main">
               <a:ext uri="{FF2B5EF4-FFF2-40B4-BE49-F238E27FC236}">
-                <a16:creationId xmlns:a16="http://schemas.microsoft.com/office/drawing/2014/main" id="{0C32AB8D-DEAB-4EF1-BBFC-DF43319599F9}"/>
+                <a16:creationId xmlns:a16="http://schemas.microsoft.com/office/drawing/2014/main" id="{417AB8F2-B051-4835-82D5-A3073BBE6278}"/>
               </a:ext>
             </a:extLst>
           </p:cNvPr>
@@ -9031,7 +9031,7 @@
           <p:cNvPr id="8" name="">
             <a:extLst xmlns:a="http://schemas.openxmlformats.org/drawingml/2006/main">
               <a:ext uri="{FF2B5EF4-FFF2-40B4-BE49-F238E27FC236}">
-                <a16:creationId xmlns:a16="http://schemas.microsoft.com/office/drawing/2014/main" id="{7F43FDCC-83FD-4CDD-86FF-1C3195A0F3AE}"/>
+                <a16:creationId xmlns:a16="http://schemas.microsoft.com/office/drawing/2014/main" id="{F41B8383-2341-4F9F-9EEE-FF5E2A0F23DC}"/>
               </a:ext>
             </a:extLst>
           </p:cNvPr>
@@ -9088,7 +9088,7 @@
           <p:cNvPr id="9" name="">
             <a:extLst xmlns:a="http://schemas.openxmlformats.org/drawingml/2006/main">
               <a:ext uri="{FF2B5EF4-FFF2-40B4-BE49-F238E27FC236}">
-                <a16:creationId xmlns:a16="http://schemas.microsoft.com/office/drawing/2014/main" id="{E59CE5CF-F033-4797-876F-9AF4E235606C}"/>
+                <a16:creationId xmlns:a16="http://schemas.microsoft.com/office/drawing/2014/main" id="{DCC3C180-C485-483A-AE1A-E1E38B3E41C0}"/>
               </a:ext>
             </a:extLst>
           </p:cNvPr>
@@ -9145,7 +9145,7 @@
           <p:cNvPr id="10" name="">
             <a:extLst xmlns:a="http://schemas.openxmlformats.org/drawingml/2006/main">
               <a:ext uri="{FF2B5EF4-FFF2-40B4-BE49-F238E27FC236}">
-                <a16:creationId xmlns:a16="http://schemas.microsoft.com/office/drawing/2014/main" id="{B1748E0D-BAF8-4636-8ACB-EEA085256D63}"/>
+                <a16:creationId xmlns:a16="http://schemas.microsoft.com/office/drawing/2014/main" id="{B1AA90D5-A43C-4B6D-99FC-B3D55B5859CF}"/>
               </a:ext>
             </a:extLst>
           </p:cNvPr>
@@ -9175,7 +9175,7 @@
           <p:cNvPr id="11" name="">
             <a:extLst xmlns:a="http://schemas.openxmlformats.org/drawingml/2006/main">
               <a:ext uri="{FF2B5EF4-FFF2-40B4-BE49-F238E27FC236}">
-                <a16:creationId xmlns:a16="http://schemas.microsoft.com/office/drawing/2014/main" id="{017B4984-4E60-4AF0-B0CD-BB1182DFC1D0}"/>
+                <a16:creationId xmlns:a16="http://schemas.microsoft.com/office/drawing/2014/main" id="{04872361-66B6-4655-B579-BEAB13590DAE}"/>
               </a:ext>
             </a:extLst>
           </p:cNvPr>
@@ -9232,7 +9232,7 @@
           <p:cNvPr id="12" name="">
             <a:extLst xmlns:a="http://schemas.openxmlformats.org/drawingml/2006/main">
               <a:ext uri="{FF2B5EF4-FFF2-40B4-BE49-F238E27FC236}">
-                <a16:creationId xmlns:a16="http://schemas.microsoft.com/office/drawing/2014/main" id="{7C47AEA1-59B4-411C-BA66-A7E3B25FF401}"/>
+                <a16:creationId xmlns:a16="http://schemas.microsoft.com/office/drawing/2014/main" id="{FB8CAE23-53E4-48CE-B7B5-4A587369A2E7}"/>
               </a:ext>
             </a:extLst>
           </p:cNvPr>
@@ -9287,7 +9287,7 @@
     </p:spTree>
     <p:extLst>
       <p:ext uri="{BB962C8B-B14F-4D97-AF65-F5344CB8AC3E}">
-        <p14:creationId xmlns:p14="http://schemas.microsoft.com/office/powerpoint/2010/main" val="1701842343"/>
+        <p14:creationId xmlns:p14="http://schemas.microsoft.com/office/powerpoint/2010/main" val="1443416809"/>
       </p:ext>
     </p:extLst>
   </p:cSld>
@@ -9318,7 +9318,7 @@
           <p:cNvPr id="14" name="">
             <a:extLst xmlns:a="http://schemas.openxmlformats.org/drawingml/2006/main">
               <a:ext uri="{FF2B5EF4-FFF2-40B4-BE49-F238E27FC236}">
-                <a16:creationId xmlns:a16="http://schemas.microsoft.com/office/drawing/2014/main" id="{433A2C25-7C41-4D5D-B307-815C1BE94C96}"/>
+                <a16:creationId xmlns:a16="http://schemas.microsoft.com/office/drawing/2014/main" id="{4D052F05-758A-465F-BE18-C2FB8BE843AC}"/>
               </a:ext>
             </a:extLst>
           </p:cNvPr>
@@ -9375,7 +9375,7 @@
           <p:cNvPr id="2" name="">
             <a:extLst xmlns:a="http://schemas.openxmlformats.org/drawingml/2006/main">
               <a:ext uri="{FF2B5EF4-FFF2-40B4-BE49-F238E27FC236}">
-                <a16:creationId xmlns:a16="http://schemas.microsoft.com/office/drawing/2014/main" id="{C07DB383-8501-4E53-8A64-6FD95BE0F1F4}"/>
+                <a16:creationId xmlns:a16="http://schemas.microsoft.com/office/drawing/2014/main" id="{1CC85321-0548-429C-A028-B44F79F1051D}"/>
               </a:ext>
             </a:extLst>
           </p:cNvPr>
@@ -9432,7 +9432,7 @@
           <p:cNvPr id="3" name="">
             <a:extLst xmlns:a="http://schemas.openxmlformats.org/drawingml/2006/main">
               <a:ext uri="{FF2B5EF4-FFF2-40B4-BE49-F238E27FC236}">
-                <a16:creationId xmlns:a16="http://schemas.microsoft.com/office/drawing/2014/main" id="{B29F527B-1AB1-4AB8-BAA4-F4EBBAEF063D}"/>
+                <a16:creationId xmlns:a16="http://schemas.microsoft.com/office/drawing/2014/main" id="{BAD49F4F-9617-4BE0-B4BE-1BBE871B1D61}"/>
               </a:ext>
             </a:extLst>
           </p:cNvPr>
@@ -9489,7 +9489,7 @@
           <p:cNvPr id="4" name="">
             <a:extLst xmlns:a="http://schemas.openxmlformats.org/drawingml/2006/main">
               <a:ext uri="{FF2B5EF4-FFF2-40B4-BE49-F238E27FC236}">
-                <a16:creationId xmlns:a16="http://schemas.microsoft.com/office/drawing/2014/main" id="{CC618550-6ABA-4135-B81B-C37C679B4373}"/>
+                <a16:creationId xmlns:a16="http://schemas.microsoft.com/office/drawing/2014/main" id="{089B2BC3-467B-4C6F-89D3-52BFDB684D36}"/>
               </a:ext>
             </a:extLst>
           </p:cNvPr>
@@ -9546,7 +9546,7 @@
           <p:cNvPr id="5" name="">
             <a:extLst xmlns:a="http://schemas.openxmlformats.org/drawingml/2006/main">
               <a:ext uri="{FF2B5EF4-FFF2-40B4-BE49-F238E27FC236}">
-                <a16:creationId xmlns:a16="http://schemas.microsoft.com/office/drawing/2014/main" id="{F699695B-6EF0-4AD5-9567-DB35F48C095B}"/>
+                <a16:creationId xmlns:a16="http://schemas.microsoft.com/office/drawing/2014/main" id="{667A0066-E9E6-4446-BD46-EF29613411A2}"/>
               </a:ext>
             </a:extLst>
           </p:cNvPr>
@@ -9603,7 +9603,7 @@
           <p:cNvPr id="6" name="">
             <a:extLst xmlns:a="http://schemas.openxmlformats.org/drawingml/2006/main">
               <a:ext uri="{FF2B5EF4-FFF2-40B4-BE49-F238E27FC236}">
-                <a16:creationId xmlns:a16="http://schemas.microsoft.com/office/drawing/2014/main" id="{F9BA1ADF-1336-40C0-A64D-62A1E6B3DE14}"/>
+                <a16:creationId xmlns:a16="http://schemas.microsoft.com/office/drawing/2014/main" id="{C1459EE2-2ABD-4152-B9A5-47813B64D62E}"/>
               </a:ext>
             </a:extLst>
           </p:cNvPr>
@@ -9660,7 +9660,7 @@
           <p:cNvPr id="7" name="">
             <a:extLst xmlns:a="http://schemas.openxmlformats.org/drawingml/2006/main">
               <a:ext uri="{FF2B5EF4-FFF2-40B4-BE49-F238E27FC236}">
-                <a16:creationId xmlns:a16="http://schemas.microsoft.com/office/drawing/2014/main" id="{33AC47E6-9D4E-4F4D-B12B-D41A7D8C37F0}"/>
+                <a16:creationId xmlns:a16="http://schemas.microsoft.com/office/drawing/2014/main" id="{9A60FFB3-A665-400D-ACD4-EDA68A712105}"/>
               </a:ext>
             </a:extLst>
           </p:cNvPr>
@@ -9717,7 +9717,7 @@
           <p:cNvPr id="8" name="">
             <a:extLst xmlns:a="http://schemas.openxmlformats.org/drawingml/2006/main">
               <a:ext uri="{FF2B5EF4-FFF2-40B4-BE49-F238E27FC236}">
-                <a16:creationId xmlns:a16="http://schemas.microsoft.com/office/drawing/2014/main" id="{BE53F0BD-491B-4AAA-A678-A319E488E7C1}"/>
+                <a16:creationId xmlns:a16="http://schemas.microsoft.com/office/drawing/2014/main" id="{C5A23FF3-AEF5-4470-BE73-F5C5A5D38848}"/>
               </a:ext>
             </a:extLst>
           </p:cNvPr>
@@ -9774,7 +9774,7 @@
           <p:cNvPr id="9" name="">
             <a:extLst xmlns:a="http://schemas.openxmlformats.org/drawingml/2006/main">
               <a:ext uri="{FF2B5EF4-FFF2-40B4-BE49-F238E27FC236}">
-                <a16:creationId xmlns:a16="http://schemas.microsoft.com/office/drawing/2014/main" id="{F2FE8D55-1FFC-47D3-B091-45942217A4ED}"/>
+                <a16:creationId xmlns:a16="http://schemas.microsoft.com/office/drawing/2014/main" id="{83AF8E1E-7C17-4D84-83D8-FF6D894B7759}"/>
               </a:ext>
             </a:extLst>
           </p:cNvPr>
@@ -9831,7 +9831,7 @@
           <p:cNvPr id="10" name="">
             <a:extLst xmlns:a="http://schemas.openxmlformats.org/drawingml/2006/main">
               <a:ext uri="{FF2B5EF4-FFF2-40B4-BE49-F238E27FC236}">
-                <a16:creationId xmlns:a16="http://schemas.microsoft.com/office/drawing/2014/main" id="{98741487-0D7A-42C4-8B07-EB82A0353D49}"/>
+                <a16:creationId xmlns:a16="http://schemas.microsoft.com/office/drawing/2014/main" id="{26EDF07E-D65C-404E-9064-BD1FDECBBCA6}"/>
               </a:ext>
             </a:extLst>
           </p:cNvPr>
@@ -10157,7 +10157,7 @@
           <p:cNvPr id="12" name="">
             <a:extLst xmlns:a="http://schemas.openxmlformats.org/drawingml/2006/main">
               <a:ext uri="{FF2B5EF4-FFF2-40B4-BE49-F238E27FC236}">
-                <a16:creationId xmlns:a16="http://schemas.microsoft.com/office/drawing/2014/main" id="{DEBDB096-6997-490C-BE9F-EC404ED698C1}"/>
+                <a16:creationId xmlns:a16="http://schemas.microsoft.com/office/drawing/2014/main" id="{CF2AE8DB-9C12-4BF5-8E04-A6A33B92FED9}"/>
               </a:ext>
             </a:extLst>
           </p:cNvPr>
@@ -10214,7 +10214,7 @@
           <p:cNvPr id="13" name="">
             <a:extLst xmlns:a="http://schemas.openxmlformats.org/drawingml/2006/main">
               <a:ext uri="{FF2B5EF4-FFF2-40B4-BE49-F238E27FC236}">
-                <a16:creationId xmlns:a16="http://schemas.microsoft.com/office/drawing/2014/main" id="{93AC20A5-7D83-47C3-82D0-3BD0D09D0089}"/>
+                <a16:creationId xmlns:a16="http://schemas.microsoft.com/office/drawing/2014/main" id="{E2223508-52AE-4D58-A5F4-CBC51AEB1E08}"/>
               </a:ext>
             </a:extLst>
           </p:cNvPr>
@@ -10269,7 +10269,7 @@
     </p:spTree>
     <p:extLst>
       <p:ext uri="{BB962C8B-B14F-4D97-AF65-F5344CB8AC3E}">
-        <p14:creationId xmlns:p14="http://schemas.microsoft.com/office/powerpoint/2010/main" val="1452000656"/>
+        <p14:creationId xmlns:p14="http://schemas.microsoft.com/office/powerpoint/2010/main" val="1129704239"/>
       </p:ext>
     </p:extLst>
   </p:cSld>
@@ -10300,7 +10300,7 @@
           <p:cNvPr id="12" name="">
             <a:extLst xmlns:a="http://schemas.openxmlformats.org/drawingml/2006/main">
               <a:ext uri="{FF2B5EF4-FFF2-40B4-BE49-F238E27FC236}">
-                <a16:creationId xmlns:a16="http://schemas.microsoft.com/office/drawing/2014/main" id="{B9A825D0-18DD-4E2D-8051-A51B9EB8D8B9}"/>
+                <a16:creationId xmlns:a16="http://schemas.microsoft.com/office/drawing/2014/main" id="{8CC69BCA-4DA9-4A84-A1CF-5F83E17BF094}"/>
               </a:ext>
             </a:extLst>
           </p:cNvPr>
@@ -10357,7 +10357,7 @@
           <p:cNvPr id="2" name="">
             <a:extLst xmlns:a="http://schemas.openxmlformats.org/drawingml/2006/main">
               <a:ext uri="{FF2B5EF4-FFF2-40B4-BE49-F238E27FC236}">
-                <a16:creationId xmlns:a16="http://schemas.microsoft.com/office/drawing/2014/main" id="{E663F3B9-99F2-4968-9B45-302FB938DAAA}"/>
+                <a16:creationId xmlns:a16="http://schemas.microsoft.com/office/drawing/2014/main" id="{16BA86C9-FA65-4DF1-AFFB-1A7DDB71C79E}"/>
               </a:ext>
             </a:extLst>
           </p:cNvPr>
@@ -10414,7 +10414,7 @@
           <p:cNvPr id="3" name="">
             <a:extLst xmlns:a="http://schemas.openxmlformats.org/drawingml/2006/main">
               <a:ext uri="{FF2B5EF4-FFF2-40B4-BE49-F238E27FC236}">
-                <a16:creationId xmlns:a16="http://schemas.microsoft.com/office/drawing/2014/main" id="{7317C279-C577-411E-935A-0EAA146F2F54}"/>
+                <a16:creationId xmlns:a16="http://schemas.microsoft.com/office/drawing/2014/main" id="{44F44FCB-832B-4AEB-9709-297F0F374FB7}"/>
               </a:ext>
             </a:extLst>
           </p:cNvPr>
@@ -10471,7 +10471,7 @@
           <p:cNvPr id="4" name="">
             <a:extLst xmlns:a="http://schemas.openxmlformats.org/drawingml/2006/main">
               <a:ext uri="{FF2B5EF4-FFF2-40B4-BE49-F238E27FC236}">
-                <a16:creationId xmlns:a16="http://schemas.microsoft.com/office/drawing/2014/main" id="{05DE0D68-AF17-424F-B9D1-82AE144C2DB3}"/>
+                <a16:creationId xmlns:a16="http://schemas.microsoft.com/office/drawing/2014/main" id="{89BD70E0-55BF-47B2-A2D3-1A5C0105C942}"/>
               </a:ext>
             </a:extLst>
           </p:cNvPr>
@@ -10528,7 +10528,7 @@
           <p:cNvPr id="5" name="">
             <a:extLst xmlns:a="http://schemas.openxmlformats.org/drawingml/2006/main">
               <a:ext uri="{FF2B5EF4-FFF2-40B4-BE49-F238E27FC236}">
-                <a16:creationId xmlns:a16="http://schemas.microsoft.com/office/drawing/2014/main" id="{DC87F83B-F7B8-4F93-A8AD-BA394D6B4AE0}"/>
+                <a16:creationId xmlns:a16="http://schemas.microsoft.com/office/drawing/2014/main" id="{F1AFEFAA-5EB4-4DC8-B03E-1104B8FA0139}"/>
               </a:ext>
             </a:extLst>
           </p:cNvPr>
@@ -10558,7 +10558,7 @@
           <p:cNvPr id="6" name="">
             <a:extLst xmlns:a="http://schemas.openxmlformats.org/drawingml/2006/main">
               <a:ext uri="{FF2B5EF4-FFF2-40B4-BE49-F238E27FC236}">
-                <a16:creationId xmlns:a16="http://schemas.microsoft.com/office/drawing/2014/main" id="{F411F297-7113-4511-85AA-DCC757246FC3}"/>
+                <a16:creationId xmlns:a16="http://schemas.microsoft.com/office/drawing/2014/main" id="{DC6F3948-E249-47E6-BE86-1F8BE9F7E47F}"/>
               </a:ext>
             </a:extLst>
           </p:cNvPr>
@@ -10615,7 +10615,7 @@
           <p:cNvPr id="7" name="">
             <a:extLst xmlns:a="http://schemas.openxmlformats.org/drawingml/2006/main">
               <a:ext uri="{FF2B5EF4-FFF2-40B4-BE49-F238E27FC236}">
-                <a16:creationId xmlns:a16="http://schemas.microsoft.com/office/drawing/2014/main" id="{633FD91B-0EFF-4B2B-A292-E7DC0D01FFCB}"/>
+                <a16:creationId xmlns:a16="http://schemas.microsoft.com/office/drawing/2014/main" id="{EECDC7CA-FF64-4A33-B530-B8EB6F6F0055}"/>
               </a:ext>
             </a:extLst>
           </p:cNvPr>
@@ -10672,7 +10672,7 @@
           <p:cNvPr id="8" name="">
             <a:extLst xmlns:a="http://schemas.openxmlformats.org/drawingml/2006/main">
               <a:ext uri="{FF2B5EF4-FFF2-40B4-BE49-F238E27FC236}">
-                <a16:creationId xmlns:a16="http://schemas.microsoft.com/office/drawing/2014/main" id="{5264615E-CC8E-4E2F-AC55-7D6F3706F554}"/>
+                <a16:creationId xmlns:a16="http://schemas.microsoft.com/office/drawing/2014/main" id="{60579928-72D4-42E9-A5FD-B0FA88818E68}"/>
               </a:ext>
             </a:extLst>
           </p:cNvPr>
@@ -10702,7 +10702,7 @@
           <p:cNvPr id="9" name="">
             <a:extLst xmlns:a="http://schemas.openxmlformats.org/drawingml/2006/main">
               <a:ext uri="{FF2B5EF4-FFF2-40B4-BE49-F238E27FC236}">
-                <a16:creationId xmlns:a16="http://schemas.microsoft.com/office/drawing/2014/main" id="{116C9944-DB12-43C5-83B3-CED0FDA79B6A}"/>
+                <a16:creationId xmlns:a16="http://schemas.microsoft.com/office/drawing/2014/main" id="{8D126110-9619-4E39-B25D-1B5F2DDC8DD9}"/>
               </a:ext>
             </a:extLst>
           </p:cNvPr>
@@ -10759,7 +10759,7 @@
           <p:cNvPr id="10" name="">
             <a:extLst xmlns:a="http://schemas.openxmlformats.org/drawingml/2006/main">
               <a:ext uri="{FF2B5EF4-FFF2-40B4-BE49-F238E27FC236}">
-                <a16:creationId xmlns:a16="http://schemas.microsoft.com/office/drawing/2014/main" id="{58650E52-212A-414E-9FA5-8D775F30BF0B}"/>
+                <a16:creationId xmlns:a16="http://schemas.microsoft.com/office/drawing/2014/main" id="{FA132733-8D1A-4B8D-BD76-96FBB878A55B}"/>
               </a:ext>
             </a:extLst>
           </p:cNvPr>
@@ -10816,7 +10816,7 @@
           <p:cNvPr id="11" name="">
             <a:extLst xmlns:a="http://schemas.openxmlformats.org/drawingml/2006/main">
               <a:ext uri="{FF2B5EF4-FFF2-40B4-BE49-F238E27FC236}">
-                <a16:creationId xmlns:a16="http://schemas.microsoft.com/office/drawing/2014/main" id="{55F4B656-79C5-42DB-8361-91A6A91F7027}"/>
+                <a16:creationId xmlns:a16="http://schemas.microsoft.com/office/drawing/2014/main" id="{084EE004-2EF6-4AD3-886A-804227C30634}"/>
               </a:ext>
             </a:extLst>
           </p:cNvPr>
@@ -10844,7 +10844,7 @@
     </p:spTree>
     <p:extLst>
       <p:ext uri="{BB962C8B-B14F-4D97-AF65-F5344CB8AC3E}">
-        <p14:creationId xmlns:p14="http://schemas.microsoft.com/office/powerpoint/2010/main" val="1701460908"/>
+        <p14:creationId xmlns:p14="http://schemas.microsoft.com/office/powerpoint/2010/main" val="858775372"/>
       </p:ext>
     </p:extLst>
   </p:cSld>

</xml_diff>

<commit_message>
Finalize verified full-corpus PRISM submission
</commit_message>
<xml_diff>
--- a/submission/SRM_Team_Ctrl_Alt_Elite_1_Submission.pptx
+++ b/submission/SRM_Team_Ctrl_Alt_Elite_1_Submission.pptx
@@ -2,24 +2,24 @@
 <file path=ppt/presentation.xml><?xml version="1.0" encoding="utf-8"?>
 <p:presentation xmlns:p="http://schemas.openxmlformats.org/presentationml/2006/main">
   <p:sldMasterIdLst>
-    <p:sldMasterId xmlns:r="http://schemas.openxmlformats.org/officeDocument/2006/relationships" id="2147483648" r:id="R6bfee2f295704558"/>
+    <p:sldMasterId xmlns:r="http://schemas.openxmlformats.org/officeDocument/2006/relationships" id="2147483648" r:id="R0e190352c49b4686"/>
   </p:sldMasterIdLst>
   <p:notesMasterIdLst>
-    <p:notesMasterId xmlns:r="http://schemas.openxmlformats.org/officeDocument/2006/relationships" r:id="R0031f81d85294ccc"/>
+    <p:notesMasterId xmlns:r="http://schemas.openxmlformats.org/officeDocument/2006/relationships" r:id="Rcae7648eef2e4588"/>
   </p:notesMasterIdLst>
   <p:sldIdLst>
-    <p:sldId xmlns:r="http://schemas.openxmlformats.org/officeDocument/2006/relationships" id="256" r:id="R15c9bd34f12d463c"/>
-    <p:sldId xmlns:r="http://schemas.openxmlformats.org/officeDocument/2006/relationships" id="257" r:id="R436a12759fd6437a"/>
-    <p:sldId xmlns:r="http://schemas.openxmlformats.org/officeDocument/2006/relationships" id="258" r:id="R6b829dc952dd4630"/>
-    <p:sldId xmlns:r="http://schemas.openxmlformats.org/officeDocument/2006/relationships" id="259" r:id="Rebeff2e04e5d482d"/>
-    <p:sldId xmlns:r="http://schemas.openxmlformats.org/officeDocument/2006/relationships" id="260" r:id="R66ef8402df6a4411"/>
-    <p:sldId xmlns:r="http://schemas.openxmlformats.org/officeDocument/2006/relationships" id="261" r:id="Rbb02419e3b824b81"/>
-    <p:sldId xmlns:r="http://schemas.openxmlformats.org/officeDocument/2006/relationships" id="262" r:id="R544e5ca0155640db"/>
-    <p:sldId xmlns:r="http://schemas.openxmlformats.org/officeDocument/2006/relationships" id="263" r:id="R0cbb73b2201e4cd2"/>
-    <p:sldId xmlns:r="http://schemas.openxmlformats.org/officeDocument/2006/relationships" id="264" r:id="R108bd0c18a834e1c"/>
-    <p:sldId xmlns:r="http://schemas.openxmlformats.org/officeDocument/2006/relationships" id="265" r:id="R2111477f6d504957"/>
-    <p:sldId xmlns:r="http://schemas.openxmlformats.org/officeDocument/2006/relationships" id="266" r:id="R58e7f268e5564d72"/>
-    <p:sldId xmlns:r="http://schemas.openxmlformats.org/officeDocument/2006/relationships" id="267" r:id="R2d6fbab0d7ef482b"/>
+    <p:sldId xmlns:r="http://schemas.openxmlformats.org/officeDocument/2006/relationships" id="256" r:id="Ra90475ce9b4c4ef3"/>
+    <p:sldId xmlns:r="http://schemas.openxmlformats.org/officeDocument/2006/relationships" id="257" r:id="R2a158c7500744a6e"/>
+    <p:sldId xmlns:r="http://schemas.openxmlformats.org/officeDocument/2006/relationships" id="258" r:id="R3673c8b97dbf4870"/>
+    <p:sldId xmlns:r="http://schemas.openxmlformats.org/officeDocument/2006/relationships" id="259" r:id="R69a9ccc02ac04337"/>
+    <p:sldId xmlns:r="http://schemas.openxmlformats.org/officeDocument/2006/relationships" id="260" r:id="Rdd68b4c930f14481"/>
+    <p:sldId xmlns:r="http://schemas.openxmlformats.org/officeDocument/2006/relationships" id="261" r:id="R5dfae220155e4da6"/>
+    <p:sldId xmlns:r="http://schemas.openxmlformats.org/officeDocument/2006/relationships" id="262" r:id="R50f45ef7c7064665"/>
+    <p:sldId xmlns:r="http://schemas.openxmlformats.org/officeDocument/2006/relationships" id="263" r:id="R8c31251628da4316"/>
+    <p:sldId xmlns:r="http://schemas.openxmlformats.org/officeDocument/2006/relationships" id="264" r:id="Rc929aaa0c031445b"/>
+    <p:sldId xmlns:r="http://schemas.openxmlformats.org/officeDocument/2006/relationships" id="265" r:id="R08608fc5df6c4ad3"/>
+    <p:sldId xmlns:r="http://schemas.openxmlformats.org/officeDocument/2006/relationships" id="266" r:id="Ra60d909dd36c40b7"/>
+    <p:sldId xmlns:r="http://schemas.openxmlformats.org/officeDocument/2006/relationships" id="267" r:id="Rf647e1018d4b433a"/>
   </p:sldIdLst>
   <p:sldSz cx="12192000" cy="6858000"/>
   <p:notesSz cx="6858000" cy="9144000"/>
@@ -528,12 +528,7 @@
           <a:lstStyle xmlns:a="http://schemas.openxmlformats.org/drawingml/2006/main"/>
           <a:p xmlns:a="http://schemas.openxmlformats.org/drawingml/2006/main">
             <a:r>
-              <a:t>Linux CI run: https://github.com/SinghDevansh-2006/prism-code-intelligence/actions/runs/36049593708 . It covers CPU Docker build, startup/health, HTML and exact-usage/structural routes. It does not validate semantic/evolution gated-model downloads or fresh benchmark inference. Windows confirmation supplied by team lead on 30 September 2026.</a:t>
-            </a:r>
-          </a:p>
-          <a:p xmlns:a="http://schemas.openxmlformats.org/drawingml/2006/main">
-            <a:r>
-              <a:t>Sources: https://github.com/SinghDevansh-2006/prism-code-intelligence/tree/030e29f6133f0ff0ea138243891c886fcff5a039; user-provided final submission form and team confirmations, 30 September 2026.</a:t>
+              <a:t>Local sources: README.md; docs/review/windows-recheck.json; docs/review/mteb-uniform-result.json; docs/windows-review.md. Verified candidate SHA256 cb77efdbc0230b0342b6285770b687a5af856170776940559a0f079f9a002b72. Publication authorized on 4 October 2026; the release tag identifies the final package. Windows models already cached; no fresh download or full benchmark repeated. New GitHub CI not yet run.</a:t>
             </a:r>
           </a:p>
         </p:txBody>
@@ -603,12 +598,7 @@
           <a:lstStyle xmlns:a="http://schemas.openxmlformats.org/drawingml/2006/main"/>
           <a:p xmlns:a="http://schemas.openxmlformats.org/drawingml/2006/main">
             <a:r>
-              <a:t>Final repository package includes the refined PPT, signed disclosure, demo link, setup instructions and evaluation artifacts. Release tag: PRISM_GENAI_HACKATHON_Y2026. Publication is verified as part of this delivery. The official submission form is a separate step.</a:t>
-            </a:r>
-          </a:p>
-          <a:p xmlns:a="http://schemas.openxmlformats.org/drawingml/2006/main">
-            <a:r>
-              <a:t>Sources: https://github.com/SinghDevansh-2006/prism-code-intelligence/tree/030e29f6133f0ff0ea138243891c886fcff5a039; user-provided final submission form and team confirmations, 30 September 2026.</a:t>
+              <a:t>Local sources: README.md; docs/review/windows-recheck.json; docs/review/mteb-uniform-result.json; docs/windows-review.md. Verified candidate SHA256 cb77efdbc0230b0342b6285770b687a5af856170776940559a0f079f9a002b72. Publication authorized on 4 October 2026; the release tag identifies the final package.</a:t>
             </a:r>
           </a:p>
         </p:txBody>
@@ -678,12 +668,7 @@
           <a:lstStyle xmlns:a="http://schemas.openxmlformats.org/drawingml/2006/main"/>
           <a:p xmlns:a="http://schemas.openxmlformats.org/drawingml/2006/main">
             <a:r>
-              <a:t>Team members and contact emails on cover. Public repo and demo are active hyperlinks.</a:t>
-            </a:r>
-          </a:p>
-          <a:p xmlns:a="http://schemas.openxmlformats.org/drawingml/2006/main">
-            <a:r>
-              <a:t>Sources: https://github.com/SinghDevansh-2006/prism-code-intelligence/tree/030e29f6133f0ff0ea138243891c886fcff5a039; user-provided final submission form and team confirmations, 30 September 2026.</a:t>
+              <a:t>Local sources: README.md; docs/review/windows-recheck.json; docs/review/mteb-uniform-result.json; docs/windows-review.md. Verified candidate SHA256 cb77efdbc0230b0342b6285770b687a5af856170776940559a0f079f9a002b72. Publication authorized on 4 October 2026; the release tag identifies the final package. Final video URL supplied by the team; duration confirmed as 4 minutes 49 seconds. Screenshot shows the current local build.</a:t>
             </a:r>
           </a:p>
         </p:txBody>
@@ -903,12 +888,7 @@
           <a:lstStyle xmlns:a="http://schemas.openxmlformats.org/drawingml/2006/main"/>
           <a:p xmlns:a="http://schemas.openxmlformats.org/drawingml/2006/main">
             <a:r>
-              <a:t>Semantic algorithm: normalized query vectors dotted with stored normalized document embeddings. Each model score distribution is z-normalized per query: z=(s-mean(s))/(std(s)+1e-8). Fusion F=0.65*zGemma+0.35*zQwen. NumPy argsort(-F) establishes ranking. Reranker disabled by default. Routes are alternatives, not a four-way fusion. Structural order is static, not runtime proof. Evolution uses a controlled synthetic fixture. Source: src/retriever.py, query_router.py, agentic_engine.py, versioned_retriever.py.</a:t>
-            </a:r>
-          </a:p>
-          <a:p xmlns:a="http://schemas.openxmlformats.org/drawingml/2006/main">
-            <a:r>
-              <a:t>Sources: https://github.com/SinghDevansh-2006/prism-code-intelligence/tree/030e29f6133f0ff0ea138243891c886fcff5a039; user-provided final submission form and team confirmations, 30 September 2026.</a:t>
+              <a:t>Local sources: README.md; docs/review/windows-recheck.json; docs/review/mteb-uniform-result.json; docs/windows-review.md. Verified candidate SHA256 cb77efdbc0230b0342b6285770b687a5af856170776940559a0f079f9a002b72. Publication authorized on 4 October 2026; the release tag identifies the final package.</a:t>
             </a:r>
           </a:p>
         </p:txBody>
@@ -978,12 +958,7 @@
           <a:lstStyle xmlns:a="http://schemas.openxmlformats.org/drawingml/2006/main"/>
           <a:p xmlns:a="http://schemas.openxmlformats.org/drawingml/2006/main">
             <a:r>
-              <a:t>Video URL: https://drive.google.com/file/d/1Y7nbuiszgRgTFUJU7GKSjsI3tVVWGHv8/view?usp=sharing . Duration 3:30 reported by team lead. Drive landing page loads anonymously; full playback not independently reviewed. UI screenshot supplied directly by the team lead at full resolution. Manual query in proposed script: which files import collections? Version history is a controlled fixture.</a:t>
-            </a:r>
-          </a:p>
-          <a:p xmlns:a="http://schemas.openxmlformats.org/drawingml/2006/main">
-            <a:r>
-              <a:t>Sources: https://github.com/SinghDevansh-2006/prism-code-intelligence/tree/030e29f6133f0ff0ea138243891c886fcff5a039; user-provided final submission form and team confirmations, 30 September 2026.</a:t>
+              <a:t>Local sources: README.md; docs/review/windows-recheck.json; docs/review/mteb-uniform-result.json; docs/windows-review.md. Verified candidate SHA256 cb77efdbc0230b0342b6285770b687a5af856170776940559a0f079f9a002b72. Publication authorized on 4 October 2026; the release tag identifies the final package. Final video URL supplied by the team; duration confirmed as 4 minutes 49 seconds. Screenshot shows the current local build.</a:t>
             </a:r>
           </a:p>
         </p:txBody>
@@ -1053,12 +1028,7 @@
           <a:lstStyle xmlns:a="http://schemas.openxmlformats.org/drawingml/2006/main"/>
           <a:p xmlns:a="http://schemas.openxmlformats.org/drawingml/2006/main">
             <a:r>
-              <a:t>Default semantic weights: 65% Gemma, 35% Qwen. Optional mixedbread-ai/mxbai-rerank-xsmall-v1 is disabled by default. Global AST fusion was also evaluated; AST is routed for specific questions in final application. Exact dependency pins in requirements.txt.</a:t>
-            </a:r>
-          </a:p>
-          <a:p xmlns:a="http://schemas.openxmlformats.org/drawingml/2006/main">
-            <a:r>
-              <a:t>Sources: https://github.com/SinghDevansh-2006/prism-code-intelligence/tree/030e29f6133f0ff0ea138243891c886fcff5a039; user-provided final submission form and team confirmations, 30 September 2026.</a:t>
+              <a:t>Local sources: README.md; docs/review/windows-recheck.json; docs/review/mteb-uniform-result.json; docs/windows-review.md. Verified candidate SHA256 cb77efdbc0230b0342b6285770b687a5af856170776940559a0f079f9a002b72. Publication authorized on 4 October 2026; the release tag identifies the final package.</a:t>
             </a:r>
           </a:p>
         </p:txBody>
@@ -1128,12 +1098,7 @@
           <a:lstStyle xmlns:a="http://schemas.openxmlformats.org/drawingml/2006/main"/>
           <a:p xmlns:a="http://schemas.openxmlformats.org/drawingml/2006/main">
             <a:r>
-              <a:t>Local CPU tests passed all four routes in earlier testing. User confirms Windows operation; precise Windows hardware, test scope and clean-cache model download procedure were not supplied. No quantified time-savings or performance guarantee.</a:t>
-            </a:r>
-          </a:p>
-          <a:p xmlns:a="http://schemas.openxmlformats.org/drawingml/2006/main">
-            <a:r>
-              <a:t>Sources: https://github.com/SinghDevansh-2006/prism-code-intelligence/tree/030e29f6133f0ff0ea138243891c886fcff5a039; user-provided final submission form and team confirmations, 30 September 2026.</a:t>
+              <a:t>Local sources: README.md; docs/review/windows-recheck.json; docs/review/mteb-uniform-result.json; docs/windows-review.md. Verified candidate SHA256 cb77efdbc0230b0342b6285770b687a5af856170776940559a0f079f9a002b72. Publication authorized on 4 October 2026; the release tag identifies the final package.</a:t>
             </a:r>
           </a:p>
         </p:txBody>
@@ -1203,12 +1168,7 @@
           <a:lstStyle xmlns:a="http://schemas.openxmlformats.org/drawingml/2006/main"/>
           <a:p xmlns:a="http://schemas.openxmlformats.org/drawingml/2006/main">
             <a:r>
-              <a:t>Canonical test metrics from exact saved ranking order: NDCG@10 .853100; MRR@10 .821803; MRR@100 .824138; Recall@10 .949535; Recall@20 .973440; Recall@100 .993625. Saved rankings SHA256 519fe7b0ad8bb4ae80f1da5192ceea067bc1c68b74cad6328ee7ac8a2de644d4. MTEB export re-evaluates saved rankings using ordinal scores, not fresh end-to-end inference. Results do not measure AST, routing, evolution or runtime-demo accuracy. Private validation values are separate. Source: README, submission/, verify_submission.py. No benchmark score changed for this presentation.</a:t>
-            </a:r>
-          </a:p>
-          <a:p xmlns:a="http://schemas.openxmlformats.org/drawingml/2006/main">
-            <a:r>
-              <a:t>Sources: https://github.com/SinghDevansh-2006/prism-code-intelligence/tree/030e29f6133f0ff0ea138243891c886fcff5a039; user-provided final submission form and team confirmations, 30 September 2026.</a:t>
+              <a:t>Local sources: README.md; docs/review/windows-recheck.json; docs/review/mteb-uniform-result.json; docs/windows-review.md. Verified candidate SHA256 cb77efdbc0230b0342b6285770b687a5af856170776940559a0f079f9a002b72. Publication authorized on 4 October 2026; the release tag identifies the final package. Frozen submission scores retained. Separate corrected CPU evaluation: NDCG@10 0.853220; MRR@10 0.8220444149328615; MRR@100 0.8243958749403522; Recall@10 0.94927 versus frozen 0.94953519. Small numerical changes are not a new algorithmic improvement. Dense retrieval only; private validation remains separate.</a:t>
             </a:r>
           </a:p>
         </p:txBody>
@@ -1278,12 +1238,7 @@
           <a:lstStyle xmlns:a="http://schemas.openxmlformats.org/drawingml/2006/main"/>
           <a:p xmlns:a="http://schemas.openxmlformats.org/drawingml/2006/main">
             <a:r>
-              <a:t>User reports application runs on Windows. This does not establish all gated-model downloads from a fresh cache or full benchmark regeneration. Keep uncompleted work clearly separate from implemented features.</a:t>
-            </a:r>
-          </a:p>
-          <a:p xmlns:a="http://schemas.openxmlformats.org/drawingml/2006/main">
-            <a:r>
-              <a:t>Sources: https://github.com/SinghDevansh-2006/prism-code-intelligence/tree/030e29f6133f0ff0ea138243891c886fcff5a039; user-provided final submission form and team confirmations, 30 September 2026.</a:t>
+              <a:t>Local sources: README.md; docs/review/windows-recheck.json; docs/review/mteb-uniform-result.json; docs/windows-review.md. Verified candidate SHA256 cb77efdbc0230b0342b6285770b687a5af856170776940559a0f079f9a002b72. Publication authorized on 4 October 2026; the release tag identifies the final package.</a:t>
             </a:r>
           </a:p>
         </p:txBody>
@@ -1351,7 +1306,7 @@
   </p:cSld>
   <p:clrMap bg1="lt1" tx1="dk1" bg2="lt2" tx2="dk2" accent1="accent1" accent2="accent2" accent3="accent3" accent4="accent4" accent5="accent5" accent6="accent6" hlink="hlink" folHlink="folHlink"/>
   <p:sldLayoutIdLst>
-    <p:sldLayoutId xmlns:r="http://schemas.openxmlformats.org/officeDocument/2006/relationships" id="2147483649" r:id="R44ba65dfb7b34c5c"/>
+    <p:sldLayoutId xmlns:r="http://schemas.openxmlformats.org/officeDocument/2006/relationships" id="2147483649" r:id="Rb08826be3b074a18"/>
   </p:sldLayoutIdLst>
   <p:txStyles>
     <p:titleStyle>
@@ -1931,6 +1886,7 @@
           <a:lstStyle xmlns:a="http://schemas.openxmlformats.org/drawingml/2006/main"/>
           <a:p xmlns:a="http://schemas.openxmlformats.org/drawingml/2006/main">
             <a:pPr>
+              <a:buNone/>
               <a:defRPr sz="2025" b="1">
                 <a:solidFill>
                   <a:srgbClr val="714CB0"/>
@@ -1988,6 +1944,7 @@
           <a:lstStyle xmlns:a="http://schemas.openxmlformats.org/drawingml/2006/main"/>
           <a:p xmlns:a="http://schemas.openxmlformats.org/drawingml/2006/main">
             <a:pPr>
+              <a:buNone/>
               <a:defRPr sz="3600" b="1">
                 <a:solidFill>
                   <a:srgbClr val="1A1830"/>
@@ -2045,6 +2002,7 @@
           <a:lstStyle xmlns:a="http://schemas.openxmlformats.org/drawingml/2006/main"/>
           <a:p xmlns:a="http://schemas.openxmlformats.org/drawingml/2006/main">
             <a:pPr>
+              <a:buNone/>
               <a:defRPr sz="2025" b="1">
                 <a:solidFill>
                   <a:srgbClr val="655E79"/>
@@ -2102,6 +2060,7 @@
           <a:lstStyle xmlns:a="http://schemas.openxmlformats.org/drawingml/2006/main"/>
           <a:p xmlns:a="http://schemas.openxmlformats.org/drawingml/2006/main">
             <a:pPr>
+              <a:buNone/>
               <a:defRPr sz="2550" b="1">
                 <a:solidFill>
                   <a:srgbClr val="714CB0"/>
@@ -2159,6 +2118,7 @@
           <a:lstStyle xmlns:a="http://schemas.openxmlformats.org/drawingml/2006/main"/>
           <a:p xmlns:a="http://schemas.openxmlformats.org/drawingml/2006/main">
             <a:pPr>
+              <a:buNone/>
               <a:defRPr sz="1875" b="0">
                 <a:solidFill>
                   <a:srgbClr val="1A1830"/>
@@ -2216,6 +2176,7 @@
           <a:lstStyle xmlns:a="http://schemas.openxmlformats.org/drawingml/2006/main"/>
           <a:p xmlns:a="http://schemas.openxmlformats.org/drawingml/2006/main">
             <a:pPr>
+              <a:buNone/>
               <a:defRPr sz="2025" b="1">
                 <a:solidFill>
                   <a:srgbClr val="714CB0"/>
@@ -2273,6 +2234,7 @@
           <a:lstStyle xmlns:a="http://schemas.openxmlformats.org/drawingml/2006/main"/>
           <a:p xmlns:a="http://schemas.openxmlformats.org/drawingml/2006/main">
             <a:pPr>
+              <a:buNone/>
               <a:defRPr sz="1875" b="0">
                 <a:solidFill>
                   <a:srgbClr val="1A1830"/>
@@ -2330,6 +2292,7 @@
           <a:lstStyle xmlns:a="http://schemas.openxmlformats.org/drawingml/2006/main"/>
           <a:p xmlns:a="http://schemas.openxmlformats.org/drawingml/2006/main">
             <a:pPr>
+              <a:buNone/>
               <a:defRPr sz="1575" b="0">
                 <a:solidFill>
                   <a:srgbClr val="1A1830"/>
@@ -2353,6 +2316,7 @@
           </a:p>
           <a:p xmlns:a="http://schemas.openxmlformats.org/drawingml/2006/main">
             <a:pPr>
+              <a:buNone/>
               <a:defRPr sz="1575" b="0">
                 <a:solidFill>
                   <a:srgbClr val="1A1830"/>
@@ -2376,6 +2340,7 @@
           </a:p>
           <a:p xmlns:a="http://schemas.openxmlformats.org/drawingml/2006/main">
             <a:pPr>
+              <a:buNone/>
               <a:defRPr sz="1575" b="0">
                 <a:solidFill>
                   <a:srgbClr val="1A1830"/>
@@ -2399,6 +2364,7 @@
           </a:p>
           <a:p xmlns:a="http://schemas.openxmlformats.org/drawingml/2006/main">
             <a:pPr>
+              <a:buNone/>
               <a:defRPr sz="1575" b="0">
                 <a:solidFill>
                   <a:srgbClr val="1A1830"/>
@@ -2424,14 +2390,14 @@
       </p:sp>
       <p:pic>
         <p:nvPicPr>
-          <p:cNvPr id="19" name=""/>
+          <p:cNvPr id="21" name=""/>
           <p:cNvPicPr>
             <a:picLocks xmlns:a="http://schemas.openxmlformats.org/drawingml/2006/main" noChangeAspect="1"/>
           </p:cNvPicPr>
           <p:nvPr/>
         </p:nvPicPr>
         <p:blipFill>
-          <a:blip xmlns:r="http://schemas.openxmlformats.org/officeDocument/2006/relationships" xmlns:a="http://schemas.openxmlformats.org/drawingml/2006/main" r:embed="Rf2d1595acdd9483b"/>
+          <a:blip xmlns:r="http://schemas.openxmlformats.org/officeDocument/2006/relationships" xmlns:a="http://schemas.openxmlformats.org/drawingml/2006/main" r:embed="Rc42c65363a994a21"/>
           <a:stretch xmlns:a="http://schemas.openxmlformats.org/drawingml/2006/main"/>
         </p:blipFill>
         <p:spPr>
@@ -2478,6 +2444,7 @@
           <a:lstStyle xmlns:a="http://schemas.openxmlformats.org/drawingml/2006/main"/>
           <a:p xmlns:a="http://schemas.openxmlformats.org/drawingml/2006/main">
             <a:pPr>
+              <a:buNone/>
               <a:defRPr sz="1650" b="0">
                 <a:solidFill>
                   <a:srgbClr val="714CB0"/>
@@ -2495,7 +2462,7 @@
                 <a:latin typeface="Arial"/>
                 <a:ea typeface="Arial"/>
                 <a:cs typeface="Arial"/>
-                <a:hlinkClick xmlns:r="http://schemas.openxmlformats.org/officeDocument/2006/relationships" r:id="R19582bebfc804d67"/>
+                <a:hlinkClick xmlns:r="http://schemas.openxmlformats.org/officeDocument/2006/relationships" r:id="R24879dcc8de64e03"/>
               </a:rPr>
               <a:t>Public GitHub repository</a:t>
             </a:r>
@@ -2565,6 +2532,7 @@
           <a:lstStyle xmlns:a="http://schemas.openxmlformats.org/drawingml/2006/main"/>
           <a:p xmlns:a="http://schemas.openxmlformats.org/drawingml/2006/main">
             <a:pPr>
+              <a:buNone/>
               <a:defRPr sz="3000" b="1">
                 <a:solidFill>
                   <a:srgbClr val="714CB0"/>
@@ -2622,6 +2590,7 @@
           <a:lstStyle xmlns:a="http://schemas.openxmlformats.org/drawingml/2006/main"/>
           <a:p xmlns:a="http://schemas.openxmlformats.org/drawingml/2006/main">
             <a:pPr>
+              <a:buNone/>
               <a:defRPr sz="1875" b="1">
                 <a:solidFill>
                   <a:srgbClr val="714CB0"/>
@@ -2679,6 +2648,7 @@
           <a:lstStyle xmlns:a="http://schemas.openxmlformats.org/drawingml/2006/main"/>
           <a:p xmlns:a="http://schemas.openxmlformats.org/drawingml/2006/main">
             <a:pPr>
+              <a:buNone/>
               <a:defRPr sz="1875" b="0">
                 <a:solidFill>
                   <a:srgbClr val="1A1830"/>
@@ -2766,6 +2736,7 @@
           <a:lstStyle xmlns:a="http://schemas.openxmlformats.org/drawingml/2006/main"/>
           <a:p xmlns:a="http://schemas.openxmlformats.org/drawingml/2006/main">
             <a:pPr>
+              <a:buNone/>
               <a:defRPr sz="1875" b="1">
                 <a:solidFill>
                   <a:srgbClr val="714CB0"/>
@@ -2823,6 +2794,7 @@
           <a:lstStyle xmlns:a="http://schemas.openxmlformats.org/drawingml/2006/main"/>
           <a:p xmlns:a="http://schemas.openxmlformats.org/drawingml/2006/main">
             <a:pPr>
+              <a:buNone/>
               <a:defRPr sz="1875" b="0">
                 <a:solidFill>
                   <a:srgbClr val="1A1830"/>
@@ -2910,6 +2882,7 @@
           <a:lstStyle xmlns:a="http://schemas.openxmlformats.org/drawingml/2006/main"/>
           <a:p xmlns:a="http://schemas.openxmlformats.org/drawingml/2006/main">
             <a:pPr>
+              <a:buNone/>
               <a:defRPr sz="1875" b="1">
                 <a:solidFill>
                   <a:srgbClr val="714CB0"/>
@@ -2967,6 +2940,7 @@
           <a:lstStyle xmlns:a="http://schemas.openxmlformats.org/drawingml/2006/main"/>
           <a:p xmlns:a="http://schemas.openxmlformats.org/drawingml/2006/main">
             <a:pPr>
+              <a:buNone/>
               <a:defRPr sz="1875" b="0">
                 <a:solidFill>
                   <a:srgbClr val="1A1830"/>
@@ -2985,7 +2959,7 @@
                 <a:ea typeface="Arial"/>
                 <a:cs typeface="Arial"/>
               </a:rPr>
-              <a:t>Source evidence and stored-version lineage.</a:t>
+              <a:t>Source-line evidence, real Git lineage and snapshot filters.</a:t>
             </a:r>
           </a:p>
         </p:txBody>
@@ -3054,6 +3028,7 @@
           <a:lstStyle xmlns:a="http://schemas.openxmlformats.org/drawingml/2006/main"/>
           <a:p xmlns:a="http://schemas.openxmlformats.org/drawingml/2006/main">
             <a:pPr>
+              <a:buNone/>
               <a:defRPr sz="1875" b="1">
                 <a:solidFill>
                   <a:srgbClr val="714CB0"/>
@@ -3111,6 +3086,7 @@
           <a:lstStyle xmlns:a="http://schemas.openxmlformats.org/drawingml/2006/main"/>
           <a:p xmlns:a="http://schemas.openxmlformats.org/drawingml/2006/main">
             <a:pPr>
+              <a:buNone/>
               <a:defRPr sz="1875" b="0">
                 <a:solidFill>
                   <a:srgbClr val="1A1830"/>
@@ -3129,7 +3105,7 @@
                 <a:ea typeface="Arial"/>
                 <a:cs typeface="Arial"/>
               </a:rPr>
-              <a:t>Linux container CI passed. The team also confirms Windows operation.</a:t>
+              <a:t>Windows CPU: 23/23 tests and all four routes passed. Python 3.11; cached models.</a:t>
             </a:r>
           </a:p>
         </p:txBody>
@@ -3227,6 +3203,7 @@
           <a:lstStyle xmlns:a="http://schemas.openxmlformats.org/drawingml/2006/main"/>
           <a:p xmlns:a="http://schemas.openxmlformats.org/drawingml/2006/main">
             <a:pPr>
+              <a:buNone/>
               <a:defRPr sz="2925" b="1">
                 <a:solidFill>
                   <a:srgbClr val="714CB0"/>
@@ -3252,7 +3229,7 @@
       </p:sp>
       <p:graphicFrame>
         <p:nvGraphicFramePr>
-          <p:cNvPr id="6" name=""/>
+          <p:cNvPr id="8" name=""/>
           <p:cNvGraphicFramePr/>
           <p:nvPr/>
         </p:nvGraphicFramePr>
@@ -3357,7 +3334,7 @@
                           <a:ea typeface="Arial"/>
                           <a:cs typeface="Arial"/>
                         </a:rPr>
-                        <a:t>Present in public GitHub repository</a:t>
+                        <a:t>Source, requirements and verified runtime indexes</a:t>
                       </a:r>
                     </a:p>
                   </a:txBody>
@@ -3407,7 +3384,7 @@
                           <a:ea typeface="Arial"/>
                           <a:cs typeface="Arial"/>
                         </a:rPr>
-                        <a:t>Published with setup and submission links</a:t>
+                        <a:t>Setup, Docker and verification instructions</a:t>
                       </a:r>
                     </a:p>
                   </a:txBody>
@@ -3457,7 +3434,7 @@
                           <a:ea typeface="Arial"/>
                           <a:cs typeface="Arial"/>
                         </a:rPr>
-                        <a:t>Final refined PPT published in repository</a:t>
+                        <a:t>Final presentation included in repository</a:t>
                       </a:r>
                     </a:p>
                   </a:txBody>
@@ -3507,7 +3484,7 @@
                           <a:ea typeface="Arial"/>
                           <a:cs typeface="Arial"/>
                         </a:rPr>
-                        <a:t>3:30 demo linked in README</a:t>
+                        <a:t>4:49 demo linked in README and presentation</a:t>
                       </a:r>
                     </a:p>
                   </a:txBody>
@@ -3557,7 +3534,7 @@
                           <a:ea typeface="Arial"/>
                           <a:cs typeface="Arial"/>
                         </a:rPr>
-                        <a:t>Signed disclosure published in repository</a:t>
+                        <a:t>Signed disclosure included in DOCX and PDF</a:t>
                       </a:r>
                     </a:p>
                   </a:txBody>
@@ -3607,7 +3584,7 @@
                           <a:ea typeface="Arial"/>
                           <a:cs typeface="Arial"/>
                         </a:rPr>
-                        <a:t>Published with evaluation JSON assets</a:t>
+                        <a:t>Required tag identifies the final submission</a:t>
                       </a:r>
                     </a:p>
                   </a:txBody>
@@ -3706,6 +3683,7 @@
           <a:lstStyle xmlns:a="http://schemas.openxmlformats.org/drawingml/2006/main"/>
           <a:p xmlns:a="http://schemas.openxmlformats.org/drawingml/2006/main">
             <a:pPr>
+              <a:buNone/>
               <a:defRPr sz="1950" b="1">
                 <a:solidFill>
                   <a:srgbClr val="714CB0"/>
@@ -3763,6 +3741,7 @@
           <a:lstStyle xmlns:a="http://schemas.openxmlformats.org/drawingml/2006/main"/>
           <a:p xmlns:a="http://schemas.openxmlformats.org/drawingml/2006/main">
             <a:pPr>
+              <a:buNone/>
               <a:defRPr sz="1725" b="0">
                 <a:solidFill>
                   <a:srgbClr val="655E79"/>
@@ -3781,7 +3760,7 @@
                 <a:ea typeface="Arial"/>
                 <a:cs typeface="Arial"/>
               </a:rPr>
-              <a:t>Repository submission package complete: 30 September 2026</a:t>
+              <a:t>Final submission package · Updated 4 October 2026</a:t>
             </a:r>
           </a:p>
         </p:txBody>
@@ -3849,6 +3828,7 @@
           <a:lstStyle xmlns:a="http://schemas.openxmlformats.org/drawingml/2006/main"/>
           <a:p xmlns:a="http://schemas.openxmlformats.org/drawingml/2006/main">
             <a:pPr>
+              <a:buNone/>
               <a:defRPr sz="3150" b="1">
                 <a:solidFill>
                   <a:srgbClr val="714CB0"/>
@@ -3906,6 +3886,7 @@
           <a:lstStyle xmlns:a="http://schemas.openxmlformats.org/drawingml/2006/main"/>
           <a:p xmlns:a="http://schemas.openxmlformats.org/drawingml/2006/main">
             <a:pPr>
+              <a:buNone/>
               <a:defRPr sz="2100" b="0">
                 <a:solidFill>
                   <a:srgbClr val="1A1830"/>
@@ -3963,6 +3944,7 @@
           <a:lstStyle xmlns:a="http://schemas.openxmlformats.org/drawingml/2006/main"/>
           <a:p xmlns:a="http://schemas.openxmlformats.org/drawingml/2006/main">
             <a:pPr>
+              <a:buNone/>
               <a:defRPr sz="2250" b="1">
                 <a:solidFill>
                   <a:srgbClr val="714CB0"/>
@@ -4020,6 +4002,7 @@
           <a:lstStyle xmlns:a="http://schemas.openxmlformats.org/drawingml/2006/main"/>
           <a:p xmlns:a="http://schemas.openxmlformats.org/drawingml/2006/main">
             <a:pPr>
+              <a:buNone/>
               <a:defRPr sz="2025" b="0">
                 <a:solidFill>
                   <a:srgbClr val="1A1830"/>
@@ -4077,6 +4060,7 @@
           <a:lstStyle xmlns:a="http://schemas.openxmlformats.org/drawingml/2006/main"/>
           <a:p xmlns:a="http://schemas.openxmlformats.org/drawingml/2006/main">
             <a:pPr>
+              <a:buNone/>
               <a:defRPr sz="4875" b="1">
                 <a:solidFill>
                   <a:srgbClr val="1A1830"/>
@@ -4134,6 +4118,7 @@
           <a:lstStyle xmlns:a="http://schemas.openxmlformats.org/drawingml/2006/main"/>
           <a:p xmlns:a="http://schemas.openxmlformats.org/drawingml/2006/main">
             <a:pPr>
+              <a:buNone/>
               <a:defRPr sz="1875" b="0">
                 <a:solidFill>
                   <a:srgbClr val="714CB0"/>
@@ -4151,7 +4136,7 @@
                 <a:latin typeface="Arial"/>
                 <a:ea typeface="Arial"/>
                 <a:cs typeface="Arial"/>
-                <a:hlinkClick xmlns:r="http://schemas.openxmlformats.org/officeDocument/2006/relationships" r:id="R4a631a7d9fe54808"/>
+                <a:hlinkClick xmlns:r="http://schemas.openxmlformats.org/officeDocument/2006/relationships" r:id="Raf0dbb0a0524448f"/>
               </a:rPr>
               <a:t>View the public GitHub repository</a:t>
             </a:r>
@@ -4192,6 +4177,7 @@
           <a:lstStyle xmlns:a="http://schemas.openxmlformats.org/drawingml/2006/main"/>
           <a:p xmlns:a="http://schemas.openxmlformats.org/drawingml/2006/main">
             <a:pPr>
+              <a:buNone/>
               <a:defRPr sz="1875" b="0">
                 <a:solidFill>
                   <a:srgbClr val="714CB0"/>
@@ -4209,9 +4195,9 @@
                 <a:latin typeface="Arial"/>
                 <a:ea typeface="Arial"/>
                 <a:cs typeface="Arial"/>
-                <a:hlinkClick xmlns:r="http://schemas.openxmlformats.org/officeDocument/2006/relationships" r:id="Rcb83ac9c518e4eda"/>
-              </a:rPr>
-              <a:t>Watch our 3:30 demo</a:t>
+                <a:hlinkClick xmlns:r="http://schemas.openxmlformats.org/officeDocument/2006/relationships" r:id="R4addf0c14e6a4291"/>
+              </a:rPr>
+              <a:t>Watch our 4:49 demo</a:t>
             </a:r>
           </a:p>
         </p:txBody>
@@ -4250,6 +4236,7 @@
           <a:lstStyle xmlns:a="http://schemas.openxmlformats.org/drawingml/2006/main"/>
           <a:p xmlns:a="http://schemas.openxmlformats.org/drawingml/2006/main">
             <a:pPr>
+              <a:buNone/>
               <a:defRPr sz="1350" b="0">
                 <a:solidFill>
                   <a:srgbClr val="655E79"/>
@@ -4336,6 +4323,7 @@
           <a:lstStyle xmlns:a="http://schemas.openxmlformats.org/drawingml/2006/main"/>
           <a:p xmlns:a="http://schemas.openxmlformats.org/drawingml/2006/main">
             <a:pPr>
+              <a:buNone/>
               <a:defRPr sz="3225" b="1">
                 <a:solidFill>
                   <a:srgbClr val="714CB0"/>
@@ -4393,6 +4381,7 @@
           <a:lstStyle xmlns:a="http://schemas.openxmlformats.org/drawingml/2006/main"/>
           <a:p xmlns:a="http://schemas.openxmlformats.org/drawingml/2006/main">
             <a:pPr>
+              <a:buNone/>
               <a:defRPr sz="2475" b="1">
                 <a:solidFill>
                   <a:srgbClr val="1A1830"/>
@@ -4450,6 +4439,7 @@
           <a:lstStyle xmlns:a="http://schemas.openxmlformats.org/drawingml/2006/main"/>
           <a:p xmlns:a="http://schemas.openxmlformats.org/drawingml/2006/main">
             <a:pPr>
+              <a:buNone/>
               <a:defRPr sz="2025" b="0">
                 <a:solidFill>
                   <a:srgbClr val="1A1830"/>
@@ -4507,6 +4497,7 @@
           <a:lstStyle xmlns:a="http://schemas.openxmlformats.org/drawingml/2006/main"/>
           <a:p xmlns:a="http://schemas.openxmlformats.org/drawingml/2006/main">
             <a:pPr>
+              <a:buNone/>
               <a:defRPr sz="1875" b="1">
                 <a:solidFill>
                   <a:srgbClr val="714CB0"/>
@@ -4564,6 +4555,7 @@
           <a:lstStyle xmlns:a="http://schemas.openxmlformats.org/drawingml/2006/main"/>
           <a:p xmlns:a="http://schemas.openxmlformats.org/drawingml/2006/main">
             <a:pPr>
+              <a:buNone/>
               <a:defRPr sz="1875" b="0">
                 <a:solidFill>
                   <a:srgbClr val="1A1830"/>
@@ -4651,6 +4643,7 @@
           <a:lstStyle xmlns:a="http://schemas.openxmlformats.org/drawingml/2006/main"/>
           <a:p xmlns:a="http://schemas.openxmlformats.org/drawingml/2006/main">
             <a:pPr>
+              <a:buNone/>
               <a:defRPr sz="1875" b="1">
                 <a:solidFill>
                   <a:srgbClr val="714CB0"/>
@@ -4708,6 +4701,7 @@
           <a:lstStyle xmlns:a="http://schemas.openxmlformats.org/drawingml/2006/main"/>
           <a:p xmlns:a="http://schemas.openxmlformats.org/drawingml/2006/main">
             <a:pPr>
+              <a:buNone/>
               <a:defRPr sz="1875" b="0">
                 <a:solidFill>
                   <a:srgbClr val="1A1830"/>
@@ -4795,6 +4789,7 @@
           <a:lstStyle xmlns:a="http://schemas.openxmlformats.org/drawingml/2006/main"/>
           <a:p xmlns:a="http://schemas.openxmlformats.org/drawingml/2006/main">
             <a:pPr>
+              <a:buNone/>
               <a:defRPr sz="1875" b="1">
                 <a:solidFill>
                   <a:srgbClr val="714CB0"/>
@@ -4852,6 +4847,7 @@
           <a:lstStyle xmlns:a="http://schemas.openxmlformats.org/drawingml/2006/main"/>
           <a:p xmlns:a="http://schemas.openxmlformats.org/drawingml/2006/main">
             <a:pPr>
+              <a:buNone/>
               <a:defRPr sz="1875" b="0">
                 <a:solidFill>
                   <a:srgbClr val="1A1830"/>
@@ -4939,6 +4935,7 @@
           <a:lstStyle xmlns:a="http://schemas.openxmlformats.org/drawingml/2006/main"/>
           <a:p xmlns:a="http://schemas.openxmlformats.org/drawingml/2006/main">
             <a:pPr>
+              <a:buNone/>
               <a:defRPr sz="1800" b="1">
                 <a:solidFill>
                   <a:srgbClr val="714CB0"/>
@@ -5025,6 +5022,7 @@
           <a:lstStyle xmlns:a="http://schemas.openxmlformats.org/drawingml/2006/main"/>
           <a:p xmlns:a="http://schemas.openxmlformats.org/drawingml/2006/main">
             <a:pPr>
+              <a:buNone/>
               <a:defRPr sz="3225" b="1">
                 <a:solidFill>
                   <a:srgbClr val="714CB0"/>
@@ -5050,7 +5048,7 @@
       </p:sp>
       <p:graphicFrame>
         <p:nvGraphicFramePr>
-          <p:cNvPr id="6" name=""/>
+          <p:cNvPr id="8" name=""/>
           <p:cNvGraphicFramePr/>
           <p:nvPr/>
         </p:nvGraphicFramePr>
@@ -5401,6 +5399,7 @@
           <a:lstStyle xmlns:a="http://schemas.openxmlformats.org/drawingml/2006/main"/>
           <a:p xmlns:a="http://schemas.openxmlformats.org/drawingml/2006/main">
             <a:pPr>
+              <a:buNone/>
               <a:defRPr sz="2100" b="1">
                 <a:solidFill>
                   <a:srgbClr val="714CB0"/>
@@ -5458,6 +5457,7 @@
           <a:lstStyle xmlns:a="http://schemas.openxmlformats.org/drawingml/2006/main"/>
           <a:p xmlns:a="http://schemas.openxmlformats.org/drawingml/2006/main">
             <a:pPr>
+              <a:buNone/>
               <a:defRPr sz="1575" b="0">
                 <a:solidFill>
                   <a:srgbClr val="655E79"/>
@@ -5544,6 +5544,7 @@
           <a:lstStyle xmlns:a="http://schemas.openxmlformats.org/drawingml/2006/main"/>
           <a:p xmlns:a="http://schemas.openxmlformats.org/drawingml/2006/main">
             <a:pPr>
+              <a:buNone/>
               <a:defRPr sz="2925" b="1">
                 <a:solidFill>
                   <a:srgbClr val="714CB0"/>
@@ -5607,6 +5608,7 @@
           <a:lstStyle xmlns:a="http://schemas.openxmlformats.org/drawingml/2006/main"/>
           <a:p xmlns:a="http://schemas.openxmlformats.org/drawingml/2006/main">
             <a:pPr algn="ctr">
+              <a:buNone/>
               <a:defRPr sz="1650" b="1">
                 <a:solidFill>
                   <a:srgbClr val="714CB0"/>
@@ -5670,6 +5672,7 @@
           <a:lstStyle xmlns:a="http://schemas.openxmlformats.org/drawingml/2006/main"/>
           <a:p xmlns:a="http://schemas.openxmlformats.org/drawingml/2006/main">
             <a:pPr algn="ctr">
+              <a:buNone/>
               <a:defRPr sz="1650" b="1">
                 <a:solidFill>
                   <a:srgbClr val="714CB0"/>
@@ -5695,7 +5698,7 @@
       </p:sp>
       <p:cxnSp>
         <p:nvCxnSpPr>
-          <p:cNvPr id="36" name=""/>
+          <p:cNvPr id="67" name=""/>
           <p:cNvCxnSpPr>
             <a:stCxn xmlns:a="http://schemas.openxmlformats.org/drawingml/2006/main" id="2" idx="3"/>
             <a:endCxn xmlns:a="http://schemas.openxmlformats.org/drawingml/2006/main" id="3" idx="1"/>
@@ -5752,6 +5755,7 @@
           <a:lstStyle xmlns:a="http://schemas.openxmlformats.org/drawingml/2006/main"/>
           <a:p xmlns:a="http://schemas.openxmlformats.org/drawingml/2006/main">
             <a:pPr>
+              <a:buNone/>
               <a:defRPr sz="1500" b="0">
                 <a:solidFill>
                   <a:srgbClr val="655E79"/>
@@ -5815,6 +5819,7 @@
           <a:lstStyle xmlns:a="http://schemas.openxmlformats.org/drawingml/2006/main"/>
           <a:p xmlns:a="http://schemas.openxmlformats.org/drawingml/2006/main">
             <a:pPr algn="ctr">
+              <a:buNone/>
               <a:defRPr sz="1650" b="1">
                 <a:solidFill>
                   <a:srgbClr val="714CB0"/>
@@ -5838,6 +5843,7 @@
           </a:p>
           <a:p xmlns:a="http://schemas.openxmlformats.org/drawingml/2006/main">
             <a:pPr algn="ctr">
+              <a:buNone/>
               <a:defRPr sz="1650" b="1">
                 <a:solidFill>
                   <a:srgbClr val="714CB0"/>
@@ -5901,6 +5907,7 @@
           <a:lstStyle xmlns:a="http://schemas.openxmlformats.org/drawingml/2006/main"/>
           <a:p xmlns:a="http://schemas.openxmlformats.org/drawingml/2006/main">
             <a:pPr algn="ctr">
+              <a:buNone/>
               <a:defRPr sz="1650" b="1">
                 <a:solidFill>
                   <a:srgbClr val="714CB0"/>
@@ -5924,6 +5931,7 @@
           </a:p>
           <a:p xmlns:a="http://schemas.openxmlformats.org/drawingml/2006/main">
             <a:pPr algn="ctr">
+              <a:buNone/>
               <a:defRPr sz="1650" b="1">
                 <a:solidFill>
                   <a:srgbClr val="714CB0"/>
@@ -5987,6 +5995,7 @@
           <a:lstStyle xmlns:a="http://schemas.openxmlformats.org/drawingml/2006/main"/>
           <a:p xmlns:a="http://schemas.openxmlformats.org/drawingml/2006/main">
             <a:pPr algn="ctr">
+              <a:buNone/>
               <a:defRPr sz="1650" b="1">
                 <a:solidFill>
                   <a:srgbClr val="714CB0"/>
@@ -6010,6 +6019,7 @@
           </a:p>
           <a:p xmlns:a="http://schemas.openxmlformats.org/drawingml/2006/main">
             <a:pPr algn="ctr">
+              <a:buNone/>
               <a:defRPr sz="1650" b="1">
                 <a:solidFill>
                   <a:srgbClr val="714CB0"/>
@@ -6073,6 +6083,7 @@
           <a:lstStyle xmlns:a="http://schemas.openxmlformats.org/drawingml/2006/main"/>
           <a:p xmlns:a="http://schemas.openxmlformats.org/drawingml/2006/main">
             <a:pPr algn="ctr">
+              <a:buNone/>
               <a:defRPr sz="1650" b="1">
                 <a:solidFill>
                   <a:srgbClr val="714CB0"/>
@@ -6096,6 +6107,7 @@
           </a:p>
           <a:p xmlns:a="http://schemas.openxmlformats.org/drawingml/2006/main">
             <a:pPr algn="ctr">
+              <a:buNone/>
               <a:defRPr sz="1650" b="1">
                 <a:solidFill>
                   <a:srgbClr val="714CB0"/>
@@ -6114,14 +6126,14 @@
                 <a:ea typeface="Arial"/>
                 <a:cs typeface="Arial"/>
               </a:rPr>
-              <a:t>Stored versions</a:t>
+              <a:t>Git snapshots</a:t>
             </a:r>
           </a:p>
         </p:txBody>
       </p:sp>
       <p:cxnSp>
         <p:nvCxnSpPr>
-          <p:cNvPr id="42" name=""/>
+          <p:cNvPr id="73" name=""/>
           <p:cNvCxnSpPr>
             <a:stCxn xmlns:a="http://schemas.openxmlformats.org/drawingml/2006/main" id="3" idx="2"/>
             <a:endCxn xmlns:a="http://schemas.openxmlformats.org/drawingml/2006/main" id="6" idx="0"/>
@@ -6149,7 +6161,7 @@
       </p:cxnSp>
       <p:cxnSp>
         <p:nvCxnSpPr>
-          <p:cNvPr id="43" name=""/>
+          <p:cNvPr id="74" name=""/>
           <p:cNvCxnSpPr>
             <a:stCxn xmlns:a="http://schemas.openxmlformats.org/drawingml/2006/main" id="3" idx="2"/>
             <a:endCxn xmlns:a="http://schemas.openxmlformats.org/drawingml/2006/main" id="7" idx="0"/>
@@ -6177,7 +6189,7 @@
       </p:cxnSp>
       <p:cxnSp>
         <p:nvCxnSpPr>
-          <p:cNvPr id="44" name=""/>
+          <p:cNvPr id="75" name=""/>
           <p:cNvCxnSpPr>
             <a:stCxn xmlns:a="http://schemas.openxmlformats.org/drawingml/2006/main" id="3" idx="2"/>
             <a:endCxn xmlns:a="http://schemas.openxmlformats.org/drawingml/2006/main" id="8" idx="0"/>
@@ -6205,7 +6217,7 @@
       </p:cxnSp>
       <p:cxnSp>
         <p:nvCxnSpPr>
-          <p:cNvPr id="45" name=""/>
+          <p:cNvPr id="76" name=""/>
           <p:cNvCxnSpPr>
             <a:stCxn xmlns:a="http://schemas.openxmlformats.org/drawingml/2006/main" id="3" idx="2"/>
             <a:endCxn xmlns:a="http://schemas.openxmlformats.org/drawingml/2006/main" id="9" idx="0"/>
@@ -6271,6 +6283,7 @@
           <a:lstStyle xmlns:a="http://schemas.openxmlformats.org/drawingml/2006/main"/>
           <a:p xmlns:a="http://schemas.openxmlformats.org/drawingml/2006/main">
             <a:pPr algn="ctr">
+              <a:buNone/>
               <a:defRPr sz="1425" b="1">
                 <a:solidFill>
                   <a:srgbClr val="714CB0"/>
@@ -6294,6 +6307,7 @@
           </a:p>
           <a:p xmlns:a="http://schemas.openxmlformats.org/drawingml/2006/main">
             <a:pPr algn="ctr">
+              <a:buNone/>
               <a:defRPr sz="1425" b="1">
                 <a:solidFill>
                   <a:srgbClr val="714CB0"/>
@@ -6357,6 +6371,7 @@
           <a:lstStyle xmlns:a="http://schemas.openxmlformats.org/drawingml/2006/main"/>
           <a:p xmlns:a="http://schemas.openxmlformats.org/drawingml/2006/main">
             <a:pPr algn="ctr">
+              <a:buNone/>
               <a:defRPr sz="1425" b="1">
                 <a:solidFill>
                   <a:srgbClr val="714CB0"/>
@@ -6380,6 +6395,7 @@
           </a:p>
           <a:p xmlns:a="http://schemas.openxmlformats.org/drawingml/2006/main">
             <a:pPr algn="ctr">
+              <a:buNone/>
               <a:defRPr sz="1425" b="1">
                 <a:solidFill>
                   <a:srgbClr val="714CB0"/>
@@ -6405,7 +6421,7 @@
       </p:sp>
       <p:cxnSp>
         <p:nvCxnSpPr>
-          <p:cNvPr id="48" name=""/>
+          <p:cNvPr id="79" name=""/>
           <p:cNvCxnSpPr>
             <a:stCxn xmlns:a="http://schemas.openxmlformats.org/drawingml/2006/main" id="6" idx="2"/>
             <a:endCxn xmlns:a="http://schemas.openxmlformats.org/drawingml/2006/main" id="14" idx="0"/>
@@ -6433,7 +6449,7 @@
       </p:cxnSp>
       <p:cxnSp>
         <p:nvCxnSpPr>
-          <p:cNvPr id="49" name=""/>
+          <p:cNvPr id="80" name=""/>
           <p:cNvCxnSpPr>
             <a:stCxn xmlns:a="http://schemas.openxmlformats.org/drawingml/2006/main" id="6" idx="2"/>
             <a:endCxn xmlns:a="http://schemas.openxmlformats.org/drawingml/2006/main" id="15" idx="0"/>
@@ -6499,6 +6515,7 @@
           <a:lstStyle xmlns:a="http://schemas.openxmlformats.org/drawingml/2006/main"/>
           <a:p xmlns:a="http://schemas.openxmlformats.org/drawingml/2006/main">
             <a:pPr algn="ctr">
+              <a:buNone/>
               <a:defRPr sz="1500" b="1">
                 <a:solidFill>
                   <a:srgbClr val="FFFFFF"/>
@@ -6517,11 +6534,12 @@
                 <a:ea typeface="Arial"/>
                 <a:cs typeface="Arial"/>
               </a:rPr>
-              <a:t>Normalize and fuse scores</a:t>
+              <a:t>Z-score then 65/35 fusion</a:t>
             </a:r>
           </a:p>
           <a:p xmlns:a="http://schemas.openxmlformats.org/drawingml/2006/main">
             <a:pPr algn="ctr">
+              <a:buNone/>
               <a:defRPr sz="1500" b="1">
                 <a:solidFill>
                   <a:srgbClr val="FFFFFF"/>
@@ -6547,7 +6565,7 @@
       </p:sp>
       <p:cxnSp>
         <p:nvCxnSpPr>
-          <p:cNvPr id="51" name=""/>
+          <p:cNvPr id="82" name=""/>
           <p:cNvCxnSpPr>
             <a:stCxn xmlns:a="http://schemas.openxmlformats.org/drawingml/2006/main" id="14" idx="2"/>
             <a:endCxn xmlns:a="http://schemas.openxmlformats.org/drawingml/2006/main" id="18" idx="0"/>
@@ -6575,7 +6593,7 @@
       </p:cxnSp>
       <p:cxnSp>
         <p:nvCxnSpPr>
-          <p:cNvPr id="52" name=""/>
+          <p:cNvPr id="83" name=""/>
           <p:cNvCxnSpPr>
             <a:stCxn xmlns:a="http://schemas.openxmlformats.org/drawingml/2006/main" id="15" idx="2"/>
             <a:endCxn xmlns:a="http://schemas.openxmlformats.org/drawingml/2006/main" id="18" idx="0"/>
@@ -6641,6 +6659,7 @@
           <a:lstStyle xmlns:a="http://schemas.openxmlformats.org/drawingml/2006/main"/>
           <a:p xmlns:a="http://schemas.openxmlformats.org/drawingml/2006/main">
             <a:pPr algn="ctr">
+              <a:buNone/>
               <a:defRPr sz="1500" b="1">
                 <a:solidFill>
                   <a:srgbClr val="714CB0"/>
@@ -6664,6 +6683,7 @@
           </a:p>
           <a:p xmlns:a="http://schemas.openxmlformats.org/drawingml/2006/main">
             <a:pPr algn="ctr">
+              <a:buNone/>
               <a:defRPr sz="1500" b="1">
                 <a:solidFill>
                   <a:srgbClr val="714CB0"/>
@@ -6727,6 +6747,7 @@
           <a:lstStyle xmlns:a="http://schemas.openxmlformats.org/drawingml/2006/main"/>
           <a:p xmlns:a="http://schemas.openxmlformats.org/drawingml/2006/main">
             <a:pPr algn="ctr">
+              <a:buNone/>
               <a:defRPr sz="1500" b="1">
                 <a:solidFill>
                   <a:srgbClr val="714CB0"/>
@@ -6750,6 +6771,7 @@
           </a:p>
           <a:p xmlns:a="http://schemas.openxmlformats.org/drawingml/2006/main">
             <a:pPr algn="ctr">
+              <a:buNone/>
               <a:defRPr sz="1500" b="1">
                 <a:solidFill>
                   <a:srgbClr val="714CB0"/>
@@ -6813,6 +6835,7 @@
           <a:lstStyle xmlns:a="http://schemas.openxmlformats.org/drawingml/2006/main"/>
           <a:p xmlns:a="http://schemas.openxmlformats.org/drawingml/2006/main">
             <a:pPr algn="ctr">
+              <a:buNone/>
               <a:defRPr sz="1500" b="1">
                 <a:solidFill>
                   <a:srgbClr val="714CB0"/>
@@ -6836,6 +6859,7 @@
           </a:p>
           <a:p xmlns:a="http://schemas.openxmlformats.org/drawingml/2006/main">
             <a:pPr algn="ctr">
+              <a:buNone/>
               <a:defRPr sz="1500" b="1">
                 <a:solidFill>
                   <a:srgbClr val="714CB0"/>
@@ -6854,14 +6878,14 @@
                 <a:ea typeface="Arial"/>
                 <a:cs typeface="Arial"/>
               </a:rPr>
-              <a:t>Version lineage</a:t>
+              <a:t>Commit / path lineage</a:t>
             </a:r>
           </a:p>
         </p:txBody>
       </p:sp>
       <p:cxnSp>
         <p:nvCxnSpPr>
-          <p:cNvPr id="56" name=""/>
+          <p:cNvPr id="87" name=""/>
           <p:cNvCxnSpPr>
             <a:stCxn xmlns:a="http://schemas.openxmlformats.org/drawingml/2006/main" id="7" idx="2"/>
             <a:endCxn xmlns:a="http://schemas.openxmlformats.org/drawingml/2006/main" id="21" idx="0"/>
@@ -6886,7 +6910,7 @@
       </p:cxnSp>
       <p:cxnSp>
         <p:nvCxnSpPr>
-          <p:cNvPr id="57" name=""/>
+          <p:cNvPr id="88" name=""/>
           <p:cNvCxnSpPr>
             <a:stCxn xmlns:a="http://schemas.openxmlformats.org/drawingml/2006/main" id="8" idx="2"/>
             <a:endCxn xmlns:a="http://schemas.openxmlformats.org/drawingml/2006/main" id="22" idx="0"/>
@@ -6911,7 +6935,7 @@
       </p:cxnSp>
       <p:cxnSp>
         <p:nvCxnSpPr>
-          <p:cNvPr id="58" name=""/>
+          <p:cNvPr id="89" name=""/>
           <p:cNvCxnSpPr>
             <a:stCxn xmlns:a="http://schemas.openxmlformats.org/drawingml/2006/main" id="9" idx="2"/>
             <a:endCxn xmlns:a="http://schemas.openxmlformats.org/drawingml/2006/main" id="23" idx="0"/>
@@ -6974,6 +6998,7 @@
           <a:lstStyle xmlns:a="http://schemas.openxmlformats.org/drawingml/2006/main"/>
           <a:p xmlns:a="http://schemas.openxmlformats.org/drawingml/2006/main">
             <a:pPr algn="ctr">
+              <a:buNone/>
               <a:defRPr sz="1575" b="1">
                 <a:solidFill>
                   <a:srgbClr val="FFFFFF"/>
@@ -6999,7 +7024,7 @@
       </p:sp>
       <p:cxnSp>
         <p:nvCxnSpPr>
-          <p:cNvPr id="60" name=""/>
+          <p:cNvPr id="91" name=""/>
           <p:cNvCxnSpPr>
             <a:stCxn xmlns:a="http://schemas.openxmlformats.org/drawingml/2006/main" id="18" idx="3"/>
             <a:endCxn xmlns:a="http://schemas.openxmlformats.org/drawingml/2006/main" id="27" idx="1"/>
@@ -7026,7 +7051,7 @@
       </p:cxnSp>
       <p:cxnSp>
         <p:nvCxnSpPr>
-          <p:cNvPr id="61" name=""/>
+          <p:cNvPr id="92" name=""/>
           <p:cNvCxnSpPr>
             <a:stCxn xmlns:a="http://schemas.openxmlformats.org/drawingml/2006/main" id="21" idx="2"/>
             <a:endCxn xmlns:a="http://schemas.openxmlformats.org/drawingml/2006/main" id="27" idx="0"/>
@@ -7054,7 +7079,7 @@
       </p:cxnSp>
       <p:cxnSp>
         <p:nvCxnSpPr>
-          <p:cNvPr id="62" name=""/>
+          <p:cNvPr id="93" name=""/>
           <p:cNvCxnSpPr>
             <a:stCxn xmlns:a="http://schemas.openxmlformats.org/drawingml/2006/main" id="22" idx="2"/>
             <a:endCxn xmlns:a="http://schemas.openxmlformats.org/drawingml/2006/main" id="27" idx="0"/>
@@ -7079,7 +7104,7 @@
       </p:cxnSp>
       <p:cxnSp>
         <p:nvCxnSpPr>
-          <p:cNvPr id="63" name=""/>
+          <p:cNvPr id="94" name=""/>
           <p:cNvCxnSpPr>
             <a:stCxn xmlns:a="http://schemas.openxmlformats.org/drawingml/2006/main" id="23" idx="2"/>
             <a:endCxn xmlns:a="http://schemas.openxmlformats.org/drawingml/2006/main" id="27" idx="0"/>
@@ -7139,6 +7164,7 @@
           <a:lstStyle xmlns:a="http://schemas.openxmlformats.org/drawingml/2006/main"/>
           <a:p xmlns:a="http://schemas.openxmlformats.org/drawingml/2006/main">
             <a:pPr>
+              <a:buNone/>
               <a:defRPr sz="1500" b="0">
                 <a:solidFill>
                   <a:srgbClr val="655E79"/>
@@ -7157,7 +7183,7 @@
                 <a:ea typeface="Arial"/>
                 <a:cs typeface="Arial"/>
               </a:rPr>
-              <a:t>Precomputed document embeddings support semantic search. Both models read the full query.</a:t>
+              <a:t>Both models read the full query. Git scope: all versions, latest snapshot or selected commit.</a:t>
             </a:r>
           </a:p>
         </p:txBody>
@@ -7225,6 +7251,7 @@
           <a:lstStyle xmlns:a="http://schemas.openxmlformats.org/drawingml/2006/main"/>
           <a:p xmlns:a="http://schemas.openxmlformats.org/drawingml/2006/main">
             <a:pPr>
+              <a:buNone/>
               <a:defRPr sz="3225" b="1">
                 <a:solidFill>
                   <a:srgbClr val="714CB0"/>
@@ -7250,20 +7277,20 @@
       </p:sp>
       <p:pic>
         <p:nvPicPr>
-          <p:cNvPr id="15" name=""/>
+          <p:cNvPr id="17" name=""/>
           <p:cNvPicPr>
             <a:picLocks xmlns:a="http://schemas.openxmlformats.org/drawingml/2006/main" noChangeAspect="1"/>
           </p:cNvPicPr>
           <p:nvPr/>
         </p:nvPicPr>
         <p:blipFill>
-          <a:blip xmlns:r="http://schemas.openxmlformats.org/officeDocument/2006/relationships" xmlns:a="http://schemas.openxmlformats.org/drawingml/2006/main" r:embed="R3ebe87a0a2e043cb"/>
+          <a:blip xmlns:r="http://schemas.openxmlformats.org/officeDocument/2006/relationships" xmlns:a="http://schemas.openxmlformats.org/drawingml/2006/main" r:embed="Re16bd06eb5ad4649"/>
           <a:stretch xmlns:a="http://schemas.openxmlformats.org/drawingml/2006/main"/>
         </p:blipFill>
         <p:spPr>
           <a:xfrm xmlns:a="http://schemas.openxmlformats.org/drawingml/2006/main">
-            <a:off x="1122866" y="1466850"/>
-            <a:ext cx="6326768" cy="4095750"/>
+            <a:off x="762000" y="1381584"/>
+            <a:ext cx="7096125" cy="4952082"/>
           </a:xfrm>
           <a:prstGeom xmlns:a="http://schemas.openxmlformats.org/drawingml/2006/main" prst="rect">
             <a:avLst/>
@@ -7304,6 +7331,7 @@
           <a:lstStyle xmlns:a="http://schemas.openxmlformats.org/drawingml/2006/main"/>
           <a:p xmlns:a="http://schemas.openxmlformats.org/drawingml/2006/main">
             <a:pPr>
+              <a:buNone/>
               <a:defRPr sz="2100" b="1">
                 <a:solidFill>
                   <a:srgbClr val="714CB0"/>
@@ -7361,6 +7389,7 @@
           <a:lstStyle xmlns:a="http://schemas.openxmlformats.org/drawingml/2006/main"/>
           <a:p xmlns:a="http://schemas.openxmlformats.org/drawingml/2006/main">
             <a:pPr>
+              <a:buNone/>
               <a:defRPr sz="1800" b="1">
                 <a:solidFill>
                   <a:srgbClr val="714CB0"/>
@@ -7418,6 +7447,7 @@
           <a:lstStyle xmlns:a="http://schemas.openxmlformats.org/drawingml/2006/main"/>
           <a:p xmlns:a="http://schemas.openxmlformats.org/drawingml/2006/main">
             <a:pPr>
+              <a:buNone/>
               <a:defRPr sz="1650" b="0">
                 <a:solidFill>
                   <a:srgbClr val="1A1830"/>
@@ -7436,7 +7466,7 @@
                 <a:ea typeface="Arial"/>
                 <a:cs typeface="Arial"/>
               </a:rPr>
-              <a:t>Tic-tac-toe validation</a:t>
+              <a:t>Find a relevant validator</a:t>
             </a:r>
           </a:p>
         </p:txBody>
@@ -7475,6 +7505,7 @@
           <a:lstStyle xmlns:a="http://schemas.openxmlformats.org/drawingml/2006/main"/>
           <a:p xmlns:a="http://schemas.openxmlformats.org/drawingml/2006/main">
             <a:pPr>
+              <a:buNone/>
               <a:defRPr sz="1800" b="1">
                 <a:solidFill>
                   <a:srgbClr val="714CB0"/>
@@ -7532,6 +7563,7 @@
           <a:lstStyle xmlns:a="http://schemas.openxmlformats.org/drawingml/2006/main"/>
           <a:p xmlns:a="http://schemas.openxmlformats.org/drawingml/2006/main">
             <a:pPr>
+              <a:buNone/>
               <a:defRPr sz="1650" b="0">
                 <a:solidFill>
                   <a:srgbClr val="1A1830"/>
@@ -7589,6 +7621,7 @@
           <a:lstStyle xmlns:a="http://schemas.openxmlformats.org/drawingml/2006/main"/>
           <a:p xmlns:a="http://schemas.openxmlformats.org/drawingml/2006/main">
             <a:pPr>
+              <a:buNone/>
               <a:defRPr sz="1800" b="1">
                 <a:solidFill>
                   <a:srgbClr val="714CB0"/>
@@ -7646,6 +7679,7 @@
           <a:lstStyle xmlns:a="http://schemas.openxmlformats.org/drawingml/2006/main"/>
           <a:p xmlns:a="http://schemas.openxmlformats.org/drawingml/2006/main">
             <a:pPr>
+              <a:buNone/>
               <a:defRPr sz="1650" b="0">
                 <a:solidFill>
                   <a:srgbClr val="1A1830"/>
@@ -7703,6 +7737,7 @@
           <a:lstStyle xmlns:a="http://schemas.openxmlformats.org/drawingml/2006/main"/>
           <a:p xmlns:a="http://schemas.openxmlformats.org/drawingml/2006/main">
             <a:pPr>
+              <a:buNone/>
               <a:defRPr sz="1800" b="1">
                 <a:solidFill>
                   <a:srgbClr val="714CB0"/>
@@ -7760,6 +7795,7 @@
           <a:lstStyle xmlns:a="http://schemas.openxmlformats.org/drawingml/2006/main"/>
           <a:p xmlns:a="http://schemas.openxmlformats.org/drawingml/2006/main">
             <a:pPr>
+              <a:buNone/>
               <a:defRPr sz="1650" b="0">
                 <a:solidFill>
                   <a:srgbClr val="1A1830"/>
@@ -7778,7 +7814,7 @@
                 <a:ea typeface="Arial"/>
                 <a:cs typeface="Arial"/>
               </a:rPr>
-              <a:t>Binary-search history</a:t>
+              <a:t>Actual Git / API history</a:t>
             </a:r>
           </a:p>
         </p:txBody>
@@ -7799,8 +7835,8 @@
         </p:nvSpPr>
         <p:spPr>
           <a:xfrm xmlns:a="http://schemas.openxmlformats.org/drawingml/2006/main">
-            <a:off x="800100" y="5772150"/>
-            <a:ext cx="6667500" cy="400050"/>
+            <a:off x="8239125" y="5772150"/>
+            <a:ext cx="3143250" cy="400050"/>
           </a:xfrm>
           <a:prstGeom xmlns:a="http://schemas.openxmlformats.org/drawingml/2006/main" prst="rect">
             <a:avLst/>
@@ -7817,26 +7853,27 @@
           <a:lstStyle xmlns:a="http://schemas.openxmlformats.org/drawingml/2006/main"/>
           <a:p xmlns:a="http://schemas.openxmlformats.org/drawingml/2006/main">
             <a:pPr>
-              <a:defRPr sz="1875" b="0">
-                <a:solidFill>
-                  <a:srgbClr val="714CB0"/>
-                </a:solidFill>
-                <a:latin typeface="Arial"/>
-                <a:ea typeface="Arial"/>
-                <a:cs typeface="Arial"/>
-              </a:defRPr>
-            </a:pPr>
-            <a:r>
-              <a:rPr sz="1875" b="0">
-                <a:solidFill>
-                  <a:srgbClr val="714CB0"/>
-                </a:solidFill>
-                <a:latin typeface="Arial"/>
-                <a:ea typeface="Arial"/>
-                <a:cs typeface="Arial"/>
-                <a:hlinkClick xmlns:r="http://schemas.openxmlformats.org/officeDocument/2006/relationships" r:id="Rc7e0e929af6a4560"/>
-              </a:rPr>
-              <a:t>Watch the demo — 3:30</a:t>
+              <a:buNone/>
+              <a:defRPr sz="1725" b="0">
+                <a:solidFill>
+                  <a:srgbClr val="714CB0"/>
+                </a:solidFill>
+                <a:latin typeface="Arial"/>
+                <a:ea typeface="Arial"/>
+                <a:cs typeface="Arial"/>
+              </a:defRPr>
+            </a:pPr>
+            <a:r>
+              <a:rPr sz="1725" b="0">
+                <a:solidFill>
+                  <a:srgbClr val="714CB0"/>
+                </a:solidFill>
+                <a:latin typeface="Arial"/>
+                <a:ea typeface="Arial"/>
+                <a:cs typeface="Arial"/>
+                <a:hlinkClick xmlns:r="http://schemas.openxmlformats.org/officeDocument/2006/relationships" r:id="Rd4e57ce2eab84f44"/>
+              </a:rPr>
+              <a:t>Watch the demo — 4:49</a:t>
             </a:r>
           </a:p>
         </p:txBody>
@@ -7857,8 +7894,8 @@
         </p:nvSpPr>
         <p:spPr>
           <a:xfrm xmlns:a="http://schemas.openxmlformats.org/drawingml/2006/main">
-            <a:off x="800100" y="6191250"/>
-            <a:ext cx="10572750" cy="381000"/>
+            <a:off x="800100" y="6429375"/>
+            <a:ext cx="10572750" cy="285750"/>
           </a:xfrm>
           <a:prstGeom xmlns:a="http://schemas.openxmlformats.org/drawingml/2006/main" prst="rect">
             <a:avLst/>
@@ -7875,7 +7912,8 @@
           <a:lstStyle xmlns:a="http://schemas.openxmlformats.org/drawingml/2006/main"/>
           <a:p xmlns:a="http://schemas.openxmlformats.org/drawingml/2006/main">
             <a:pPr>
-              <a:defRPr sz="1575" b="0">
+              <a:buNone/>
+              <a:defRPr sz="1500" b="0">
                 <a:solidFill>
                   <a:srgbClr val="655E79"/>
                 </a:solidFill>
@@ -7885,7 +7923,7 @@
               </a:defRPr>
             </a:pPr>
             <a:r>
-              <a:rPr sz="1575" b="0">
+              <a:rPr sz="1500" b="0">
                 <a:solidFill>
                   <a:srgbClr val="655E79"/>
                 </a:solidFill>
@@ -7893,7 +7931,7 @@
                 <a:ea typeface="Arial"/>
                 <a:cs typeface="Arial"/>
               </a:rPr>
-              <a:t>Select a result to inspect its source and supporting evidence.</a:t>
+              <a:t>Current local UI · Actual Git history · 8,765-document code corpus</a:t>
             </a:r>
           </a:p>
         </p:txBody>
@@ -7961,6 +7999,7 @@
           <a:lstStyle xmlns:a="http://schemas.openxmlformats.org/drawingml/2006/main"/>
           <a:p xmlns:a="http://schemas.openxmlformats.org/drawingml/2006/main">
             <a:pPr>
+              <a:buNone/>
               <a:defRPr sz="3225" b="1">
                 <a:solidFill>
                   <a:srgbClr val="714CB0"/>
@@ -8018,6 +8057,7 @@
           <a:lstStyle xmlns:a="http://schemas.openxmlformats.org/drawingml/2006/main"/>
           <a:p xmlns:a="http://schemas.openxmlformats.org/drawingml/2006/main">
             <a:pPr>
+              <a:buNone/>
               <a:defRPr sz="1875" b="1">
                 <a:solidFill>
                   <a:srgbClr val="714CB0"/>
@@ -8075,6 +8115,7 @@
           <a:lstStyle xmlns:a="http://schemas.openxmlformats.org/drawingml/2006/main"/>
           <a:p xmlns:a="http://schemas.openxmlformats.org/drawingml/2006/main">
             <a:pPr>
+              <a:buNone/>
               <a:defRPr sz="1875" b="0">
                 <a:solidFill>
                   <a:srgbClr val="1A1830"/>
@@ -8098,6 +8139,7 @@
           </a:p>
           <a:p xmlns:a="http://schemas.openxmlformats.org/drawingml/2006/main">
             <a:pPr>
+              <a:buNone/>
               <a:defRPr sz="1875" b="0">
                 <a:solidFill>
                   <a:srgbClr val="1A1830"/>
@@ -8185,6 +8227,7 @@
           <a:lstStyle xmlns:a="http://schemas.openxmlformats.org/drawingml/2006/main"/>
           <a:p xmlns:a="http://schemas.openxmlformats.org/drawingml/2006/main">
             <a:pPr>
+              <a:buNone/>
               <a:defRPr sz="1875" b="1">
                 <a:solidFill>
                   <a:srgbClr val="714CB0"/>
@@ -8242,6 +8285,7 @@
           <a:lstStyle xmlns:a="http://schemas.openxmlformats.org/drawingml/2006/main"/>
           <a:p xmlns:a="http://schemas.openxmlformats.org/drawingml/2006/main">
             <a:pPr>
+              <a:buNone/>
               <a:defRPr sz="1875" b="0">
                 <a:solidFill>
                   <a:srgbClr val="1A1830"/>
@@ -8265,6 +8309,7 @@
           </a:p>
           <a:p xmlns:a="http://schemas.openxmlformats.org/drawingml/2006/main">
             <a:pPr>
+              <a:buNone/>
               <a:defRPr sz="1875" b="0">
                 <a:solidFill>
                   <a:srgbClr val="1A1830"/>
@@ -8352,6 +8397,7 @@
           <a:lstStyle xmlns:a="http://schemas.openxmlformats.org/drawingml/2006/main"/>
           <a:p xmlns:a="http://schemas.openxmlformats.org/drawingml/2006/main">
             <a:pPr>
+              <a:buNone/>
               <a:defRPr sz="1875" b="1">
                 <a:solidFill>
                   <a:srgbClr val="714CB0"/>
@@ -8409,6 +8455,7 @@
           <a:lstStyle xmlns:a="http://schemas.openxmlformats.org/drawingml/2006/main"/>
           <a:p xmlns:a="http://schemas.openxmlformats.org/drawingml/2006/main">
             <a:pPr>
+              <a:buNone/>
               <a:defRPr sz="1875" b="0">
                 <a:solidFill>
                   <a:srgbClr val="1A1830"/>
@@ -8432,6 +8479,7 @@
           </a:p>
           <a:p xmlns:a="http://schemas.openxmlformats.org/drawingml/2006/main">
             <a:pPr>
+              <a:buNone/>
               <a:defRPr sz="1875" b="0">
                 <a:solidFill>
                   <a:srgbClr val="1A1830"/>
@@ -8450,7 +8498,7 @@
                 <a:ea typeface="Arial"/>
                 <a:cs typeface="Arial"/>
               </a:rPr>
-              <a:t>Precomputed embeddings and stored metadata</a:t>
+              <a:t>Precomputed embeddings, AST and bounded Git history</a:t>
             </a:r>
           </a:p>
         </p:txBody>
@@ -8519,6 +8567,7 @@
           <a:lstStyle xmlns:a="http://schemas.openxmlformats.org/drawingml/2006/main"/>
           <a:p xmlns:a="http://schemas.openxmlformats.org/drawingml/2006/main">
             <a:pPr>
+              <a:buNone/>
               <a:defRPr sz="1875" b="1">
                 <a:solidFill>
                   <a:srgbClr val="714CB0"/>
@@ -8576,6 +8625,7 @@
           <a:lstStyle xmlns:a="http://schemas.openxmlformats.org/drawingml/2006/main"/>
           <a:p xmlns:a="http://schemas.openxmlformats.org/drawingml/2006/main">
             <a:pPr>
+              <a:buNone/>
               <a:defRPr sz="1875" b="0">
                 <a:solidFill>
                   <a:srgbClr val="1A1830"/>
@@ -8599,6 +8649,7 @@
           </a:p>
           <a:p xmlns:a="http://schemas.openxmlformats.org/drawingml/2006/main">
             <a:pPr>
+              <a:buNone/>
               <a:defRPr sz="1875" b="0">
                 <a:solidFill>
                   <a:srgbClr val="1A1830"/>
@@ -8715,6 +8766,7 @@
           <a:lstStyle xmlns:a="http://schemas.openxmlformats.org/drawingml/2006/main"/>
           <a:p xmlns:a="http://schemas.openxmlformats.org/drawingml/2006/main">
             <a:pPr>
+              <a:buNone/>
               <a:defRPr sz="3225" b="1">
                 <a:solidFill>
                   <a:srgbClr val="714CB0"/>
@@ -8772,6 +8824,7 @@
           <a:lstStyle xmlns:a="http://schemas.openxmlformats.org/drawingml/2006/main"/>
           <a:p xmlns:a="http://schemas.openxmlformats.org/drawingml/2006/main">
             <a:pPr>
+              <a:buNone/>
               <a:defRPr sz="1875" b="1">
                 <a:solidFill>
                   <a:srgbClr val="714CB0"/>
@@ -8829,6 +8882,7 @@
           <a:lstStyle xmlns:a="http://schemas.openxmlformats.org/drawingml/2006/main"/>
           <a:p xmlns:a="http://schemas.openxmlformats.org/drawingml/2006/main">
             <a:pPr>
+              <a:buNone/>
               <a:defRPr sz="1875" b="0">
                 <a:solidFill>
                   <a:srgbClr val="1A1830"/>
@@ -8916,6 +8970,7 @@
           <a:lstStyle xmlns:a="http://schemas.openxmlformats.org/drawingml/2006/main"/>
           <a:p xmlns:a="http://schemas.openxmlformats.org/drawingml/2006/main">
             <a:pPr>
+              <a:buNone/>
               <a:defRPr sz="1875" b="1">
                 <a:solidFill>
                   <a:srgbClr val="714CB0"/>
@@ -8973,6 +9028,7 @@
           <a:lstStyle xmlns:a="http://schemas.openxmlformats.org/drawingml/2006/main"/>
           <a:p xmlns:a="http://schemas.openxmlformats.org/drawingml/2006/main">
             <a:pPr>
+              <a:buNone/>
               <a:defRPr sz="1875" b="0">
                 <a:solidFill>
                   <a:srgbClr val="1A1830"/>
@@ -9060,6 +9116,7 @@
           <a:lstStyle xmlns:a="http://schemas.openxmlformats.org/drawingml/2006/main"/>
           <a:p xmlns:a="http://schemas.openxmlformats.org/drawingml/2006/main">
             <a:pPr>
+              <a:buNone/>
               <a:defRPr sz="1875" b="1">
                 <a:solidFill>
                   <a:srgbClr val="714CB0"/>
@@ -9117,6 +9174,7 @@
           <a:lstStyle xmlns:a="http://schemas.openxmlformats.org/drawingml/2006/main"/>
           <a:p xmlns:a="http://schemas.openxmlformats.org/drawingml/2006/main">
             <a:pPr>
+              <a:buNone/>
               <a:defRPr sz="1875" b="0">
                 <a:solidFill>
                   <a:srgbClr val="1A1830"/>
@@ -9135,7 +9193,7 @@
                 <a:ea typeface="Arial"/>
                 <a:cs typeface="Arial"/>
               </a:rPr>
-              <a:t>Compare stored implementations and inspect version lineage.</a:t>
+              <a:t>Inspect actual Git revisions by commit, path and snapshot.</a:t>
             </a:r>
           </a:p>
         </p:txBody>
@@ -9204,6 +9262,7 @@
           <a:lstStyle xmlns:a="http://schemas.openxmlformats.org/drawingml/2006/main"/>
           <a:p xmlns:a="http://schemas.openxmlformats.org/drawingml/2006/main">
             <a:pPr>
+              <a:buNone/>
               <a:defRPr sz="2175" b="1">
                 <a:solidFill>
                   <a:srgbClr val="714CB0"/>
@@ -9261,6 +9320,7 @@
           <a:lstStyle xmlns:a="http://schemas.openxmlformats.org/drawingml/2006/main"/>
           <a:p xmlns:a="http://schemas.openxmlformats.org/drawingml/2006/main">
             <a:pPr>
+              <a:buNone/>
               <a:defRPr sz="1575" b="0">
                 <a:solidFill>
                   <a:srgbClr val="655E79"/>
@@ -9347,6 +9407,7 @@
           <a:lstStyle xmlns:a="http://schemas.openxmlformats.org/drawingml/2006/main"/>
           <a:p xmlns:a="http://schemas.openxmlformats.org/drawingml/2006/main">
             <a:pPr>
+              <a:buNone/>
               <a:defRPr sz="2700" b="1">
                 <a:solidFill>
                   <a:srgbClr val="714CB0"/>
@@ -9404,6 +9465,7 @@
           <a:lstStyle xmlns:a="http://schemas.openxmlformats.org/drawingml/2006/main"/>
           <a:p xmlns:a="http://schemas.openxmlformats.org/drawingml/2006/main">
             <a:pPr>
+              <a:buNone/>
               <a:defRPr sz="2025" b="1">
                 <a:solidFill>
                   <a:srgbClr val="1A1830"/>
@@ -9461,6 +9523,7 @@
           <a:lstStyle xmlns:a="http://schemas.openxmlformats.org/drawingml/2006/main"/>
           <a:p xmlns:a="http://schemas.openxmlformats.org/drawingml/2006/main">
             <a:pPr>
+              <a:buNone/>
               <a:defRPr sz="1875" b="1">
                 <a:solidFill>
                   <a:srgbClr val="714CB0"/>
@@ -9518,6 +9581,7 @@
           <a:lstStyle xmlns:a="http://schemas.openxmlformats.org/drawingml/2006/main"/>
           <a:p xmlns:a="http://schemas.openxmlformats.org/drawingml/2006/main">
             <a:pPr>
+              <a:buNone/>
               <a:defRPr sz="3450" b="1">
                 <a:solidFill>
                   <a:srgbClr val="1A1830"/>
@@ -9575,6 +9639,7 @@
           <a:lstStyle xmlns:a="http://schemas.openxmlformats.org/drawingml/2006/main"/>
           <a:p xmlns:a="http://schemas.openxmlformats.org/drawingml/2006/main">
             <a:pPr>
+              <a:buNone/>
               <a:defRPr sz="1875" b="1">
                 <a:solidFill>
                   <a:srgbClr val="714CB0"/>
@@ -9632,6 +9697,7 @@
           <a:lstStyle xmlns:a="http://schemas.openxmlformats.org/drawingml/2006/main"/>
           <a:p xmlns:a="http://schemas.openxmlformats.org/drawingml/2006/main">
             <a:pPr>
+              <a:buNone/>
               <a:defRPr sz="3450" b="1">
                 <a:solidFill>
                   <a:srgbClr val="1A1830"/>
@@ -9689,6 +9755,7 @@
           <a:lstStyle xmlns:a="http://schemas.openxmlformats.org/drawingml/2006/main"/>
           <a:p xmlns:a="http://schemas.openxmlformats.org/drawingml/2006/main">
             <a:pPr>
+              <a:buNone/>
               <a:defRPr sz="1875" b="1">
                 <a:solidFill>
                   <a:srgbClr val="714CB0"/>
@@ -9746,6 +9813,7 @@
           <a:lstStyle xmlns:a="http://schemas.openxmlformats.org/drawingml/2006/main"/>
           <a:p xmlns:a="http://schemas.openxmlformats.org/drawingml/2006/main">
             <a:pPr>
+              <a:buNone/>
               <a:defRPr sz="3450" b="1">
                 <a:solidFill>
                   <a:srgbClr val="1A1830"/>
@@ -9803,6 +9871,7 @@
           <a:lstStyle xmlns:a="http://schemas.openxmlformats.org/drawingml/2006/main"/>
           <a:p xmlns:a="http://schemas.openxmlformats.org/drawingml/2006/main">
             <a:pPr>
+              <a:buNone/>
               <a:defRPr sz="1575" b="0">
                 <a:solidFill>
                   <a:srgbClr val="655E79"/>
@@ -9821,7 +9890,7 @@
                 <a:ea typeface="Arial"/>
                 <a:cs typeface="Arial"/>
               </a:rPr>
-              <a:t>Saved-ranking evaluation, top 100 per query. Live application index: 5,000 training documents.</a:t>
+              <a:t>Frozen rankings, top 100 per query. Configured live corpus: 8,765 documents.</a:t>
             </a:r>
           </a:p>
         </p:txBody>
@@ -9860,6 +9929,7 @@
           <a:lstStyle xmlns:a="http://schemas.openxmlformats.org/drawingml/2006/main"/>
           <a:p xmlns:a="http://schemas.openxmlformats.org/drawingml/2006/main">
             <a:pPr>
+              <a:buNone/>
               <a:defRPr sz="1875" b="1">
                 <a:solidFill>
                   <a:srgbClr val="714CB0"/>
@@ -9885,7 +9955,7 @@
       </p:sp>
       <p:graphicFrame>
         <p:nvGraphicFramePr>
-          <p:cNvPr id="24" name=""/>
+          <p:cNvPr id="26" name=""/>
           <p:cNvGraphicFramePr/>
           <p:nvPr/>
         </p:nvGraphicFramePr>
@@ -10186,6 +10256,7 @@
           <a:lstStyle xmlns:a="http://schemas.openxmlformats.org/drawingml/2006/main"/>
           <a:p xmlns:a="http://schemas.openxmlformats.org/drawingml/2006/main">
             <a:pPr>
+              <a:buNone/>
               <a:defRPr sz="1725" b="1">
                 <a:solidFill>
                   <a:srgbClr val="714CB0"/>
@@ -10243,6 +10314,7 @@
           <a:lstStyle xmlns:a="http://schemas.openxmlformats.org/drawingml/2006/main"/>
           <a:p xmlns:a="http://schemas.openxmlformats.org/drawingml/2006/main">
             <a:pPr>
+              <a:buNone/>
               <a:defRPr sz="1575" b="0">
                 <a:solidFill>
                   <a:srgbClr val="655E79"/>
@@ -10261,7 +10333,7 @@
                 <a:ea typeface="Arial"/>
                 <a:cs typeface="Arial"/>
               </a:rPr>
-              <a:t>Limits: rule-based routing, controlled version fixture and gated models. These scores measure dense retrieval only.</a:t>
+              <a:t>Limits: rule-based routing, Python scope and gated models. Metrics cover dense retrieval only.</a:t>
             </a:r>
           </a:p>
         </p:txBody>
@@ -10329,6 +10401,7 @@
           <a:lstStyle xmlns:a="http://schemas.openxmlformats.org/drawingml/2006/main"/>
           <a:p xmlns:a="http://schemas.openxmlformats.org/drawingml/2006/main">
             <a:pPr>
+              <a:buNone/>
               <a:defRPr sz="3225" b="1">
                 <a:solidFill>
                   <a:srgbClr val="714CB0"/>
@@ -10386,6 +10459,7 @@
           <a:lstStyle xmlns:a="http://schemas.openxmlformats.org/drawingml/2006/main"/>
           <a:p xmlns:a="http://schemas.openxmlformats.org/drawingml/2006/main">
             <a:pPr>
+              <a:buNone/>
               <a:defRPr sz="1875" b="1">
                 <a:solidFill>
                   <a:srgbClr val="714CB0"/>
@@ -10443,6 +10517,7 @@
           <a:lstStyle xmlns:a="http://schemas.openxmlformats.org/drawingml/2006/main"/>
           <a:p xmlns:a="http://schemas.openxmlformats.org/drawingml/2006/main">
             <a:pPr>
+              <a:buNone/>
               <a:defRPr sz="1875" b="1">
                 <a:solidFill>
                   <a:srgbClr val="714CB0"/>
@@ -10461,7 +10536,7 @@
                 <a:ea typeface="Arial"/>
                 <a:cs typeface="Arial"/>
               </a:rPr>
-              <a:t>Real repository history</a:t>
+              <a:t>Broader code support</a:t>
             </a:r>
           </a:p>
         </p:txBody>
@@ -10500,6 +10575,7 @@
           <a:lstStyle xmlns:a="http://schemas.openxmlformats.org/drawingml/2006/main"/>
           <a:p xmlns:a="http://schemas.openxmlformats.org/drawingml/2006/main">
             <a:pPr>
+              <a:buNone/>
               <a:defRPr sz="1875" b="0">
                 <a:solidFill>
                   <a:srgbClr val="1A1830"/>
@@ -10518,7 +10594,7 @@
                 <a:ea typeface="Arial"/>
                 <a:cs typeface="Arial"/>
               </a:rPr>
-              <a:t>Ingest actual Git history and extend beyond Python.</a:t>
+              <a:t>Extend beyond Python and evaluate larger repository histories.</a:t>
             </a:r>
           </a:p>
         </p:txBody>
@@ -10587,6 +10663,7 @@
           <a:lstStyle xmlns:a="http://schemas.openxmlformats.org/drawingml/2006/main"/>
           <a:p xmlns:a="http://schemas.openxmlformats.org/drawingml/2006/main">
             <a:pPr>
+              <a:buNone/>
               <a:defRPr sz="1875" b="1">
                 <a:solidFill>
                   <a:srgbClr val="714CB0"/>
@@ -10644,6 +10721,7 @@
           <a:lstStyle xmlns:a="http://schemas.openxmlformats.org/drawingml/2006/main"/>
           <a:p xmlns:a="http://schemas.openxmlformats.org/drawingml/2006/main">
             <a:pPr>
+              <a:buNone/>
               <a:defRPr sz="1875" b="0">
                 <a:solidFill>
                   <a:srgbClr val="1A1830"/>
@@ -10731,6 +10809,7 @@
           <a:lstStyle xmlns:a="http://schemas.openxmlformats.org/drawingml/2006/main"/>
           <a:p xmlns:a="http://schemas.openxmlformats.org/drawingml/2006/main">
             <a:pPr>
+              <a:buNone/>
               <a:defRPr sz="1875" b="1">
                 <a:solidFill>
                   <a:srgbClr val="714CB0"/>
@@ -10749,7 +10828,7 @@
                 <a:ea typeface="Arial"/>
                 <a:cs typeface="Arial"/>
               </a:rPr>
-              <a:t>Reproducibility evidence</a:t>
+              <a:t>Fresh Windows setup</a:t>
             </a:r>
           </a:p>
         </p:txBody>
@@ -10788,6 +10867,7 @@
           <a:lstStyle xmlns:a="http://schemas.openxmlformats.org/drawingml/2006/main"/>
           <a:p xmlns:a="http://schemas.openxmlformats.org/drawingml/2006/main">
             <a:pPr>
+              <a:buNone/>
               <a:defRPr sz="1875" b="0">
                 <a:solidFill>
                   <a:srgbClr val="1A1830"/>
@@ -10806,7 +10886,7 @@
                 <a:ea typeface="Arial"/>
                 <a:cs typeface="Arial"/>
               </a:rPr>
-              <a:t>Document Windows hardware, environment and model-download steps for repeatable setup.</a:t>
+              <a:t>Test model downloads and access setup from an empty Windows cache.</a:t>
             </a:r>
           </a:p>
         </p:txBody>

</xml_diff>